<commit_message>
Hackathon: forest photo, app video slot, team name Alanguka
Co-Authored-By: Claude Opus 5.5 <noreply@anthropic.com>
Claude-Session: https://claude.ai/code/session_01C3KfjncommuX479wUy9vJ7
</commit_message>
<xml_diff>
--- a/hakatons/buvgruzu-birza.pptx
+++ b/hakatons/buvgruzu-birza.pptx
@@ -652,7 +652,7 @@
           <a:p/>
           <a:p>
             <a:r>
-              <a:t>[DEMO 1:00]</a:t>
+              <a:t>[VIDEO 1:00 — Gustavs komentē]</a:t>
             </a:r>
           </a:p>
         </p:txBody>
@@ -4142,16 +4142,40 @@
           </a:p>
         </p:txBody>
       </p:sp>
-      <p:sp>
-        <p:nvSpPr>
-          <p:cNvPr id="10" name="Rounded Rectangle 9"/>
+      <p:pic>
+        <p:nvPicPr>
+          <p:cNvPr id="10" name="Picture 9" descr="foto-mezs.jpg"/>
+          <p:cNvPicPr>
+            <a:picLocks noChangeAspect="1"/>
+          </p:cNvPicPr>
+          <p:nvPr/>
+        </p:nvPicPr>
+        <p:blipFill>
+          <a:blip r:embed="rId2"/>
+          <a:stretch>
+            <a:fillRect/>
+          </a:stretch>
+        </p:blipFill>
+        <p:spPr>
+          <a:xfrm>
+            <a:off x="7086600" y="548640"/>
+            <a:ext cx="4526280" cy="4206240"/>
+          </a:xfrm>
+          <a:prstGeom prst="rect">
+            <a:avLst/>
+          </a:prstGeom>
+        </p:spPr>
+      </p:pic>
+      <p:sp>
+        <p:nvSpPr>
+          <p:cNvPr id="11" name="Rounded Rectangle 10"/>
           <p:cNvSpPr/>
           <p:nvPr/>
         </p:nvSpPr>
         <p:spPr>
           <a:xfrm>
-            <a:off x="7086600" y="548640"/>
-            <a:ext cx="4526280" cy="4206240"/>
+            <a:off x="7086600" y="4983480"/>
+            <a:ext cx="4526280" cy="1325880"/>
           </a:xfrm>
           <a:prstGeom prst="roundRect">
             <a:avLst>
@@ -4159,7 +4183,7 @@
             </a:avLst>
           </a:prstGeom>
           <a:solidFill>
-            <a:srgbClr val="CFE0C8"/>
+            <a:srgbClr val="FFFFFF"/>
           </a:solidFill>
           <a:ln>
             <a:noFill/>
@@ -4190,114 +4214,7 @@
       </p:sp>
       <p:sp>
         <p:nvSpPr>
-          <p:cNvPr id="11" name="TextBox 10"/>
-          <p:cNvSpPr txBox="1"/>
-          <p:nvPr/>
-        </p:nvSpPr>
-        <p:spPr>
-          <a:xfrm>
-            <a:off x="7086600" y="548640"/>
-            <a:ext cx="4526280" cy="4206240"/>
-          </a:xfrm>
-          <a:prstGeom prst="rect">
-            <a:avLst/>
-          </a:prstGeom>
-          <a:noFill/>
-        </p:spPr>
-        <p:txBody>
-          <a:bodyPr wrap="square" anchor="ctr" lIns="0" rIns="0" tIns="0" bIns="0">
-            <a:spAutoFit/>
-          </a:bodyPr>
-          <a:lstStyle/>
-          <a:p>
-            <a:pPr algn="ctr">
-              <a:lnSpc>
-                <a:spcPct val="110000"/>
-              </a:lnSpc>
-              <a:spcAft>
-                <a:spcPts val="600"/>
-              </a:spcAft>
-            </a:pPr>
-            <a:r>
-              <a:rPr sz="1600" b="0">
-                <a:solidFill>
-                  <a:srgbClr val="244A30"/>
-                </a:solidFill>
-                <a:latin typeface="Open Sans"/>
-              </a:rPr>
-              <a:t>FOTO</a:t>
-            </a:r>
-          </a:p>
-          <a:p>
-            <a:pPr algn="ctr">
-              <a:lnSpc>
-                <a:spcPct val="110000"/>
-              </a:lnSpc>
-              <a:spcAft>
-                <a:spcPts val="600"/>
-              </a:spcAft>
-            </a:pPr>
-            <a:r>
-              <a:rPr sz="1600" b="0">
-                <a:solidFill>
-                  <a:srgbClr val="244A30"/>
-                </a:solidFill>
-                <a:latin typeface="Open Sans"/>
-              </a:rPr>
-              <a:t>būvgruži mežā</a:t>
-            </a:r>
-          </a:p>
-        </p:txBody>
-      </p:sp>
-      <p:sp>
-        <p:nvSpPr>
-          <p:cNvPr id="12" name="Rounded Rectangle 11"/>
-          <p:cNvSpPr/>
-          <p:nvPr/>
-        </p:nvSpPr>
-        <p:spPr>
-          <a:xfrm>
-            <a:off x="7086600" y="4983480"/>
-            <a:ext cx="4526280" cy="1325880"/>
-          </a:xfrm>
-          <a:prstGeom prst="roundRect">
-            <a:avLst>
-              <a:gd name="adj" fmla="val 8000"/>
-            </a:avLst>
-          </a:prstGeom>
-          <a:solidFill>
-            <a:srgbClr val="FFFFFF"/>
-          </a:solidFill>
-          <a:ln>
-            <a:noFill/>
-          </a:ln>
-          <a:effectLst/>
-        </p:spPr>
-        <p:style>
-          <a:lnRef idx="1">
-            <a:schemeClr val="accent1"/>
-          </a:lnRef>
-          <a:fillRef idx="3">
-            <a:schemeClr val="accent1"/>
-          </a:fillRef>
-          <a:effectRef idx="2">
-            <a:schemeClr val="accent1"/>
-          </a:effectRef>
-          <a:fontRef idx="minor">
-            <a:schemeClr val="lt1"/>
-          </a:fontRef>
-        </p:style>
-        <p:txBody>
-          <a:bodyPr rtlCol="0" anchor="ctr"/>
-          <a:lstStyle/>
-          <a:p>
-            <a:pPr algn="ctr"/>
-          </a:p>
-        </p:txBody>
-      </p:sp>
-      <p:sp>
-        <p:nvSpPr>
-          <p:cNvPr id="13" name="TextBox 12"/>
+          <p:cNvPr id="12" name="TextBox 11"/>
           <p:cNvSpPr txBox="1"/>
           <p:nvPr/>
         </p:nvSpPr>
@@ -5942,8 +5859,8 @@
         </p:nvSpPr>
         <p:spPr>
           <a:xfrm>
-            <a:off x="6858000" y="914400"/>
-            <a:ext cx="1508760" cy="5394960"/>
+            <a:off x="7589520" y="548640"/>
+            <a:ext cx="3291840" cy="5760720"/>
           </a:xfrm>
           <a:prstGeom prst="roundRect">
             <a:avLst>
@@ -5951,7 +5868,7 @@
             </a:avLst>
           </a:prstGeom>
           <a:solidFill>
-            <a:srgbClr val="CFE0C8"/>
+            <a:srgbClr val="244A30"/>
           </a:solidFill>
           <a:ln>
             <a:noFill/>
@@ -5982,56 +5899,14 @@
       </p:sp>
       <p:sp>
         <p:nvSpPr>
-          <p:cNvPr id="21" name="TextBox 20"/>
-          <p:cNvSpPr txBox="1"/>
-          <p:nvPr/>
-        </p:nvSpPr>
-        <p:spPr>
-          <a:xfrm>
-            <a:off x="6858000" y="914400"/>
-            <a:ext cx="1508760" cy="5394960"/>
-          </a:xfrm>
-          <a:prstGeom prst="rect">
-            <a:avLst/>
-          </a:prstGeom>
-          <a:noFill/>
-        </p:spPr>
-        <p:txBody>
-          <a:bodyPr wrap="square" anchor="ctr" lIns="0" rIns="0" tIns="0" bIns="0">
-            <a:spAutoFit/>
-          </a:bodyPr>
-          <a:lstStyle/>
-          <a:p>
-            <a:pPr algn="ctr">
-              <a:lnSpc>
-                <a:spcPct val="110000"/>
-              </a:lnSpc>
-              <a:spcAft>
-                <a:spcPts val="600"/>
-              </a:spcAft>
-            </a:pPr>
-            <a:r>
-              <a:rPr sz="1600" b="0">
-                <a:solidFill>
-                  <a:srgbClr val="244A30"/>
-                </a:solidFill>
-                <a:latin typeface="Open Sans"/>
-              </a:rPr>
-              <a:t>Ekrāns 1</a:t>
-            </a:r>
-          </a:p>
-        </p:txBody>
-      </p:sp>
-      <p:sp>
-        <p:nvSpPr>
-          <p:cNvPr id="22" name="Rounded Rectangle 21"/>
+          <p:cNvPr id="21" name="Rounded Rectangle 20"/>
           <p:cNvSpPr/>
           <p:nvPr/>
         </p:nvSpPr>
         <p:spPr>
           <a:xfrm>
-            <a:off x="8549640" y="914400"/>
-            <a:ext cx="1508760" cy="5394960"/>
+            <a:off x="7726679" y="685800"/>
+            <a:ext cx="3017520" cy="5486400"/>
           </a:xfrm>
           <a:prstGeom prst="roundRect">
             <a:avLst>
@@ -6070,14 +5945,14 @@
       </p:sp>
       <p:sp>
         <p:nvSpPr>
-          <p:cNvPr id="23" name="TextBox 22"/>
+          <p:cNvPr id="22" name="TextBox 21"/>
           <p:cNvSpPr txBox="1"/>
           <p:nvPr/>
         </p:nvSpPr>
         <p:spPr>
           <a:xfrm>
-            <a:off x="8549640" y="914400"/>
-            <a:ext cx="1508760" cy="5394960"/>
+            <a:off x="7726679" y="685800"/>
+            <a:ext cx="3017520" cy="5486400"/>
           </a:xfrm>
           <a:prstGeom prst="rect">
             <a:avLst/>
@@ -6105,78 +5980,9 @@
                 </a:solidFill>
                 <a:latin typeface="Open Sans"/>
               </a:rPr>
-              <a:t>Ekrāns 2</a:t>
-            </a:r>
-          </a:p>
-        </p:txBody>
-      </p:sp>
-      <p:sp>
-        <p:nvSpPr>
-          <p:cNvPr id="24" name="Rounded Rectangle 23"/>
-          <p:cNvSpPr/>
-          <p:nvPr/>
-        </p:nvSpPr>
-        <p:spPr>
-          <a:xfrm>
-            <a:off x="10241280" y="914400"/>
-            <a:ext cx="1508760" cy="5394960"/>
-          </a:xfrm>
-          <a:prstGeom prst="roundRect">
-            <a:avLst>
-              <a:gd name="adj" fmla="val 8000"/>
-            </a:avLst>
-          </a:prstGeom>
-          <a:solidFill>
-            <a:srgbClr val="CFE0C8"/>
-          </a:solidFill>
-          <a:ln>
-            <a:noFill/>
-          </a:ln>
-          <a:effectLst/>
-        </p:spPr>
-        <p:style>
-          <a:lnRef idx="1">
-            <a:schemeClr val="accent1"/>
-          </a:lnRef>
-          <a:fillRef idx="3">
-            <a:schemeClr val="accent1"/>
-          </a:fillRef>
-          <a:effectRef idx="2">
-            <a:schemeClr val="accent1"/>
-          </a:effectRef>
-          <a:fontRef idx="minor">
-            <a:schemeClr val="lt1"/>
-          </a:fontRef>
-        </p:style>
-        <p:txBody>
-          <a:bodyPr rtlCol="0" anchor="ctr"/>
-          <a:lstStyle/>
-          <a:p>
-            <a:pPr algn="ctr"/>
-          </a:p>
-        </p:txBody>
-      </p:sp>
-      <p:sp>
-        <p:nvSpPr>
-          <p:cNvPr id="25" name="TextBox 24"/>
-          <p:cNvSpPr txBox="1"/>
-          <p:nvPr/>
-        </p:nvSpPr>
-        <p:spPr>
-          <a:xfrm>
-            <a:off x="10241280" y="914400"/>
-            <a:ext cx="1508760" cy="5394960"/>
-          </a:xfrm>
-          <a:prstGeom prst="rect">
-            <a:avLst/>
-          </a:prstGeom>
-          <a:noFill/>
-        </p:spPr>
-        <p:txBody>
-          <a:bodyPr wrap="square" anchor="ctr" lIns="0" rIns="0" tIns="0" bIns="0">
-            <a:spAutoFit/>
-          </a:bodyPr>
-          <a:lstStyle/>
+              <a:t>VIDEO</a:t>
+            </a:r>
+          </a:p>
           <a:p>
             <a:pPr algn="ctr">
               <a:lnSpc>
@@ -6193,7 +5999,26 @@
                 </a:solidFill>
                 <a:latin typeface="Open Sans"/>
               </a:rPr>
-              <a:t>Ekrāns 3</a:t>
+              <a:t>no lietotnes</a:t>
+            </a:r>
+          </a:p>
+          <a:p>
+            <a:pPr algn="ctr">
+              <a:lnSpc>
+                <a:spcPct val="110000"/>
+              </a:lnSpc>
+              <a:spcAft>
+                <a:spcPts val="600"/>
+              </a:spcAft>
+            </a:pPr>
+            <a:r>
+              <a:rPr sz="1600" b="0">
+                <a:solidFill>
+                  <a:srgbClr val="244A30"/>
+                </a:solidFill>
+                <a:latin typeface="Open Sans"/>
+              </a:rPr>
+              <a:t>(ievelc Canva)</a:t>
             </a:r>
           </a:p>
         </p:txBody>
@@ -7292,7 +7117,7 @@
                 </a:solidFill>
                 <a:latin typeface="Open Sans"/>
               </a:rPr>
-              <a:t>Komandas nosaukums</a:t>
+              <a:t>Komanda Alanguka</a:t>
             </a:r>
           </a:p>
         </p:txBody>

</xml_diff>

<commit_message>
Hackathon: discreet photo credit on slide 1
Co-Authored-By: Claude Opus 5.5 <noreply@anthropic.com>
Claude-Session: https://claude.ai/code/session_01C3KfjncommuX479wUy9vJ7
</commit_message>
<xml_diff>
--- a/hakatons/buvgruzu-birza.pptx
+++ b/hakatons/buvgruzu-birza.pptx
@@ -507,6 +507,12 @@
           <a:p>
             <a:r>
               <a:t>0:35 — Iedomājieties: jūs remontējat dzīvokli, un jums ir 30 maisi ar betonu un flīzēm. Nav piekabes, nezināt, kur tos nodot. Internetā — "izvedam būvgružus lēti". Viens zvans, un problēma atrisināta. Bet daļa šo gružu nonāk mežā. Būvniecība patērē pusi no visiem zemē iegūtajiem resursiem, un būvgruži ir vairāk nekā trešdaļa no visiem ES atkritumiem. Problēma nav cilvēkos. Problēma ir tā, ka nelegālais ceļš ir lētāks un vienkāršāks.</a:t>
+            </a:r>
+          </a:p>
+          <a:p/>
+          <a:p>
+            <a:r>
+              <a:t>Foto avots: https://iauto.lv/zinas/latvija/49412-izg-atkritumus-me-k-tdus-cilvkus-nosaukt-foto</a:t>
             </a:r>
           </a:p>
         </p:txBody>
@@ -4168,7 +4174,49 @@
       </p:pic>
       <p:sp>
         <p:nvSpPr>
-          <p:cNvPr id="11" name="Rounded Rectangle 10"/>
+          <p:cNvPr id="11" name="TextBox 10"/>
+          <p:cNvSpPr txBox="1"/>
+          <p:nvPr/>
+        </p:nvSpPr>
+        <p:spPr>
+          <a:xfrm>
+            <a:off x="7086600" y="4773168"/>
+            <a:ext cx="4526280" cy="182880"/>
+          </a:xfrm>
+          <a:prstGeom prst="rect">
+            <a:avLst/>
+          </a:prstGeom>
+          <a:noFill/>
+        </p:spPr>
+        <p:txBody>
+          <a:bodyPr wrap="square" anchor="t" lIns="0" rIns="0" tIns="0" bIns="0">
+            <a:spAutoFit/>
+          </a:bodyPr>
+          <a:lstStyle/>
+          <a:p>
+            <a:pPr algn="r">
+              <a:lnSpc>
+                <a:spcPct val="110000"/>
+              </a:lnSpc>
+              <a:spcAft>
+                <a:spcPts val="600"/>
+              </a:spcAft>
+            </a:pPr>
+            <a:r>
+              <a:rPr sz="800" b="0">
+                <a:solidFill>
+                  <a:srgbClr val="5E8C5A"/>
+                </a:solidFill>
+                <a:latin typeface="Open Sans"/>
+              </a:rPr>
+              <a:t>Foto: iauto.lv</a:t>
+            </a:r>
+          </a:p>
+        </p:txBody>
+      </p:sp>
+      <p:sp>
+        <p:nvSpPr>
+          <p:cNvPr id="12" name="Rounded Rectangle 11"/>
           <p:cNvSpPr/>
           <p:nvPr/>
         </p:nvSpPr>
@@ -4214,7 +4262,7 @@
       </p:sp>
       <p:sp>
         <p:nvSpPr>
-          <p:cNvPr id="12" name="TextBox 11"/>
+          <p:cNvPr id="13" name="TextBox 12"/>
           <p:cNvSpPr txBox="1"/>
           <p:nvPr/>
         </p:nvSpPr>

</xml_diff>

<commit_message>
Hackathon: logo, benefits for people/companies/environment, 'why our solution' slide
Co-Authored-By: Claude Opus 5.5 <noreply@anthropic.com>
Claude-Session: https://claude.ai/code/session_01C3KfjncommuX479wUy9vJ7
</commit_message>
<xml_diff>
--- a/hakatons/buvgruzu-birza.pptx
+++ b/hakatons/buvgruzu-birza.pptx
@@ -582,7 +582,7 @@
           <a:lstStyle/>
           <a:p>
             <a:r>
-              <a:t>0:30 — Būvgružu birža ir aprites ekonomikas platforma: tā savieno cilvēkus, kuriem ir būvgruži, ar uzņēmumiem, kas tos pārstrādā. Princips kā pudeļu depozītam — nodod un saņem. Cilvēks sašķiro gružus un nodod tos bez maksas — tas jau ir ietaupījums. Par koksni viņš saņem naudu, par betonu un ķieģeļiem — punktus vai pārstrādātas šķembas. Uzņēmums saņem tīru materiālu, ko var pārstrādāt un izmantot vēlreiz. Pašvaldībai — mazāk izgāztuvju mežos. Ieguvēji ir visi.</a:t>
+              <a:t>0:30 — Mūsu risinājums ir Būvgružu birža — aprites ekonomikas platforma, kas savieno cilvēkus, kuriem ir būvgruži, ar uzņēmumiem, kas tos pārstrādā. Princips kā pudeļu depozītam — nodod un saņem. Cilvēkiem: bezmaksas nodošana un atlīdzība — par koksni nauda, par betonu punkti. Uzņēmumiem: tīrs materiāls bez šķirošanas izmaksām. Videi: mazāk izgāztuvju mežos un mazāk jaunu izejvielu ieguves.</a:t>
             </a:r>
           </a:p>
         </p:txBody>
@@ -728,7 +728,7 @@
           <a:lstStyle/>
           <a:p>
             <a:r>
-              <a:t>0:30 — Mēs to aprēķinājām. Pārstrādātāju peļņa ir tikai ap diviem procentiem, tāpēc godīgi: par betonu lielu naudu neviens nemaksās. Reālu naudu maksā par koksni — līdz 30 eiro tonnā. Galvenais ieguvums cilvēkam ir bezmaksas pieņemšana, uzņēmumam — tīrs materiāls bez šķirošanas izmaksām. Lietotnes uzturēšanu sedz pašvaldība, kas ietaupa uz izgāztuvju sakopšanu. Sākt gribam ar pilotprojektu vienā pašvaldībā.</a:t>
+              <a:t>0:30 — Kāpēc tieši mūsu risinājums? Pirmkārt, tas ir izdevīgi, nevis tikai pareizi — mēs nepaļaujamies uz cilvēku apziņu. Otrkārt, mēs to aprēķinājām: pārstrādātāju peļņa ir ap diviem procentiem, tāpēc par koksni maksājam naudu, par betonu — punktus. Treškārt, lietotne rāda tikai tos punktus, kur braukt atmaksājas. Un mums nevajag jaunu infrastruktūru — sākam ar pilotprojektu vienā pašvaldībā.</a:t>
             </a:r>
           </a:p>
         </p:txBody>
@@ -4398,7 +4398,7 @@
         <p:spPr>
           <a:xfrm>
             <a:off x="640080" y="914400"/>
-            <a:ext cx="10972800" cy="822960"/>
+            <a:ext cx="9144000" cy="822960"/>
           </a:xfrm>
           <a:prstGeom prst="rect">
             <a:avLst/>
@@ -4440,7 +4440,7 @@
         <p:spPr>
           <a:xfrm>
             <a:off x="640080" y="1691640"/>
-            <a:ext cx="10972800" cy="548640"/>
+            <a:ext cx="9326880" cy="548640"/>
           </a:xfrm>
           <a:prstGeom prst="rect">
             <a:avLst/>
@@ -4473,9 +4473,33 @@
           </a:p>
         </p:txBody>
       </p:sp>
-      <p:sp>
-        <p:nvSpPr>
-          <p:cNvPr id="5" name="Rounded Rectangle 4"/>
+      <p:pic>
+        <p:nvPicPr>
+          <p:cNvPr id="5" name="Picture 4" descr="logo.png"/>
+          <p:cNvPicPr>
+            <a:picLocks noChangeAspect="1"/>
+          </p:cNvPicPr>
+          <p:nvPr/>
+        </p:nvPicPr>
+        <p:blipFill>
+          <a:blip r:embed="rId2"/>
+          <a:stretch>
+            <a:fillRect/>
+          </a:stretch>
+        </p:blipFill>
+        <p:spPr>
+          <a:xfrm>
+            <a:off x="10241280" y="502920"/>
+            <a:ext cx="1325880" cy="1290912"/>
+          </a:xfrm>
+          <a:prstGeom prst="rect">
+            <a:avLst/>
+          </a:prstGeom>
+        </p:spPr>
+      </p:pic>
+      <p:sp>
+        <p:nvSpPr>
+          <p:cNvPr id="6" name="Rounded Rectangle 5"/>
           <p:cNvSpPr/>
           <p:nvPr/>
         </p:nvSpPr>
@@ -4521,7 +4545,7 @@
       </p:sp>
       <p:sp>
         <p:nvSpPr>
-          <p:cNvPr id="6" name="Rectangle 5"/>
+          <p:cNvPr id="7" name="Rectangle 6"/>
           <p:cNvSpPr/>
           <p:nvPr/>
         </p:nvSpPr>
@@ -4565,7 +4589,7 @@
       </p:sp>
       <p:sp>
         <p:nvSpPr>
-          <p:cNvPr id="7" name="TextBox 6"/>
+          <p:cNvPr id="8" name="TextBox 7"/>
           <p:cNvSpPr txBox="1"/>
           <p:nvPr/>
         </p:nvSpPr>
@@ -4600,14 +4624,14 @@
                 </a:solidFill>
                 <a:latin typeface="Montserrat"/>
               </a:rPr>
-              <a:t>Iedzīvotājs</a:t>
-            </a:r>
-          </a:p>
-        </p:txBody>
-      </p:sp>
-      <p:sp>
-        <p:nvSpPr>
-          <p:cNvPr id="8" name="TextBox 7"/>
+              <a:t>Cilvēkiem</a:t>
+            </a:r>
+          </a:p>
+        </p:txBody>
+      </p:sp>
+      <p:sp>
+        <p:nvSpPr>
+          <p:cNvPr id="9" name="TextBox 8"/>
           <p:cNvSpPr txBox="1"/>
           <p:nvPr/>
         </p:nvSpPr>
@@ -4687,7 +4711,7 @@
       </p:sp>
       <p:sp>
         <p:nvSpPr>
-          <p:cNvPr id="9" name="Rounded Rectangle 8"/>
+          <p:cNvPr id="10" name="Rounded Rectangle 9"/>
           <p:cNvSpPr/>
           <p:nvPr/>
         </p:nvSpPr>
@@ -4733,7 +4757,7 @@
       </p:sp>
       <p:sp>
         <p:nvSpPr>
-          <p:cNvPr id="10" name="Rectangle 9"/>
+          <p:cNvPr id="11" name="Rectangle 10"/>
           <p:cNvSpPr/>
           <p:nvPr/>
         </p:nvSpPr>
@@ -4777,7 +4801,7 @@
       </p:sp>
       <p:sp>
         <p:nvSpPr>
-          <p:cNvPr id="11" name="TextBox 10"/>
+          <p:cNvPr id="12" name="TextBox 11"/>
           <p:cNvSpPr txBox="1"/>
           <p:nvPr/>
         </p:nvSpPr>
@@ -4812,14 +4836,14 @@
                 </a:solidFill>
                 <a:latin typeface="Montserrat"/>
               </a:rPr>
-              <a:t>Uzņēmums</a:t>
-            </a:r>
-          </a:p>
-        </p:txBody>
-      </p:sp>
-      <p:sp>
-        <p:nvSpPr>
-          <p:cNvPr id="12" name="TextBox 11"/>
+              <a:t>Uzņēmumiem</a:t>
+            </a:r>
+          </a:p>
+        </p:txBody>
+      </p:sp>
+      <p:sp>
+        <p:nvSpPr>
+          <p:cNvPr id="13" name="TextBox 12"/>
           <p:cNvSpPr txBox="1"/>
           <p:nvPr/>
         </p:nvSpPr>
@@ -4854,7 +4878,7 @@
                 </a:solidFill>
                 <a:latin typeface="Open Sans"/>
               </a:rPr>
-              <a:t>— Saņem tīru, sašķirotu materiālu</a:t>
+              <a:t>— Tīrs, sašķirots materiāls</a:t>
             </a:r>
           </a:p>
           <a:p>
@@ -4892,14 +4916,14 @@
                 </a:solidFill>
                 <a:latin typeface="Open Sans"/>
               </a:rPr>
-              <a:t>— Pārstrādā un izmanto vēlreiz</a:t>
-            </a:r>
-          </a:p>
-        </p:txBody>
-      </p:sp>
-      <p:sp>
-        <p:nvSpPr>
-          <p:cNvPr id="13" name="Rounded Rectangle 12"/>
+              <a:t>— Lētāka izejviela nekā jauna</a:t>
+            </a:r>
+          </a:p>
+        </p:txBody>
+      </p:sp>
+      <p:sp>
+        <p:nvSpPr>
+          <p:cNvPr id="14" name="Rounded Rectangle 13"/>
           <p:cNvSpPr/>
           <p:nvPr/>
         </p:nvSpPr>
@@ -4945,7 +4969,7 @@
       </p:sp>
       <p:sp>
         <p:nvSpPr>
-          <p:cNvPr id="14" name="Rectangle 13"/>
+          <p:cNvPr id="15" name="Rectangle 14"/>
           <p:cNvSpPr/>
           <p:nvPr/>
         </p:nvSpPr>
@@ -4989,7 +5013,7 @@
       </p:sp>
       <p:sp>
         <p:nvSpPr>
-          <p:cNvPr id="15" name="TextBox 14"/>
+          <p:cNvPr id="16" name="TextBox 15"/>
           <p:cNvSpPr txBox="1"/>
           <p:nvPr/>
         </p:nvSpPr>
@@ -5024,14 +5048,14 @@
                 </a:solidFill>
                 <a:latin typeface="Montserrat"/>
               </a:rPr>
-              <a:t>Pašvaldība</a:t>
-            </a:r>
-          </a:p>
-        </p:txBody>
-      </p:sp>
-      <p:sp>
-        <p:nvSpPr>
-          <p:cNvPr id="16" name="TextBox 15"/>
+              <a:t>Videi</a:t>
+            </a:r>
+          </a:p>
+        </p:txBody>
+      </p:sp>
+      <p:sp>
+        <p:nvSpPr>
+          <p:cNvPr id="17" name="TextBox 16"/>
           <p:cNvSpPr txBox="1"/>
           <p:nvPr/>
         </p:nvSpPr>
@@ -5085,7 +5109,7 @@
                 </a:solidFill>
                 <a:latin typeface="Open Sans"/>
               </a:rPr>
-              <a:t>— Mazāk izmaksu par sakopšanu</a:t>
+              <a:t>— Mazāk jaunu izejvielu ieguves</a:t>
             </a:r>
           </a:p>
           <a:p>
@@ -5104,7 +5128,7 @@
                 </a:solidFill>
                 <a:latin typeface="Open Sans"/>
               </a:rPr>
-              <a:t>— Dati par to, kur rodas būvgruži</a:t>
+              <a:t>— Pašvaldība ietaupa uz sakopšanu</a:t>
             </a:r>
           </a:p>
         </p:txBody>
@@ -6134,7 +6158,7 @@
                 </a:solidFill>
                 <a:latin typeface="Montserrat"/>
               </a:rPr>
-              <a:t>EKONOMIKA</a:t>
+              <a:t>KĀPĒC TIEŠI MŪSU RISINĀJUMS</a:t>
             </a:r>
           </a:p>
         </p:txBody>
@@ -6176,7 +6200,7 @@
                 </a:solidFill>
                 <a:latin typeface="Montserrat"/>
               </a:rPr>
-              <a:t>Cik var maksāt — godīgi</a:t>
+              <a:t>Izdevīgi, nevis tikai pareizi</a:t>
             </a:r>
           </a:p>
         </p:txBody>
@@ -6189,8 +6213,8 @@
         </p:nvSpPr>
         <p:spPr>
           <a:xfrm>
-            <a:off x="640080" y="2011680"/>
-            <a:ext cx="3291840" cy="4206240"/>
+            <a:off x="640080" y="1965960"/>
+            <a:ext cx="5349240" cy="1280160"/>
           </a:xfrm>
           <a:prstGeom prst="roundRect">
             <a:avLst>
@@ -6198,7 +6222,7 @@
             </a:avLst>
           </a:prstGeom>
           <a:solidFill>
-            <a:srgbClr val="244A30"/>
+            <a:srgbClr val="FFFFFF"/>
           </a:solidFill>
           <a:ln>
             <a:noFill/>
@@ -6229,148 +6253,20 @@
       </p:sp>
       <p:sp>
         <p:nvSpPr>
-          <p:cNvPr id="5" name="TextBox 4"/>
-          <p:cNvSpPr txBox="1"/>
-          <p:nvPr/>
-        </p:nvSpPr>
-        <p:spPr>
-          <a:xfrm>
-            <a:off x="914400" y="2377440"/>
-            <a:ext cx="2743200" cy="1097280"/>
-          </a:xfrm>
-          <a:prstGeom prst="rect">
-            <a:avLst/>
-          </a:prstGeom>
-          <a:noFill/>
-        </p:spPr>
-        <p:txBody>
-          <a:bodyPr wrap="square" anchor="t" lIns="0" rIns="0" tIns="0" bIns="0">
-            <a:spAutoFit/>
-          </a:bodyPr>
-          <a:lstStyle/>
-          <a:p>
-            <a:pPr algn="l">
-              <a:lnSpc>
-                <a:spcPct val="110000"/>
-              </a:lnSpc>
-              <a:spcAft>
-                <a:spcPts val="600"/>
-              </a:spcAft>
-            </a:pPr>
-            <a:r>
-              <a:rPr sz="6400" b="1">
-                <a:solidFill>
-                  <a:srgbClr val="FFFFFF"/>
-                </a:solidFill>
-                <a:latin typeface="Montserrat"/>
-              </a:rPr>
-              <a:t>~2 %</a:t>
-            </a:r>
-          </a:p>
-        </p:txBody>
-      </p:sp>
-      <p:sp>
-        <p:nvSpPr>
-          <p:cNvPr id="6" name="TextBox 5"/>
-          <p:cNvSpPr txBox="1"/>
-          <p:nvPr/>
-        </p:nvSpPr>
-        <p:spPr>
-          <a:xfrm>
-            <a:off x="914400" y="3566160"/>
-            <a:ext cx="2743200" cy="1463040"/>
-          </a:xfrm>
-          <a:prstGeom prst="rect">
-            <a:avLst/>
-          </a:prstGeom>
-          <a:noFill/>
-        </p:spPr>
-        <p:txBody>
-          <a:bodyPr wrap="square" anchor="t" lIns="0" rIns="0" tIns="0" bIns="0">
-            <a:spAutoFit/>
-          </a:bodyPr>
-          <a:lstStyle/>
-          <a:p>
-            <a:pPr algn="l">
-              <a:lnSpc>
-                <a:spcPct val="110000"/>
-              </a:lnSpc>
-              <a:spcAft>
-                <a:spcPts val="600"/>
-              </a:spcAft>
-            </a:pPr>
-            <a:r>
-              <a:rPr sz="1600" b="0">
-                <a:solidFill>
-                  <a:srgbClr val="CFE0C8"/>
-                </a:solidFill>
-                <a:latin typeface="Open Sans"/>
-              </a:rPr>
-              <a:t>pārstrādātāju peļņa — tāpēc par betonu lielu naudu nesolām</a:t>
-            </a:r>
-          </a:p>
-        </p:txBody>
-      </p:sp>
-      <p:sp>
-        <p:nvSpPr>
-          <p:cNvPr id="7" name="TextBox 6"/>
-          <p:cNvSpPr txBox="1"/>
-          <p:nvPr/>
-        </p:nvSpPr>
-        <p:spPr>
-          <a:xfrm>
-            <a:off x="914400" y="5257800"/>
-            <a:ext cx="2743200" cy="822960"/>
-          </a:xfrm>
-          <a:prstGeom prst="rect">
-            <a:avLst/>
-          </a:prstGeom>
-          <a:noFill/>
-        </p:spPr>
-        <p:txBody>
-          <a:bodyPr wrap="square" anchor="t" lIns="0" rIns="0" tIns="0" bIns="0">
-            <a:spAutoFit/>
-          </a:bodyPr>
-          <a:lstStyle/>
-          <a:p>
-            <a:pPr algn="l">
-              <a:lnSpc>
-                <a:spcPct val="110000"/>
-              </a:lnSpc>
-              <a:spcAft>
-                <a:spcPts val="600"/>
-              </a:spcAft>
-            </a:pPr>
-            <a:r>
-              <a:rPr sz="1100" b="0">
-                <a:solidFill>
-                  <a:srgbClr val="CFE0C8"/>
-                </a:solidFill>
-                <a:latin typeface="Open Sans"/>
-              </a:rPr>
-              <a:t>SIA Būvgružu Pārstrāde 2024: 869 tūkst. € apgrozījums, 13,7 tūkst. € peļņa</a:t>
-            </a:r>
-          </a:p>
-        </p:txBody>
-      </p:sp>
-      <p:sp>
-        <p:nvSpPr>
-          <p:cNvPr id="8" name="Rounded Rectangle 7"/>
+          <p:cNvPr id="5" name="Oval 4"/>
           <p:cNvSpPr/>
           <p:nvPr/>
         </p:nvSpPr>
         <p:spPr>
           <a:xfrm>
-            <a:off x="4206240" y="2011680"/>
-            <a:ext cx="7360920" cy="731520"/>
-          </a:xfrm>
-          <a:prstGeom prst="roundRect">
-            <a:avLst>
-              <a:gd name="adj" fmla="val 8000"/>
-            </a:avLst>
+            <a:off x="914400" y="2240279"/>
+            <a:ext cx="731520" cy="731520"/>
+          </a:xfrm>
+          <a:prstGeom prst="ellipse">
+            <a:avLst/>
           </a:prstGeom>
           <a:solidFill>
-            <a:srgbClr val="FFFFFF"/>
+            <a:srgbClr val="244A30"/>
           </a:solidFill>
           <a:ln>
             <a:noFill/>
@@ -6401,14 +6297,14 @@
       </p:sp>
       <p:sp>
         <p:nvSpPr>
-          <p:cNvPr id="9" name="TextBox 8"/>
+          <p:cNvPr id="6" name="TextBox 5"/>
           <p:cNvSpPr txBox="1"/>
           <p:nvPr/>
         </p:nvSpPr>
         <p:spPr>
           <a:xfrm>
-            <a:off x="4480560" y="2011680"/>
-            <a:ext cx="2377440" cy="731520"/>
+            <a:off x="914400" y="2240279"/>
+            <a:ext cx="731520" cy="731520"/>
           </a:xfrm>
           <a:prstGeom prst="rect">
             <a:avLst/>
@@ -6417,6 +6313,48 @@
         </p:spPr>
         <p:txBody>
           <a:bodyPr wrap="square" anchor="ctr" lIns="0" rIns="0" tIns="0" bIns="0">
+            <a:spAutoFit/>
+          </a:bodyPr>
+          <a:lstStyle/>
+          <a:p>
+            <a:pPr algn="ctr">
+              <a:lnSpc>
+                <a:spcPct val="110000"/>
+              </a:lnSpc>
+              <a:spcAft>
+                <a:spcPts val="600"/>
+              </a:spcAft>
+            </a:pPr>
+            <a:r>
+              <a:rPr sz="2200" b="1">
+                <a:solidFill>
+                  <a:srgbClr val="FFFFFF"/>
+                </a:solidFill>
+                <a:latin typeface="Montserrat"/>
+              </a:rPr>
+              <a:t>1</a:t>
+            </a:r>
+          </a:p>
+        </p:txBody>
+      </p:sp>
+      <p:sp>
+        <p:nvSpPr>
+          <p:cNvPr id="7" name="TextBox 6"/>
+          <p:cNvSpPr txBox="1"/>
+          <p:nvPr/>
+        </p:nvSpPr>
+        <p:spPr>
+          <a:xfrm>
+            <a:off x="1874519" y="2167128"/>
+            <a:ext cx="3931920" cy="457200"/>
+          </a:xfrm>
+          <a:prstGeom prst="rect">
+            <a:avLst/>
+          </a:prstGeom>
+          <a:noFill/>
+        </p:spPr>
+        <p:txBody>
+          <a:bodyPr wrap="square" anchor="t" lIns="0" rIns="0" tIns="0" bIns="0">
             <a:spAutoFit/>
           </a:bodyPr>
           <a:lstStyle/>
@@ -6436,21 +6374,21 @@
                 </a:solidFill>
                 <a:latin typeface="Montserrat"/>
               </a:rPr>
-              <a:t>Koksne</a:t>
-            </a:r>
-          </a:p>
-        </p:txBody>
-      </p:sp>
-      <p:sp>
-        <p:nvSpPr>
-          <p:cNvPr id="10" name="TextBox 9"/>
+              <a:t>Izdevīgi</a:t>
+            </a:r>
+          </a:p>
+        </p:txBody>
+      </p:sp>
+      <p:sp>
+        <p:nvSpPr>
+          <p:cNvPr id="8" name="TextBox 7"/>
           <p:cNvSpPr txBox="1"/>
           <p:nvPr/>
         </p:nvSpPr>
         <p:spPr>
           <a:xfrm>
-            <a:off x="6766560" y="2011680"/>
-            <a:ext cx="2194560" cy="731520"/>
+            <a:off x="1874519" y="2606039"/>
+            <a:ext cx="3931920" cy="548640"/>
           </a:xfrm>
           <a:prstGeom prst="rect">
             <a:avLst/>
@@ -6458,7 +6396,7 @@
           <a:noFill/>
         </p:spPr>
         <p:txBody>
-          <a:bodyPr wrap="square" anchor="ctr" lIns="0" rIns="0" tIns="0" bIns="0">
+          <a:bodyPr wrap="square" anchor="t" lIns="0" rIns="0" tIns="0" bIns="0">
             <a:spAutoFit/>
           </a:bodyPr>
           <a:lstStyle/>
@@ -6472,69 +6410,27 @@
               </a:spcAft>
             </a:pPr>
             <a:r>
-              <a:rPr sz="2200" b="1">
-                <a:solidFill>
-                  <a:srgbClr val="244A30"/>
-                </a:solidFill>
-                <a:latin typeface="Montserrat"/>
-              </a:rPr>
-              <a:t>15–30 €/t</a:t>
-            </a:r>
-          </a:p>
-        </p:txBody>
-      </p:sp>
-      <p:sp>
-        <p:nvSpPr>
-          <p:cNvPr id="11" name="TextBox 10"/>
-          <p:cNvSpPr txBox="1"/>
-          <p:nvPr/>
-        </p:nvSpPr>
-        <p:spPr>
-          <a:xfrm>
-            <a:off x="9052560" y="2011680"/>
-            <a:ext cx="2377440" cy="731520"/>
-          </a:xfrm>
-          <a:prstGeom prst="rect">
-            <a:avLst/>
-          </a:prstGeom>
-          <a:noFill/>
-        </p:spPr>
-        <p:txBody>
-          <a:bodyPr wrap="square" anchor="ctr" lIns="0" rIns="0" tIns="0" bIns="0">
-            <a:spAutoFit/>
-          </a:bodyPr>
-          <a:lstStyle/>
-          <a:p>
-            <a:pPr algn="l">
-              <a:lnSpc>
-                <a:spcPct val="110000"/>
-              </a:lnSpc>
-              <a:spcAft>
-                <a:spcPts val="600"/>
-              </a:spcAft>
-            </a:pPr>
-            <a:r>
-              <a:rPr sz="1500" b="0">
+              <a:rPr sz="1400" b="0">
                 <a:solidFill>
                   <a:srgbClr val="5B665D"/>
                 </a:solidFill>
                 <a:latin typeface="Open Sans"/>
               </a:rPr>
-              <a:t>nauda</a:t>
-            </a:r>
-          </a:p>
-        </p:txBody>
-      </p:sp>
-      <p:sp>
-        <p:nvSpPr>
-          <p:cNvPr id="12" name="Rounded Rectangle 11"/>
+              <a:t>Nepaļaujamies uz apziņu — legālais ceļš kļūst lētāks par mežu</a:t>
+            </a:r>
+          </a:p>
+        </p:txBody>
+      </p:sp>
+      <p:sp>
+        <p:nvSpPr>
+          <p:cNvPr id="9" name="Rounded Rectangle 8"/>
           <p:cNvSpPr/>
           <p:nvPr/>
         </p:nvSpPr>
         <p:spPr>
           <a:xfrm>
-            <a:off x="4206240" y="2880360"/>
-            <a:ext cx="7360920" cy="731520"/>
+            <a:off x="6172200" y="1965960"/>
+            <a:ext cx="5349240" cy="1280160"/>
           </a:xfrm>
           <a:prstGeom prst="roundRect">
             <a:avLst>
@@ -6573,148 +6469,20 @@
       </p:sp>
       <p:sp>
         <p:nvSpPr>
-          <p:cNvPr id="13" name="TextBox 12"/>
-          <p:cNvSpPr txBox="1"/>
-          <p:nvPr/>
-        </p:nvSpPr>
-        <p:spPr>
-          <a:xfrm>
-            <a:off x="4480560" y="2880360"/>
-            <a:ext cx="2377440" cy="731520"/>
-          </a:xfrm>
-          <a:prstGeom prst="rect">
-            <a:avLst/>
-          </a:prstGeom>
-          <a:noFill/>
-        </p:spPr>
-        <p:txBody>
-          <a:bodyPr wrap="square" anchor="ctr" lIns="0" rIns="0" tIns="0" bIns="0">
-            <a:spAutoFit/>
-          </a:bodyPr>
-          <a:lstStyle/>
-          <a:p>
-            <a:pPr algn="l">
-              <a:lnSpc>
-                <a:spcPct val="110000"/>
-              </a:lnSpc>
-              <a:spcAft>
-                <a:spcPts val="600"/>
-              </a:spcAft>
-            </a:pPr>
-            <a:r>
-              <a:rPr sz="2000" b="1">
-                <a:solidFill>
-                  <a:srgbClr val="1C261E"/>
-                </a:solidFill>
-                <a:latin typeface="Montserrat"/>
-              </a:rPr>
-              <a:t>Betons</a:t>
-            </a:r>
-          </a:p>
-        </p:txBody>
-      </p:sp>
-      <p:sp>
-        <p:nvSpPr>
-          <p:cNvPr id="14" name="TextBox 13"/>
-          <p:cNvSpPr txBox="1"/>
-          <p:nvPr/>
-        </p:nvSpPr>
-        <p:spPr>
-          <a:xfrm>
-            <a:off x="6766560" y="2880360"/>
-            <a:ext cx="2194560" cy="731520"/>
-          </a:xfrm>
-          <a:prstGeom prst="rect">
-            <a:avLst/>
-          </a:prstGeom>
-          <a:noFill/>
-        </p:spPr>
-        <p:txBody>
-          <a:bodyPr wrap="square" anchor="ctr" lIns="0" rIns="0" tIns="0" bIns="0">
-            <a:spAutoFit/>
-          </a:bodyPr>
-          <a:lstStyle/>
-          <a:p>
-            <a:pPr algn="l">
-              <a:lnSpc>
-                <a:spcPct val="110000"/>
-              </a:lnSpc>
-              <a:spcAft>
-                <a:spcPts val="600"/>
-              </a:spcAft>
-            </a:pPr>
-            <a:r>
-              <a:rPr sz="2200" b="1">
-                <a:solidFill>
-                  <a:srgbClr val="244A30"/>
-                </a:solidFill>
-                <a:latin typeface="Montserrat"/>
-              </a:rPr>
-              <a:t>1–3 €/t</a:t>
-            </a:r>
-          </a:p>
-        </p:txBody>
-      </p:sp>
-      <p:sp>
-        <p:nvSpPr>
-          <p:cNvPr id="15" name="TextBox 14"/>
-          <p:cNvSpPr txBox="1"/>
-          <p:nvPr/>
-        </p:nvSpPr>
-        <p:spPr>
-          <a:xfrm>
-            <a:off x="9052560" y="2880360"/>
-            <a:ext cx="2377440" cy="731520"/>
-          </a:xfrm>
-          <a:prstGeom prst="rect">
-            <a:avLst/>
-          </a:prstGeom>
-          <a:noFill/>
-        </p:spPr>
-        <p:txBody>
-          <a:bodyPr wrap="square" anchor="ctr" lIns="0" rIns="0" tIns="0" bIns="0">
-            <a:spAutoFit/>
-          </a:bodyPr>
-          <a:lstStyle/>
-          <a:p>
-            <a:pPr algn="l">
-              <a:lnSpc>
-                <a:spcPct val="110000"/>
-              </a:lnSpc>
-              <a:spcAft>
-                <a:spcPts val="600"/>
-              </a:spcAft>
-            </a:pPr>
-            <a:r>
-              <a:rPr sz="1500" b="0">
-                <a:solidFill>
-                  <a:srgbClr val="5B665D"/>
-                </a:solidFill>
-                <a:latin typeface="Open Sans"/>
-              </a:rPr>
-              <a:t>punkti / šķembas</a:t>
-            </a:r>
-          </a:p>
-        </p:txBody>
-      </p:sp>
-      <p:sp>
-        <p:nvSpPr>
-          <p:cNvPr id="16" name="Rounded Rectangle 15"/>
+          <p:cNvPr id="10" name="Oval 9"/>
           <p:cNvSpPr/>
           <p:nvPr/>
         </p:nvSpPr>
         <p:spPr>
           <a:xfrm>
-            <a:off x="4206240" y="3749039"/>
-            <a:ext cx="7360920" cy="731520"/>
-          </a:xfrm>
-          <a:prstGeom prst="roundRect">
-            <a:avLst>
-              <a:gd name="adj" fmla="val 8000"/>
-            </a:avLst>
+            <a:off x="6446520" y="2240279"/>
+            <a:ext cx="731520" cy="731520"/>
+          </a:xfrm>
+          <a:prstGeom prst="ellipse">
+            <a:avLst/>
           </a:prstGeom>
           <a:solidFill>
-            <a:srgbClr val="FFFFFF"/>
+            <a:srgbClr val="244A30"/>
           </a:solidFill>
           <a:ln>
             <a:noFill/>
@@ -6745,14 +6513,14 @@
       </p:sp>
       <p:sp>
         <p:nvSpPr>
-          <p:cNvPr id="17" name="TextBox 16"/>
+          <p:cNvPr id="11" name="TextBox 10"/>
           <p:cNvSpPr txBox="1"/>
           <p:nvPr/>
         </p:nvSpPr>
         <p:spPr>
           <a:xfrm>
-            <a:off x="4480560" y="3749039"/>
-            <a:ext cx="2377440" cy="731520"/>
+            <a:off x="6446520" y="2240279"/>
+            <a:ext cx="731520" cy="731520"/>
           </a:xfrm>
           <a:prstGeom prst="rect">
             <a:avLst/>
@@ -6761,6 +6529,48 @@
         </p:spPr>
         <p:txBody>
           <a:bodyPr wrap="square" anchor="ctr" lIns="0" rIns="0" tIns="0" bIns="0">
+            <a:spAutoFit/>
+          </a:bodyPr>
+          <a:lstStyle/>
+          <a:p>
+            <a:pPr algn="ctr">
+              <a:lnSpc>
+                <a:spcPct val="110000"/>
+              </a:lnSpc>
+              <a:spcAft>
+                <a:spcPts val="600"/>
+              </a:spcAft>
+            </a:pPr>
+            <a:r>
+              <a:rPr sz="2200" b="1">
+                <a:solidFill>
+                  <a:srgbClr val="FFFFFF"/>
+                </a:solidFill>
+                <a:latin typeface="Montserrat"/>
+              </a:rPr>
+              <a:t>2</a:t>
+            </a:r>
+          </a:p>
+        </p:txBody>
+      </p:sp>
+      <p:sp>
+        <p:nvSpPr>
+          <p:cNvPr id="12" name="TextBox 11"/>
+          <p:cNvSpPr txBox="1"/>
+          <p:nvPr/>
+        </p:nvSpPr>
+        <p:spPr>
+          <a:xfrm>
+            <a:off x="7406640" y="2167128"/>
+            <a:ext cx="3931920" cy="457200"/>
+          </a:xfrm>
+          <a:prstGeom prst="rect">
+            <a:avLst/>
+          </a:prstGeom>
+          <a:noFill/>
+        </p:spPr>
+        <p:txBody>
+          <a:bodyPr wrap="square" anchor="t" lIns="0" rIns="0" tIns="0" bIns="0">
             <a:spAutoFit/>
           </a:bodyPr>
           <a:lstStyle/>
@@ -6780,21 +6590,21 @@
                 </a:solidFill>
                 <a:latin typeface="Montserrat"/>
               </a:rPr>
-              <a:t>Ķieģeļi</a:t>
-            </a:r>
-          </a:p>
-        </p:txBody>
-      </p:sp>
-      <p:sp>
-        <p:nvSpPr>
-          <p:cNvPr id="18" name="TextBox 17"/>
+              <a:t>Reāli aprēķināts</a:t>
+            </a:r>
+          </a:p>
+        </p:txBody>
+      </p:sp>
+      <p:sp>
+        <p:nvSpPr>
+          <p:cNvPr id="13" name="TextBox 12"/>
           <p:cNvSpPr txBox="1"/>
           <p:nvPr/>
         </p:nvSpPr>
         <p:spPr>
           <a:xfrm>
-            <a:off x="6766560" y="3749039"/>
-            <a:ext cx="2194560" cy="731520"/>
+            <a:off x="7406640" y="2606039"/>
+            <a:ext cx="3931920" cy="548640"/>
           </a:xfrm>
           <a:prstGeom prst="rect">
             <a:avLst/>
@@ -6802,7 +6612,7 @@
           <a:noFill/>
         </p:spPr>
         <p:txBody>
-          <a:bodyPr wrap="square" anchor="ctr" lIns="0" rIns="0" tIns="0" bIns="0">
+          <a:bodyPr wrap="square" anchor="t" lIns="0" rIns="0" tIns="0" bIns="0">
             <a:spAutoFit/>
           </a:bodyPr>
           <a:lstStyle/>
@@ -6816,69 +6626,27 @@
               </a:spcAft>
             </a:pPr>
             <a:r>
-              <a:rPr sz="2200" b="1">
-                <a:solidFill>
-                  <a:srgbClr val="244A30"/>
-                </a:solidFill>
-                <a:latin typeface="Montserrat"/>
-              </a:rPr>
-              <a:t>0,5–1,5 €/t</a:t>
-            </a:r>
-          </a:p>
-        </p:txBody>
-      </p:sp>
-      <p:sp>
-        <p:nvSpPr>
-          <p:cNvPr id="19" name="TextBox 18"/>
-          <p:cNvSpPr txBox="1"/>
-          <p:nvPr/>
-        </p:nvSpPr>
-        <p:spPr>
-          <a:xfrm>
-            <a:off x="9052560" y="3749039"/>
-            <a:ext cx="2377440" cy="731520"/>
-          </a:xfrm>
-          <a:prstGeom prst="rect">
-            <a:avLst/>
-          </a:prstGeom>
-          <a:noFill/>
-        </p:spPr>
-        <p:txBody>
-          <a:bodyPr wrap="square" anchor="ctr" lIns="0" rIns="0" tIns="0" bIns="0">
-            <a:spAutoFit/>
-          </a:bodyPr>
-          <a:lstStyle/>
-          <a:p>
-            <a:pPr algn="l">
-              <a:lnSpc>
-                <a:spcPct val="110000"/>
-              </a:lnSpc>
-              <a:spcAft>
-                <a:spcPts val="600"/>
-              </a:spcAft>
-            </a:pPr>
-            <a:r>
-              <a:rPr sz="1500" b="0">
+              <a:rPr sz="1400" b="0">
                 <a:solidFill>
                   <a:srgbClr val="5B665D"/>
                 </a:solidFill>
                 <a:latin typeface="Open Sans"/>
               </a:rPr>
-              <a:t>punkti / šķembas</a:t>
-            </a:r>
-          </a:p>
-        </p:txBody>
-      </p:sp>
-      <p:sp>
-        <p:nvSpPr>
-          <p:cNvPr id="20" name="Rounded Rectangle 19"/>
+              <a:t>Atlīdzība balstīta uz pārstrādātāju cenām un peļņu (~2 %)</a:t>
+            </a:r>
+          </a:p>
+        </p:txBody>
+      </p:sp>
+      <p:sp>
+        <p:nvSpPr>
+          <p:cNvPr id="14" name="Rounded Rectangle 13"/>
           <p:cNvSpPr/>
           <p:nvPr/>
         </p:nvSpPr>
         <p:spPr>
           <a:xfrm>
-            <a:off x="4206240" y="4709160"/>
-            <a:ext cx="7360920" cy="685800"/>
+            <a:off x="640080" y="3429000"/>
+            <a:ext cx="5349240" cy="1280160"/>
           </a:xfrm>
           <a:prstGeom prst="roundRect">
             <a:avLst>
@@ -6886,7 +6654,7 @@
             </a:avLst>
           </a:prstGeom>
           <a:solidFill>
-            <a:srgbClr val="5E8C5A"/>
+            <a:srgbClr val="FFFFFF"/>
           </a:solidFill>
           <a:ln>
             <a:noFill/>
@@ -6917,14 +6685,58 @@
       </p:sp>
       <p:sp>
         <p:nvSpPr>
-          <p:cNvPr id="21" name="TextBox 20"/>
+          <p:cNvPr id="15" name="Oval 14"/>
+          <p:cNvSpPr/>
+          <p:nvPr/>
+        </p:nvSpPr>
+        <p:spPr>
+          <a:xfrm>
+            <a:off x="914400" y="3703320"/>
+            <a:ext cx="731520" cy="731520"/>
+          </a:xfrm>
+          <a:prstGeom prst="ellipse">
+            <a:avLst/>
+          </a:prstGeom>
+          <a:solidFill>
+            <a:srgbClr val="244A30"/>
+          </a:solidFill>
+          <a:ln>
+            <a:noFill/>
+          </a:ln>
+          <a:effectLst/>
+        </p:spPr>
+        <p:style>
+          <a:lnRef idx="1">
+            <a:schemeClr val="accent1"/>
+          </a:lnRef>
+          <a:fillRef idx="3">
+            <a:schemeClr val="accent1"/>
+          </a:fillRef>
+          <a:effectRef idx="2">
+            <a:schemeClr val="accent1"/>
+          </a:effectRef>
+          <a:fontRef idx="minor">
+            <a:schemeClr val="lt1"/>
+          </a:fontRef>
+        </p:style>
+        <p:txBody>
+          <a:bodyPr rtlCol="0" anchor="ctr"/>
+          <a:lstStyle/>
+          <a:p>
+            <a:pPr algn="ctr"/>
+          </a:p>
+        </p:txBody>
+      </p:sp>
+      <p:sp>
+        <p:nvSpPr>
+          <p:cNvPr id="16" name="TextBox 15"/>
           <p:cNvSpPr txBox="1"/>
           <p:nvPr/>
         </p:nvSpPr>
         <p:spPr>
           <a:xfrm>
-            <a:off x="4480560" y="4709160"/>
-            <a:ext cx="6949440" cy="685800"/>
+            <a:off x="914400" y="3703320"/>
+            <a:ext cx="731520" cy="731520"/>
           </a:xfrm>
           <a:prstGeom prst="rect">
             <a:avLst/>
@@ -6933,6 +6745,48 @@
         </p:spPr>
         <p:txBody>
           <a:bodyPr wrap="square" anchor="ctr" lIns="0" rIns="0" tIns="0" bIns="0">
+            <a:spAutoFit/>
+          </a:bodyPr>
+          <a:lstStyle/>
+          <a:p>
+            <a:pPr algn="ctr">
+              <a:lnSpc>
+                <a:spcPct val="110000"/>
+              </a:lnSpc>
+              <a:spcAft>
+                <a:spcPts val="600"/>
+              </a:spcAft>
+            </a:pPr>
+            <a:r>
+              <a:rPr sz="2200" b="1">
+                <a:solidFill>
+                  <a:srgbClr val="FFFFFF"/>
+                </a:solidFill>
+                <a:latin typeface="Montserrat"/>
+              </a:rPr>
+              <a:t>3</a:t>
+            </a:r>
+          </a:p>
+        </p:txBody>
+      </p:sp>
+      <p:sp>
+        <p:nvSpPr>
+          <p:cNvPr id="17" name="TextBox 16"/>
+          <p:cNvSpPr txBox="1"/>
+          <p:nvPr/>
+        </p:nvSpPr>
+        <p:spPr>
+          <a:xfrm>
+            <a:off x="1874519" y="3630168"/>
+            <a:ext cx="3931920" cy="457200"/>
+          </a:xfrm>
+          <a:prstGeom prst="rect">
+            <a:avLst/>
+          </a:prstGeom>
+          <a:noFill/>
+        </p:spPr>
+        <p:txBody>
+          <a:bodyPr wrap="square" anchor="t" lIns="0" rIns="0" tIns="0" bIns="0">
             <a:spAutoFit/>
           </a:bodyPr>
           <a:lstStyle/>
@@ -6946,27 +6800,27 @@
               </a:spcAft>
             </a:pPr>
             <a:r>
-              <a:rPr sz="1500" b="1">
-                <a:solidFill>
-                  <a:srgbClr val="FFFFFF"/>
+              <a:rPr sz="2000" b="1">
+                <a:solidFill>
+                  <a:srgbClr val="1C261E"/>
                 </a:solidFill>
                 <a:latin typeface="Montserrat"/>
               </a:rPr>
-              <a:t>Atlīdzība = svars × bāzes cena × kvalitāte (A = 1 · B = 0,3–0,5 · C = 0)</a:t>
-            </a:r>
-          </a:p>
-        </p:txBody>
-      </p:sp>
-      <p:sp>
-        <p:nvSpPr>
-          <p:cNvPr id="22" name="TextBox 21"/>
+              <a:t>Atmaksājas braukt</a:t>
+            </a:r>
+          </a:p>
+        </p:txBody>
+      </p:sp>
+      <p:sp>
+        <p:nvSpPr>
+          <p:cNvPr id="18" name="TextBox 17"/>
           <p:cNvSpPr txBox="1"/>
           <p:nvPr/>
         </p:nvSpPr>
         <p:spPr>
           <a:xfrm>
-            <a:off x="4206240" y="5577840"/>
-            <a:ext cx="7360920" cy="731520"/>
+            <a:off x="1874519" y="4069080"/>
+            <a:ext cx="3931920" cy="548640"/>
           </a:xfrm>
           <a:prstGeom prst="rect">
             <a:avLst/>
@@ -6990,13 +6844,168 @@
             <a:r>
               <a:rPr sz="1400" b="0">
                 <a:solidFill>
-                  <a:srgbClr val="1C261E"/>
+                  <a:srgbClr val="5B665D"/>
                 </a:solidFill>
                 <a:latin typeface="Open Sans"/>
               </a:rPr>
-              <a:t>Lietotne nepelna — uzturēšanu sedz pašvaldība, kas ietaupa uz izgāztuvju sakopšanu. Sākums: pilotprojekts vienā pašvaldībā.</a:t>
-            </a:r>
-          </a:p>
+              <a:t>Lietotne rāda tikai punktus, kur atlīdzība &gt; degvielas izmaksas</a:t>
+            </a:r>
+          </a:p>
+        </p:txBody>
+      </p:sp>
+      <p:sp>
+        <p:nvSpPr>
+          <p:cNvPr id="19" name="Rounded Rectangle 18"/>
+          <p:cNvSpPr/>
+          <p:nvPr/>
+        </p:nvSpPr>
+        <p:spPr>
+          <a:xfrm>
+            <a:off x="6172200" y="3429000"/>
+            <a:ext cx="5349240" cy="1280160"/>
+          </a:xfrm>
+          <a:prstGeom prst="roundRect">
+            <a:avLst>
+              <a:gd name="adj" fmla="val 8000"/>
+            </a:avLst>
+          </a:prstGeom>
+          <a:solidFill>
+            <a:srgbClr val="FFFFFF"/>
+          </a:solidFill>
+          <a:ln>
+            <a:noFill/>
+          </a:ln>
+          <a:effectLst/>
+        </p:spPr>
+        <p:style>
+          <a:lnRef idx="1">
+            <a:schemeClr val="accent1"/>
+          </a:lnRef>
+          <a:fillRef idx="3">
+            <a:schemeClr val="accent1"/>
+          </a:fillRef>
+          <a:effectRef idx="2">
+            <a:schemeClr val="accent1"/>
+          </a:effectRef>
+          <a:fontRef idx="minor">
+            <a:schemeClr val="lt1"/>
+          </a:fontRef>
+        </p:style>
+        <p:txBody>
+          <a:bodyPr rtlCol="0" anchor="ctr"/>
+          <a:lstStyle/>
+          <a:p>
+            <a:pPr algn="ctr"/>
+          </a:p>
+        </p:txBody>
+      </p:sp>
+      <p:sp>
+        <p:nvSpPr>
+          <p:cNvPr id="20" name="Oval 19"/>
+          <p:cNvSpPr/>
+          <p:nvPr/>
+        </p:nvSpPr>
+        <p:spPr>
+          <a:xfrm>
+            <a:off x="6446520" y="3703320"/>
+            <a:ext cx="731520" cy="731520"/>
+          </a:xfrm>
+          <a:prstGeom prst="ellipse">
+            <a:avLst/>
+          </a:prstGeom>
+          <a:solidFill>
+            <a:srgbClr val="244A30"/>
+          </a:solidFill>
+          <a:ln>
+            <a:noFill/>
+          </a:ln>
+          <a:effectLst/>
+        </p:spPr>
+        <p:style>
+          <a:lnRef idx="1">
+            <a:schemeClr val="accent1"/>
+          </a:lnRef>
+          <a:fillRef idx="3">
+            <a:schemeClr val="accent1"/>
+          </a:fillRef>
+          <a:effectRef idx="2">
+            <a:schemeClr val="accent1"/>
+          </a:effectRef>
+          <a:fontRef idx="minor">
+            <a:schemeClr val="lt1"/>
+          </a:fontRef>
+        </p:style>
+        <p:txBody>
+          <a:bodyPr rtlCol="0" anchor="ctr"/>
+          <a:lstStyle/>
+          <a:p>
+            <a:pPr algn="ctr"/>
+          </a:p>
+        </p:txBody>
+      </p:sp>
+      <p:sp>
+        <p:nvSpPr>
+          <p:cNvPr id="21" name="TextBox 20"/>
+          <p:cNvSpPr txBox="1"/>
+          <p:nvPr/>
+        </p:nvSpPr>
+        <p:spPr>
+          <a:xfrm>
+            <a:off x="6446520" y="3703320"/>
+            <a:ext cx="731520" cy="731520"/>
+          </a:xfrm>
+          <a:prstGeom prst="rect">
+            <a:avLst/>
+          </a:prstGeom>
+          <a:noFill/>
+        </p:spPr>
+        <p:txBody>
+          <a:bodyPr wrap="square" anchor="ctr" lIns="0" rIns="0" tIns="0" bIns="0">
+            <a:spAutoFit/>
+          </a:bodyPr>
+          <a:lstStyle/>
+          <a:p>
+            <a:pPr algn="ctr">
+              <a:lnSpc>
+                <a:spcPct val="110000"/>
+              </a:lnSpc>
+              <a:spcAft>
+                <a:spcPts val="600"/>
+              </a:spcAft>
+            </a:pPr>
+            <a:r>
+              <a:rPr sz="2200" b="1">
+                <a:solidFill>
+                  <a:srgbClr val="FFFFFF"/>
+                </a:solidFill>
+                <a:latin typeface="Montserrat"/>
+              </a:rPr>
+              <a:t>4</a:t>
+            </a:r>
+          </a:p>
+        </p:txBody>
+      </p:sp>
+      <p:sp>
+        <p:nvSpPr>
+          <p:cNvPr id="22" name="TextBox 21"/>
+          <p:cNvSpPr txBox="1"/>
+          <p:nvPr/>
+        </p:nvSpPr>
+        <p:spPr>
+          <a:xfrm>
+            <a:off x="7406640" y="3630168"/>
+            <a:ext cx="3931920" cy="457200"/>
+          </a:xfrm>
+          <a:prstGeom prst="rect">
+            <a:avLst/>
+          </a:prstGeom>
+          <a:noFill/>
+        </p:spPr>
+        <p:txBody>
+          <a:bodyPr wrap="square" anchor="t" lIns="0" rIns="0" tIns="0" bIns="0">
+            <a:spAutoFit/>
+          </a:bodyPr>
+          <a:lstStyle/>
           <a:p>
             <a:pPr algn="l">
               <a:lnSpc>
@@ -7007,13 +7016,456 @@
               </a:spcAft>
             </a:pPr>
             <a:r>
-              <a:rPr sz="1000" b="0">
+              <a:rPr sz="2000" b="1">
+                <a:solidFill>
+                  <a:srgbClr val="1C261E"/>
+                </a:solidFill>
+                <a:latin typeface="Montserrat"/>
+              </a:rPr>
+              <a:t>Bez jaunas infrastruktūras</a:t>
+            </a:r>
+          </a:p>
+        </p:txBody>
+      </p:sp>
+      <p:sp>
+        <p:nvSpPr>
+          <p:cNvPr id="23" name="TextBox 22"/>
+          <p:cNvSpPr txBox="1"/>
+          <p:nvPr/>
+        </p:nvSpPr>
+        <p:spPr>
+          <a:xfrm>
+            <a:off x="7406640" y="4069080"/>
+            <a:ext cx="3931920" cy="548640"/>
+          </a:xfrm>
+          <a:prstGeom prst="rect">
+            <a:avLst/>
+          </a:prstGeom>
+          <a:noFill/>
+        </p:spPr>
+        <p:txBody>
+          <a:bodyPr wrap="square" anchor="t" lIns="0" rIns="0" tIns="0" bIns="0">
+            <a:spAutoFit/>
+          </a:bodyPr>
+          <a:lstStyle/>
+          <a:p>
+            <a:pPr algn="l">
+              <a:lnSpc>
+                <a:spcPct val="110000"/>
+              </a:lnSpc>
+              <a:spcAft>
+                <a:spcPts val="600"/>
+              </a:spcAft>
+            </a:pPr>
+            <a:r>
+              <a:rPr sz="1400" b="0">
                 <a:solidFill>
                   <a:srgbClr val="5B665D"/>
                 </a:solidFill>
                 <a:latin typeface="Open Sans"/>
               </a:rPr>
-              <a:t>€/t — aplēses, jāpārbauda ar uzņēmumiem.</a:t>
+              <a:t>Izmanto esošos licencētos punktus — sākam ar vienu pašvaldību</a:t>
+            </a:r>
+          </a:p>
+        </p:txBody>
+      </p:sp>
+      <p:sp>
+        <p:nvSpPr>
+          <p:cNvPr id="24" name="Rounded Rectangle 23"/>
+          <p:cNvSpPr/>
+          <p:nvPr/>
+        </p:nvSpPr>
+        <p:spPr>
+          <a:xfrm>
+            <a:off x="640080" y="4983480"/>
+            <a:ext cx="10881360" cy="1005840"/>
+          </a:xfrm>
+          <a:prstGeom prst="roundRect">
+            <a:avLst>
+              <a:gd name="adj" fmla="val 8000"/>
+            </a:avLst>
+          </a:prstGeom>
+          <a:solidFill>
+            <a:srgbClr val="244A30"/>
+          </a:solidFill>
+          <a:ln>
+            <a:noFill/>
+          </a:ln>
+          <a:effectLst/>
+        </p:spPr>
+        <p:style>
+          <a:lnRef idx="1">
+            <a:schemeClr val="accent1"/>
+          </a:lnRef>
+          <a:fillRef idx="3">
+            <a:schemeClr val="accent1"/>
+          </a:fillRef>
+          <a:effectRef idx="2">
+            <a:schemeClr val="accent1"/>
+          </a:effectRef>
+          <a:fontRef idx="minor">
+            <a:schemeClr val="lt1"/>
+          </a:fontRef>
+        </p:style>
+        <p:txBody>
+          <a:bodyPr rtlCol="0" anchor="ctr"/>
+          <a:lstStyle/>
+          <a:p>
+            <a:pPr algn="ctr"/>
+          </a:p>
+        </p:txBody>
+      </p:sp>
+      <p:sp>
+        <p:nvSpPr>
+          <p:cNvPr id="25" name="TextBox 24"/>
+          <p:cNvSpPr txBox="1"/>
+          <p:nvPr/>
+        </p:nvSpPr>
+        <p:spPr>
+          <a:xfrm>
+            <a:off x="914400" y="5074920"/>
+            <a:ext cx="2377440" cy="365760"/>
+          </a:xfrm>
+          <a:prstGeom prst="rect">
+            <a:avLst/>
+          </a:prstGeom>
+          <a:noFill/>
+        </p:spPr>
+        <p:txBody>
+          <a:bodyPr wrap="square" anchor="t" lIns="0" rIns="0" tIns="0" bIns="0">
+            <a:spAutoFit/>
+          </a:bodyPr>
+          <a:lstStyle/>
+          <a:p>
+            <a:pPr algn="l">
+              <a:lnSpc>
+                <a:spcPct val="110000"/>
+              </a:lnSpc>
+              <a:spcAft>
+                <a:spcPts val="600"/>
+              </a:spcAft>
+            </a:pPr>
+            <a:r>
+              <a:rPr sz="1300" b="0">
+                <a:solidFill>
+                  <a:srgbClr val="CFE0C8"/>
+                </a:solidFill>
+                <a:latin typeface="Open Sans"/>
+              </a:rPr>
+              <a:t>Koksne</a:t>
+            </a:r>
+          </a:p>
+        </p:txBody>
+      </p:sp>
+      <p:sp>
+        <p:nvSpPr>
+          <p:cNvPr id="26" name="TextBox 25"/>
+          <p:cNvSpPr txBox="1"/>
+          <p:nvPr/>
+        </p:nvSpPr>
+        <p:spPr>
+          <a:xfrm>
+            <a:off x="914400" y="5394960"/>
+            <a:ext cx="2377440" cy="457200"/>
+          </a:xfrm>
+          <a:prstGeom prst="rect">
+            <a:avLst/>
+          </a:prstGeom>
+          <a:noFill/>
+        </p:spPr>
+        <p:txBody>
+          <a:bodyPr wrap="square" anchor="t" lIns="0" rIns="0" tIns="0" bIns="0">
+            <a:spAutoFit/>
+          </a:bodyPr>
+          <a:lstStyle/>
+          <a:p>
+            <a:pPr algn="l">
+              <a:lnSpc>
+                <a:spcPct val="110000"/>
+              </a:lnSpc>
+              <a:spcAft>
+                <a:spcPts val="600"/>
+              </a:spcAft>
+            </a:pPr>
+            <a:r>
+              <a:rPr sz="2200" b="1">
+                <a:solidFill>
+                  <a:srgbClr val="FFFFFF"/>
+                </a:solidFill>
+                <a:latin typeface="Montserrat"/>
+              </a:rPr>
+              <a:t>15–30 €/t</a:t>
+            </a:r>
+          </a:p>
+        </p:txBody>
+      </p:sp>
+      <p:sp>
+        <p:nvSpPr>
+          <p:cNvPr id="27" name="TextBox 26"/>
+          <p:cNvSpPr txBox="1"/>
+          <p:nvPr/>
+        </p:nvSpPr>
+        <p:spPr>
+          <a:xfrm>
+            <a:off x="3429000" y="5074920"/>
+            <a:ext cx="2377440" cy="365760"/>
+          </a:xfrm>
+          <a:prstGeom prst="rect">
+            <a:avLst/>
+          </a:prstGeom>
+          <a:noFill/>
+        </p:spPr>
+        <p:txBody>
+          <a:bodyPr wrap="square" anchor="t" lIns="0" rIns="0" tIns="0" bIns="0">
+            <a:spAutoFit/>
+          </a:bodyPr>
+          <a:lstStyle/>
+          <a:p>
+            <a:pPr algn="l">
+              <a:lnSpc>
+                <a:spcPct val="110000"/>
+              </a:lnSpc>
+              <a:spcAft>
+                <a:spcPts val="600"/>
+              </a:spcAft>
+            </a:pPr>
+            <a:r>
+              <a:rPr sz="1300" b="0">
+                <a:solidFill>
+                  <a:srgbClr val="CFE0C8"/>
+                </a:solidFill>
+                <a:latin typeface="Open Sans"/>
+              </a:rPr>
+              <a:t>Betons</a:t>
+            </a:r>
+          </a:p>
+        </p:txBody>
+      </p:sp>
+      <p:sp>
+        <p:nvSpPr>
+          <p:cNvPr id="28" name="TextBox 27"/>
+          <p:cNvSpPr txBox="1"/>
+          <p:nvPr/>
+        </p:nvSpPr>
+        <p:spPr>
+          <a:xfrm>
+            <a:off x="3429000" y="5394960"/>
+            <a:ext cx="2377440" cy="457200"/>
+          </a:xfrm>
+          <a:prstGeom prst="rect">
+            <a:avLst/>
+          </a:prstGeom>
+          <a:noFill/>
+        </p:spPr>
+        <p:txBody>
+          <a:bodyPr wrap="square" anchor="t" lIns="0" rIns="0" tIns="0" bIns="0">
+            <a:spAutoFit/>
+          </a:bodyPr>
+          <a:lstStyle/>
+          <a:p>
+            <a:pPr algn="l">
+              <a:lnSpc>
+                <a:spcPct val="110000"/>
+              </a:lnSpc>
+              <a:spcAft>
+                <a:spcPts val="600"/>
+              </a:spcAft>
+            </a:pPr>
+            <a:r>
+              <a:rPr sz="2200" b="1">
+                <a:solidFill>
+                  <a:srgbClr val="FFFFFF"/>
+                </a:solidFill>
+                <a:latin typeface="Montserrat"/>
+              </a:rPr>
+              <a:t>1–3 €/t</a:t>
+            </a:r>
+          </a:p>
+        </p:txBody>
+      </p:sp>
+      <p:sp>
+        <p:nvSpPr>
+          <p:cNvPr id="29" name="TextBox 28"/>
+          <p:cNvSpPr txBox="1"/>
+          <p:nvPr/>
+        </p:nvSpPr>
+        <p:spPr>
+          <a:xfrm>
+            <a:off x="5943600" y="5074920"/>
+            <a:ext cx="2377440" cy="365760"/>
+          </a:xfrm>
+          <a:prstGeom prst="rect">
+            <a:avLst/>
+          </a:prstGeom>
+          <a:noFill/>
+        </p:spPr>
+        <p:txBody>
+          <a:bodyPr wrap="square" anchor="t" lIns="0" rIns="0" tIns="0" bIns="0">
+            <a:spAutoFit/>
+          </a:bodyPr>
+          <a:lstStyle/>
+          <a:p>
+            <a:pPr algn="l">
+              <a:lnSpc>
+                <a:spcPct val="110000"/>
+              </a:lnSpc>
+              <a:spcAft>
+                <a:spcPts val="600"/>
+              </a:spcAft>
+            </a:pPr>
+            <a:r>
+              <a:rPr sz="1300" b="0">
+                <a:solidFill>
+                  <a:srgbClr val="CFE0C8"/>
+                </a:solidFill>
+                <a:latin typeface="Open Sans"/>
+              </a:rPr>
+              <a:t>Ķieģeļi</a:t>
+            </a:r>
+          </a:p>
+        </p:txBody>
+      </p:sp>
+      <p:sp>
+        <p:nvSpPr>
+          <p:cNvPr id="30" name="TextBox 29"/>
+          <p:cNvSpPr txBox="1"/>
+          <p:nvPr/>
+        </p:nvSpPr>
+        <p:spPr>
+          <a:xfrm>
+            <a:off x="5943600" y="5394960"/>
+            <a:ext cx="2377440" cy="457200"/>
+          </a:xfrm>
+          <a:prstGeom prst="rect">
+            <a:avLst/>
+          </a:prstGeom>
+          <a:noFill/>
+        </p:spPr>
+        <p:txBody>
+          <a:bodyPr wrap="square" anchor="t" lIns="0" rIns="0" tIns="0" bIns="0">
+            <a:spAutoFit/>
+          </a:bodyPr>
+          <a:lstStyle/>
+          <a:p>
+            <a:pPr algn="l">
+              <a:lnSpc>
+                <a:spcPct val="110000"/>
+              </a:lnSpc>
+              <a:spcAft>
+                <a:spcPts val="600"/>
+              </a:spcAft>
+            </a:pPr>
+            <a:r>
+              <a:rPr sz="2200" b="1">
+                <a:solidFill>
+                  <a:srgbClr val="FFFFFF"/>
+                </a:solidFill>
+                <a:latin typeface="Montserrat"/>
+              </a:rPr>
+              <a:t>0,5–1,5 €/t</a:t>
+            </a:r>
+          </a:p>
+        </p:txBody>
+      </p:sp>
+      <p:sp>
+        <p:nvSpPr>
+          <p:cNvPr id="31" name="TextBox 30"/>
+          <p:cNvSpPr txBox="1"/>
+          <p:nvPr/>
+        </p:nvSpPr>
+        <p:spPr>
+          <a:xfrm>
+            <a:off x="8366760" y="5074920"/>
+            <a:ext cx="3017520" cy="822960"/>
+          </a:xfrm>
+          <a:prstGeom prst="rect">
+            <a:avLst/>
+          </a:prstGeom>
+          <a:noFill/>
+        </p:spPr>
+        <p:txBody>
+          <a:bodyPr wrap="square" anchor="t" lIns="0" rIns="0" tIns="0" bIns="0">
+            <a:spAutoFit/>
+          </a:bodyPr>
+          <a:lstStyle/>
+          <a:p>
+            <a:pPr algn="l">
+              <a:lnSpc>
+                <a:spcPct val="110000"/>
+              </a:lnSpc>
+              <a:spcAft>
+                <a:spcPts val="600"/>
+              </a:spcAft>
+            </a:pPr>
+            <a:r>
+              <a:rPr sz="1300" b="0">
+                <a:solidFill>
+                  <a:srgbClr val="CFE0C8"/>
+                </a:solidFill>
+                <a:latin typeface="Open Sans"/>
+              </a:rPr>
+              <a:t>Atlīdzība =</a:t>
+            </a:r>
+          </a:p>
+          <a:p>
+            <a:pPr algn="l">
+              <a:lnSpc>
+                <a:spcPct val="110000"/>
+              </a:lnSpc>
+              <a:spcAft>
+                <a:spcPts val="600"/>
+              </a:spcAft>
+            </a:pPr>
+            <a:r>
+              <a:rPr sz="1500" b="1">
+                <a:solidFill>
+                  <a:srgbClr val="FFFFFF"/>
+                </a:solidFill>
+                <a:latin typeface="Montserrat"/>
+              </a:rPr>
+              <a:t>svars × cena × kvalitāte</a:t>
+            </a:r>
+          </a:p>
+        </p:txBody>
+      </p:sp>
+      <p:sp>
+        <p:nvSpPr>
+          <p:cNvPr id="32" name="TextBox 31"/>
+          <p:cNvSpPr txBox="1"/>
+          <p:nvPr/>
+        </p:nvSpPr>
+        <p:spPr>
+          <a:xfrm>
+            <a:off x="640080" y="6126480"/>
+            <a:ext cx="10881360" cy="274320"/>
+          </a:xfrm>
+          <a:prstGeom prst="rect">
+            <a:avLst/>
+          </a:prstGeom>
+          <a:noFill/>
+        </p:spPr>
+        <p:txBody>
+          <a:bodyPr wrap="square" anchor="t" lIns="0" rIns="0" tIns="0" bIns="0">
+            <a:spAutoFit/>
+          </a:bodyPr>
+          <a:lstStyle/>
+          <a:p>
+            <a:pPr algn="l">
+              <a:lnSpc>
+                <a:spcPct val="110000"/>
+              </a:lnSpc>
+              <a:spcAft>
+                <a:spcPts val="600"/>
+              </a:spcAft>
+            </a:pPr>
+            <a:r>
+              <a:rPr sz="1000" b="0">
+                <a:solidFill>
+                  <a:srgbClr val="5B665D"/>
+                </a:solidFill>
+                <a:latin typeface="Open Sans"/>
+              </a:rPr>
+              <a:t>€/t — aplēses pēc uzņēmumu datiem, jāpārbauda pilotprojektā.</a:t>
             </a:r>
           </a:p>
         </p:txBody>
@@ -7044,16 +7496,40 @@
         <p:nvPr/>
       </p:nvGrpSpPr>
       <p:grpSpPr/>
-      <p:sp>
-        <p:nvSpPr>
-          <p:cNvPr id="2" name="TextBox 1"/>
+      <p:pic>
+        <p:nvPicPr>
+          <p:cNvPr id="2" name="Picture 1" descr="logo.png"/>
+          <p:cNvPicPr>
+            <a:picLocks noChangeAspect="1"/>
+          </p:cNvPicPr>
+          <p:nvPr/>
+        </p:nvPicPr>
+        <p:blipFill>
+          <a:blip r:embed="rId2"/>
+          <a:stretch>
+            <a:fillRect/>
+          </a:stretch>
+        </p:blipFill>
+        <p:spPr>
+          <a:xfrm>
+            <a:off x="5413248" y="640080"/>
+            <a:ext cx="1371600" cy="1335426"/>
+          </a:xfrm>
+          <a:prstGeom prst="rect">
+            <a:avLst/>
+          </a:prstGeom>
+        </p:spPr>
+      </p:pic>
+      <p:sp>
+        <p:nvSpPr>
+          <p:cNvPr id="3" name="TextBox 2"/>
           <p:cNvSpPr txBox="1"/>
           <p:nvPr/>
         </p:nvSpPr>
         <p:spPr>
           <a:xfrm>
-            <a:off x="640080" y="1463040"/>
-            <a:ext cx="10881360" cy="2377440"/>
+            <a:off x="640080" y="2286000"/>
+            <a:ext cx="10881360" cy="1828800"/>
           </a:xfrm>
           <a:prstGeom prst="rect">
             <a:avLst/>
@@ -7075,7 +7551,7 @@
               </a:spcAft>
             </a:pPr>
             <a:r>
-              <a:rPr sz="4800" b="1">
+              <a:rPr sz="4400" b="1">
                 <a:solidFill>
                   <a:srgbClr val="FFFFFF"/>
                 </a:solidFill>
@@ -7088,13 +7564,13 @@
       </p:sp>
       <p:sp>
         <p:nvSpPr>
-          <p:cNvPr id="3" name="TextBox 2"/>
+          <p:cNvPr id="4" name="TextBox 3"/>
           <p:cNvSpPr txBox="1"/>
           <p:nvPr/>
         </p:nvSpPr>
         <p:spPr>
           <a:xfrm>
-            <a:off x="640080" y="3931920"/>
+            <a:off x="640080" y="4160520"/>
             <a:ext cx="10881360" cy="640080"/>
           </a:xfrm>
           <a:prstGeom prst="rect">
@@ -7130,13 +7606,13 @@
       </p:sp>
       <p:sp>
         <p:nvSpPr>
-          <p:cNvPr id="4" name="TextBox 3"/>
+          <p:cNvPr id="5" name="TextBox 4"/>
           <p:cNvSpPr txBox="1"/>
           <p:nvPr/>
         </p:nvSpPr>
         <p:spPr>
           <a:xfrm>
-            <a:off x="640080" y="4572000"/>
+            <a:off x="640080" y="4754880"/>
             <a:ext cx="10881360" cy="457200"/>
           </a:xfrm>
           <a:prstGeom prst="rect">
@@ -7172,13 +7648,13 @@
       </p:sp>
       <p:sp>
         <p:nvSpPr>
-          <p:cNvPr id="5" name="TextBox 4"/>
+          <p:cNvPr id="6" name="TextBox 5"/>
           <p:cNvSpPr txBox="1"/>
           <p:nvPr/>
         </p:nvSpPr>
         <p:spPr>
           <a:xfrm>
-            <a:off x="640080" y="5669280"/>
+            <a:off x="640080" y="5760720"/>
             <a:ext cx="10881360" cy="548640"/>
           </a:xfrm>
           <a:prstGeom prst="rect">

</xml_diff>

<commit_message>
Hackathon: slide 3 as a user journey, UX principles for the app
Co-Authored-By: Claude Opus 5.5 <noreply@anthropic.com>
Claude-Session: https://claude.ai/code/session_01C3KfjncommuX479wUy9vJ7
</commit_message>
<xml_diff>
--- a/hakatons/buvgruzu-birza.pptx
+++ b/hakatons/buvgruzu-birza.pptx
@@ -652,7 +652,7 @@
           <a:lstStyle/>
           <a:p>
             <a:r>
-              <a:t>0:15 — Lietotnē tie ir četri soļi: reģistrējies, piesaki materiālu ar foto, izvēlies punktu kartē un saņem atlīdzību. Parādīšu, kā tas izskatās.</a:t>
+              <a:t>0:15 — Paskatīsimies ar Annas acīm. Viņa nofotografē gružus un uzreiz redz, cik saņems — vēl pirms reģistrācijas. Kartē redz tikai tos punktus, kur braukt atmaksājas. Parādīšu.</a:t>
             </a:r>
           </a:p>
           <a:p/>
@@ -5196,7 +5196,7 @@
                 </a:solidFill>
                 <a:latin typeface="Montserrat"/>
               </a:rPr>
-              <a:t>KĀ TAS DARBOJAS</a:t>
+              <a:t>LIETOTĀJA PIEREDZE</a:t>
             </a:r>
           </a:p>
         </p:txBody>
@@ -5210,7 +5210,7 @@
         <p:spPr>
           <a:xfrm>
             <a:off x="640080" y="914400"/>
-            <a:ext cx="5943600" cy="822960"/>
+            <a:ext cx="6583680" cy="822960"/>
           </a:xfrm>
           <a:prstGeom prst="rect">
             <a:avLst/>
@@ -5238,21 +5238,63 @@
                 </a:solidFill>
                 <a:latin typeface="Montserrat"/>
               </a:rPr>
-              <a:t>Četri soļi lietotnē</a:t>
-            </a:r>
-          </a:p>
-        </p:txBody>
-      </p:sp>
-      <p:sp>
-        <p:nvSpPr>
-          <p:cNvPr id="4" name="Oval 3"/>
+              <a:t>Anna remontē māju</a:t>
+            </a:r>
+          </a:p>
+        </p:txBody>
+      </p:sp>
+      <p:sp>
+        <p:nvSpPr>
+          <p:cNvPr id="4" name="TextBox 3"/>
+          <p:cNvSpPr txBox="1"/>
+          <p:nvPr/>
+        </p:nvSpPr>
+        <p:spPr>
+          <a:xfrm>
+            <a:off x="640080" y="1600200"/>
+            <a:ext cx="6583680" cy="457200"/>
+          </a:xfrm>
+          <a:prstGeom prst="rect">
+            <a:avLst/>
+          </a:prstGeom>
+          <a:noFill/>
+        </p:spPr>
+        <p:txBody>
+          <a:bodyPr wrap="square" anchor="t" lIns="0" rIns="0" tIns="0" bIns="0">
+            <a:spAutoFit/>
+          </a:bodyPr>
+          <a:lstStyle/>
+          <a:p>
+            <a:pPr algn="l">
+              <a:lnSpc>
+                <a:spcPct val="110000"/>
+              </a:lnSpc>
+              <a:spcAft>
+                <a:spcPts val="600"/>
+              </a:spcAft>
+            </a:pPr>
+            <a:r>
+              <a:rPr sz="1700" b="0">
+                <a:solidFill>
+                  <a:srgbClr val="5B665D"/>
+                </a:solidFill>
+                <a:latin typeface="Open Sans"/>
+              </a:rPr>
+              <a:t>Vecie grīdas dēļi un betona lauskas — ko darīt?</a:t>
+            </a:r>
+          </a:p>
+        </p:txBody>
+      </p:sp>
+      <p:sp>
+        <p:nvSpPr>
+          <p:cNvPr id="5" name="Oval 4"/>
           <p:cNvSpPr/>
           <p:nvPr/>
         </p:nvSpPr>
         <p:spPr>
           <a:xfrm>
-            <a:off x="640080" y="2011680"/>
-            <a:ext cx="731520" cy="731520"/>
+            <a:off x="640080" y="2331720"/>
+            <a:ext cx="685800" cy="685800"/>
           </a:xfrm>
           <a:prstGeom prst="ellipse">
             <a:avLst/>
@@ -5289,14 +5331,14 @@
       </p:sp>
       <p:sp>
         <p:nvSpPr>
-          <p:cNvPr id="5" name="TextBox 4"/>
+          <p:cNvPr id="6" name="TextBox 5"/>
           <p:cNvSpPr txBox="1"/>
           <p:nvPr/>
         </p:nvSpPr>
         <p:spPr>
           <a:xfrm>
-            <a:off x="640080" y="2011680"/>
-            <a:ext cx="731520" cy="731520"/>
+            <a:off x="640080" y="2331720"/>
+            <a:ext cx="685800" cy="685800"/>
           </a:xfrm>
           <a:prstGeom prst="rect">
             <a:avLst/>
@@ -5318,7 +5360,7 @@
               </a:spcAft>
             </a:pPr>
             <a:r>
-              <a:rPr sz="2400" b="1">
+              <a:rPr sz="2200" b="1">
                 <a:solidFill>
                   <a:srgbClr val="FFFFFF"/>
                 </a:solidFill>
@@ -5331,14 +5373,14 @@
       </p:sp>
       <p:sp>
         <p:nvSpPr>
-          <p:cNvPr id="6" name="TextBox 5"/>
+          <p:cNvPr id="7" name="TextBox 6"/>
           <p:cNvSpPr txBox="1"/>
           <p:nvPr/>
         </p:nvSpPr>
         <p:spPr>
           <a:xfrm>
-            <a:off x="1645920" y="1993392"/>
-            <a:ext cx="4754880" cy="457200"/>
+            <a:off x="1554480" y="2313432"/>
+            <a:ext cx="5669280" cy="457200"/>
           </a:xfrm>
           <a:prstGeom prst="rect">
             <a:avLst/>
@@ -5360,27 +5402,27 @@
               </a:spcAft>
             </a:pPr>
             <a:r>
-              <a:rPr sz="2200" b="1">
+              <a:rPr sz="2100" b="1">
                 <a:solidFill>
                   <a:srgbClr val="1C261E"/>
                 </a:solidFill>
                 <a:latin typeface="Montserrat"/>
               </a:rPr>
-              <a:t>Reģistrējies</a:t>
-            </a:r>
-          </a:p>
-        </p:txBody>
-      </p:sp>
-      <p:sp>
-        <p:nvSpPr>
-          <p:cNvPr id="7" name="TextBox 6"/>
+              <a:t>Nofotografē</a:t>
+            </a:r>
+          </a:p>
+        </p:txBody>
+      </p:sp>
+      <p:sp>
+        <p:nvSpPr>
+          <p:cNvPr id="8" name="TextBox 7"/>
           <p:cNvSpPr txBox="1"/>
           <p:nvPr/>
         </p:nvSpPr>
         <p:spPr>
           <a:xfrm>
-            <a:off x="1645920" y="2423160"/>
-            <a:ext cx="4754880" cy="365760"/>
+            <a:off x="1554480" y="2715768"/>
+            <a:ext cx="5669280" cy="365760"/>
           </a:xfrm>
           <a:prstGeom prst="rect">
             <a:avLst/>
@@ -5402,27 +5444,27 @@
               </a:spcAft>
             </a:pPr>
             <a:r>
-              <a:rPr sz="1500" b="0">
+              <a:rPr sz="1400" b="0">
                 <a:solidFill>
                   <a:srgbClr val="5B665D"/>
                 </a:solidFill>
                 <a:latin typeface="Open Sans"/>
               </a:rPr>
-              <a:t>Konts lietotnē</a:t>
-            </a:r>
-          </a:p>
-        </p:txBody>
-      </p:sp>
-      <p:sp>
-        <p:nvSpPr>
-          <p:cNvPr id="8" name="Oval 7"/>
+              <a:t>Izvēlas veidu un daudzumu maisos — lietotne parāda, kā šķirot</a:t>
+            </a:r>
+          </a:p>
+        </p:txBody>
+      </p:sp>
+      <p:sp>
+        <p:nvSpPr>
+          <p:cNvPr id="9" name="Oval 8"/>
           <p:cNvSpPr/>
           <p:nvPr/>
         </p:nvSpPr>
         <p:spPr>
           <a:xfrm>
-            <a:off x="640080" y="3108960"/>
-            <a:ext cx="731520" cy="731520"/>
+            <a:off x="640080" y="3319272"/>
+            <a:ext cx="685800" cy="685800"/>
           </a:xfrm>
           <a:prstGeom prst="ellipse">
             <a:avLst/>
@@ -5459,14 +5501,14 @@
       </p:sp>
       <p:sp>
         <p:nvSpPr>
-          <p:cNvPr id="9" name="TextBox 8"/>
+          <p:cNvPr id="10" name="TextBox 9"/>
           <p:cNvSpPr txBox="1"/>
           <p:nvPr/>
         </p:nvSpPr>
         <p:spPr>
           <a:xfrm>
-            <a:off x="640080" y="3108960"/>
-            <a:ext cx="731520" cy="731520"/>
+            <a:off x="640080" y="3319272"/>
+            <a:ext cx="685800" cy="685800"/>
           </a:xfrm>
           <a:prstGeom prst="rect">
             <a:avLst/>
@@ -5488,7 +5530,7 @@
               </a:spcAft>
             </a:pPr>
             <a:r>
-              <a:rPr sz="2400" b="1">
+              <a:rPr sz="2200" b="1">
                 <a:solidFill>
                   <a:srgbClr val="FFFFFF"/>
                 </a:solidFill>
@@ -5501,14 +5543,14 @@
       </p:sp>
       <p:sp>
         <p:nvSpPr>
-          <p:cNvPr id="10" name="TextBox 9"/>
+          <p:cNvPr id="11" name="TextBox 10"/>
           <p:cNvSpPr txBox="1"/>
           <p:nvPr/>
         </p:nvSpPr>
         <p:spPr>
           <a:xfrm>
-            <a:off x="1645920" y="3090672"/>
-            <a:ext cx="4754880" cy="457200"/>
+            <a:off x="1554480" y="3300984"/>
+            <a:ext cx="5669280" cy="457200"/>
           </a:xfrm>
           <a:prstGeom prst="rect">
             <a:avLst/>
@@ -5530,27 +5572,27 @@
               </a:spcAft>
             </a:pPr>
             <a:r>
-              <a:rPr sz="2200" b="1">
+              <a:rPr sz="2100" b="1">
                 <a:solidFill>
                   <a:srgbClr val="1C261E"/>
                 </a:solidFill>
                 <a:latin typeface="Montserrat"/>
               </a:rPr>
-              <a:t>Piesaki materiālu</a:t>
-            </a:r>
-          </a:p>
-        </p:txBody>
-      </p:sp>
-      <p:sp>
-        <p:nvSpPr>
-          <p:cNvPr id="11" name="TextBox 10"/>
+              <a:t>Uzreiz redz atlīdzību</a:t>
+            </a:r>
+          </a:p>
+        </p:txBody>
+      </p:sp>
+      <p:sp>
+        <p:nvSpPr>
+          <p:cNvPr id="12" name="TextBox 11"/>
           <p:cNvSpPr txBox="1"/>
           <p:nvPr/>
         </p:nvSpPr>
         <p:spPr>
           <a:xfrm>
-            <a:off x="1645920" y="3520440"/>
-            <a:ext cx="4754880" cy="365760"/>
+            <a:off x="1554480" y="3703320"/>
+            <a:ext cx="5669280" cy="365760"/>
           </a:xfrm>
           <a:prstGeom prst="rect">
             <a:avLst/>
@@ -5572,27 +5614,27 @@
               </a:spcAft>
             </a:pPr>
             <a:r>
-              <a:rPr sz="1500" b="0">
+              <a:rPr sz="1400" b="0">
                 <a:solidFill>
                   <a:srgbClr val="5B665D"/>
                 </a:solidFill>
                 <a:latin typeface="Open Sans"/>
               </a:rPr>
-              <a:t>Foto, veids, kvalitāte, daudzums</a:t>
-            </a:r>
-          </a:p>
-        </p:txBody>
-      </p:sp>
-      <p:sp>
-        <p:nvSpPr>
-          <p:cNvPr id="12" name="Oval 11"/>
+              <a:t>Vēl pirms reģistrācijas — bez riska, bez pūlēm</a:t>
+            </a:r>
+          </a:p>
+        </p:txBody>
+      </p:sp>
+      <p:sp>
+        <p:nvSpPr>
+          <p:cNvPr id="13" name="Oval 12"/>
           <p:cNvSpPr/>
           <p:nvPr/>
         </p:nvSpPr>
         <p:spPr>
           <a:xfrm>
-            <a:off x="640080" y="4206240"/>
-            <a:ext cx="731520" cy="731520"/>
+            <a:off x="640080" y="4306824"/>
+            <a:ext cx="685800" cy="685800"/>
           </a:xfrm>
           <a:prstGeom prst="ellipse">
             <a:avLst/>
@@ -5629,14 +5671,14 @@
       </p:sp>
       <p:sp>
         <p:nvSpPr>
-          <p:cNvPr id="13" name="TextBox 12"/>
+          <p:cNvPr id="14" name="TextBox 13"/>
           <p:cNvSpPr txBox="1"/>
           <p:nvPr/>
         </p:nvSpPr>
         <p:spPr>
           <a:xfrm>
-            <a:off x="640080" y="4206240"/>
-            <a:ext cx="731520" cy="731520"/>
+            <a:off x="640080" y="4306824"/>
+            <a:ext cx="685800" cy="685800"/>
           </a:xfrm>
           <a:prstGeom prst="rect">
             <a:avLst/>
@@ -5658,7 +5700,7 @@
               </a:spcAft>
             </a:pPr>
             <a:r>
-              <a:rPr sz="2400" b="1">
+              <a:rPr sz="2200" b="1">
                 <a:solidFill>
                   <a:srgbClr val="FFFFFF"/>
                 </a:solidFill>
@@ -5671,14 +5713,14 @@
       </p:sp>
       <p:sp>
         <p:nvSpPr>
-          <p:cNvPr id="14" name="TextBox 13"/>
+          <p:cNvPr id="15" name="TextBox 14"/>
           <p:cNvSpPr txBox="1"/>
           <p:nvPr/>
         </p:nvSpPr>
         <p:spPr>
           <a:xfrm>
-            <a:off x="1645920" y="4187952"/>
-            <a:ext cx="4754880" cy="457200"/>
+            <a:off x="1554480" y="4288536"/>
+            <a:ext cx="5669280" cy="457200"/>
           </a:xfrm>
           <a:prstGeom prst="rect">
             <a:avLst/>
@@ -5700,27 +5742,27 @@
               </a:spcAft>
             </a:pPr>
             <a:r>
-              <a:rPr sz="2200" b="1">
+              <a:rPr sz="2100" b="1">
                 <a:solidFill>
                   <a:srgbClr val="1C261E"/>
                 </a:solidFill>
                 <a:latin typeface="Montserrat"/>
               </a:rPr>
-              <a:t>Izvēlies punktu kartē</a:t>
-            </a:r>
-          </a:p>
-        </p:txBody>
-      </p:sp>
-      <p:sp>
-        <p:nvSpPr>
-          <p:cNvPr id="15" name="TextBox 14"/>
+              <a:t>Izvēlas punktu kartē</a:t>
+            </a:r>
+          </a:p>
+        </p:txBody>
+      </p:sp>
+      <p:sp>
+        <p:nvSpPr>
+          <p:cNvPr id="16" name="TextBox 15"/>
           <p:cNvSpPr txBox="1"/>
           <p:nvPr/>
         </p:nvSpPr>
         <p:spPr>
           <a:xfrm>
-            <a:off x="1645920" y="4617720"/>
-            <a:ext cx="4754880" cy="365760"/>
+            <a:off x="1554480" y="4690872"/>
+            <a:ext cx="5669280" cy="365760"/>
           </a:xfrm>
           <a:prstGeom prst="rect">
             <a:avLst/>
@@ -5742,7 +5784,7 @@
               </a:spcAft>
             </a:pPr>
             <a:r>
-              <a:rPr sz="1500" b="0">
+              <a:rPr sz="1400" b="0">
                 <a:solidFill>
                   <a:srgbClr val="5B665D"/>
                 </a:solidFill>
@@ -5755,14 +5797,14 @@
       </p:sp>
       <p:sp>
         <p:nvSpPr>
-          <p:cNvPr id="16" name="Oval 15"/>
+          <p:cNvPr id="17" name="Oval 16"/>
           <p:cNvSpPr/>
           <p:nvPr/>
         </p:nvSpPr>
         <p:spPr>
           <a:xfrm>
-            <a:off x="640080" y="5303520"/>
-            <a:ext cx="731520" cy="731520"/>
+            <a:off x="640080" y="5294376"/>
+            <a:ext cx="685800" cy="685800"/>
           </a:xfrm>
           <a:prstGeom prst="ellipse">
             <a:avLst/>
@@ -5799,14 +5841,14 @@
       </p:sp>
       <p:sp>
         <p:nvSpPr>
-          <p:cNvPr id="17" name="TextBox 16"/>
+          <p:cNvPr id="18" name="TextBox 17"/>
           <p:cNvSpPr txBox="1"/>
           <p:nvPr/>
         </p:nvSpPr>
         <p:spPr>
           <a:xfrm>
-            <a:off x="640080" y="5303520"/>
-            <a:ext cx="731520" cy="731520"/>
+            <a:off x="640080" y="5294376"/>
+            <a:ext cx="685800" cy="685800"/>
           </a:xfrm>
           <a:prstGeom prst="rect">
             <a:avLst/>
@@ -5828,7 +5870,7 @@
               </a:spcAft>
             </a:pPr>
             <a:r>
-              <a:rPr sz="2400" b="1">
+              <a:rPr sz="2200" b="1">
                 <a:solidFill>
                   <a:srgbClr val="FFFFFF"/>
                 </a:solidFill>
@@ -5841,14 +5883,14 @@
       </p:sp>
       <p:sp>
         <p:nvSpPr>
-          <p:cNvPr id="18" name="TextBox 17"/>
+          <p:cNvPr id="19" name="TextBox 18"/>
           <p:cNvSpPr txBox="1"/>
           <p:nvPr/>
         </p:nvSpPr>
         <p:spPr>
           <a:xfrm>
-            <a:off x="1645920" y="5285232"/>
-            <a:ext cx="4754880" cy="457200"/>
+            <a:off x="1554480" y="5276088"/>
+            <a:ext cx="5669280" cy="457200"/>
           </a:xfrm>
           <a:prstGeom prst="rect">
             <a:avLst/>
@@ -5870,7 +5912,7 @@
               </a:spcAft>
             </a:pPr>
             <a:r>
-              <a:rPr sz="2200" b="1">
+              <a:rPr sz="2100" b="1">
                 <a:solidFill>
                   <a:srgbClr val="1C261E"/>
                 </a:solidFill>
@@ -5883,14 +5925,14 @@
       </p:sp>
       <p:sp>
         <p:nvSpPr>
-          <p:cNvPr id="19" name="TextBox 18"/>
+          <p:cNvPr id="20" name="TextBox 19"/>
           <p:cNvSpPr txBox="1"/>
           <p:nvPr/>
         </p:nvSpPr>
         <p:spPr>
           <a:xfrm>
-            <a:off x="1645920" y="5715000"/>
-            <a:ext cx="4754880" cy="365760"/>
+            <a:off x="1554480" y="5678424"/>
+            <a:ext cx="5669280" cy="365760"/>
           </a:xfrm>
           <a:prstGeom prst="rect">
             <a:avLst/>
@@ -5912,20 +5954,20 @@
               </a:spcAft>
             </a:pPr>
             <a:r>
-              <a:rPr sz="1500" b="0">
+              <a:rPr sz="1400" b="0">
                 <a:solidFill>
                   <a:srgbClr val="5B665D"/>
                 </a:solidFill>
                 <a:latin typeface="Open Sans"/>
               </a:rPr>
-              <a:t>Nosver, pārbauda, atlīdzība kontā</a:t>
-            </a:r>
-          </a:p>
-        </p:txBody>
-      </p:sp>
-      <p:sp>
-        <p:nvSpPr>
-          <p:cNvPr id="20" name="Rounded Rectangle 19"/>
+              <a:t>Nosver, pārbauda — atlīdzība kontā</a:t>
+            </a:r>
+          </a:p>
+        </p:txBody>
+      </p:sp>
+      <p:sp>
+        <p:nvSpPr>
+          <p:cNvPr id="21" name="Rounded Rectangle 20"/>
           <p:cNvSpPr/>
           <p:nvPr/>
         </p:nvSpPr>
@@ -5971,7 +6013,7 @@
       </p:sp>
       <p:sp>
         <p:nvSpPr>
-          <p:cNvPr id="21" name="Rounded Rectangle 20"/>
+          <p:cNvPr id="22" name="Rounded Rectangle 21"/>
           <p:cNvSpPr/>
           <p:nvPr/>
         </p:nvSpPr>
@@ -6017,7 +6059,7 @@
       </p:sp>
       <p:sp>
         <p:nvSpPr>
-          <p:cNvPr id="22" name="TextBox 21"/>
+          <p:cNvPr id="23" name="TextBox 22"/>
           <p:cNvSpPr txBox="1"/>
           <p:nvPr/>
         </p:nvSpPr>

</xml_diff>

<commit_message>
Hackathon: competitor comparison, single killer feature, cleaner slide 2
Co-Authored-By: Claude Opus 5.5 <noreply@anthropic.com>
Claude-Session: https://claude.ai/code/session_01C3KfjncommuX479wUy9vJ7
</commit_message>
<xml_diff>
--- a/hakatons/buvgruzu-birza.pptx
+++ b/hakatons/buvgruzu-birza.pptx
@@ -728,7 +728,7 @@
           <a:lstStyle/>
           <a:p>
             <a:r>
-              <a:t>0:30 — Kāpēc tieši mūsu risinājums? Pirmkārt, tas ir izdevīgi, nevis tikai pareizi — mēs nepaļaujamies uz cilvēku apziņu. Otrkārt, mēs to aprēķinājām: pārstrādātāju peļņa ir ap diviem procentiem, tāpēc par koksni maksājam naudu, par betonu — punktus. Treškārt, lietotne rāda tikai tos punktus, kur braukt atmaksājas. Un mums nevajag jaunu infrastruktūru — sākam ar pilotprojektu vienā pašvaldībā.</a:t>
+              <a:t>0:30 — Šodien Annai ir trīs iespējas. Sludinājums — lēti, bet gruži bieži nonāk mežā. Konteiners — legāli, bet dārgi. Šķirošanas laukums — jāzina, kur, jāved pašam, un nekas par to netiek. No šīm iespējām tikai Būvgružu biržā nodot ir bez maksas, ar atlīdzību un pārstrādē. Un mūsu galvenā funkcija: nofotografē — un uzreiz redzi, cik saņemsi un kur nodot atmaksājas. To aprēķinājām pēc pārstrādātāju reālajām cenām.</a:t>
             </a:r>
           </a:p>
         </p:txBody>
@@ -4468,7 +4468,7 @@
                 </a:solidFill>
                 <a:latin typeface="Open Sans"/>
               </a:rPr>
-              <a:t>Aprites ekonomikas platforma būvgružiem — savieno cilvēkus, kuriem ir būvgruži, ar uzņēmumiem, kas tos pārstrādā.</a:t>
+              <a:t>Aprites ekonomikas platforma būvgružiem. Savieno cilvēkus, kuriem ir būvgruži, ar uzņēmumiem, kas tos pārstrādā.</a:t>
             </a:r>
           </a:p>
         </p:txBody>
@@ -4666,7 +4666,7 @@
                 </a:solidFill>
                 <a:latin typeface="Open Sans"/>
               </a:rPr>
-              <a:t>— Nodod sašķirotus gružus bez maksas</a:t>
+              <a:t>•  Nodod sašķirotus gružus bez maksas</a:t>
             </a:r>
           </a:p>
           <a:p>
@@ -4685,7 +4685,7 @@
                 </a:solidFill>
                 <a:latin typeface="Open Sans"/>
               </a:rPr>
-              <a:t>— Par koksni — nauda</a:t>
+              <a:t>•  Par koksni: nauda</a:t>
             </a:r>
           </a:p>
           <a:p>
@@ -4704,7 +4704,7 @@
                 </a:solidFill>
                 <a:latin typeface="Open Sans"/>
               </a:rPr>
-              <a:t>— Par betonu un ķieģeļiem — punkti vai pārstrādātas šķembas</a:t>
+              <a:t>•  Par betonu un ķieģeļiem: punkti vai šķembas</a:t>
             </a:r>
           </a:p>
         </p:txBody>
@@ -4878,7 +4878,7 @@
                 </a:solidFill>
                 <a:latin typeface="Open Sans"/>
               </a:rPr>
-              <a:t>— Tīrs, sašķirots materiāls</a:t>
+              <a:t>•  Tīrs, sašķirots materiāls</a:t>
             </a:r>
           </a:p>
           <a:p>
@@ -4897,7 +4897,7 @@
                 </a:solidFill>
                 <a:latin typeface="Open Sans"/>
               </a:rPr>
-              <a:t>— Bez šķirošanas izmaksām</a:t>
+              <a:t>•  Bez šķirošanas izmaksām</a:t>
             </a:r>
           </a:p>
           <a:p>
@@ -4916,7 +4916,7 @@
                 </a:solidFill>
                 <a:latin typeface="Open Sans"/>
               </a:rPr>
-              <a:t>— Lētāka izejviela nekā jauna</a:t>
+              <a:t>•  Lētāka izejviela nekā jauna</a:t>
             </a:r>
           </a:p>
         </p:txBody>
@@ -5090,7 +5090,7 @@
                 </a:solidFill>
                 <a:latin typeface="Open Sans"/>
               </a:rPr>
-              <a:t>— Mazāk izgāztuvju mežos</a:t>
+              <a:t>•  Mazāk izgāztuvju mežos</a:t>
             </a:r>
           </a:p>
           <a:p>
@@ -5109,7 +5109,7 @@
                 </a:solidFill>
                 <a:latin typeface="Open Sans"/>
               </a:rPr>
-              <a:t>— Mazāk jaunu izejvielu ieguves</a:t>
+              <a:t>•  Mazāk jaunu izejvielu ieguves</a:t>
             </a:r>
           </a:p>
           <a:p>
@@ -5128,7 +5128,7 @@
                 </a:solidFill>
                 <a:latin typeface="Open Sans"/>
               </a:rPr>
-              <a:t>— Pašvaldība ietaupa uz sakopšanu</a:t>
+              <a:t>•  Pašvaldība ietaupa uz sakopšanu</a:t>
             </a:r>
           </a:p>
         </p:txBody>
@@ -5287,20 +5287,22 @@
       </p:sp>
       <p:sp>
         <p:nvSpPr>
-          <p:cNvPr id="5" name="Oval 4"/>
+          <p:cNvPr id="5" name="Rounded Rectangle 4"/>
           <p:cNvSpPr/>
           <p:nvPr/>
         </p:nvSpPr>
         <p:spPr>
           <a:xfrm>
-            <a:off x="640080" y="2331720"/>
-            <a:ext cx="685800" cy="685800"/>
-          </a:xfrm>
-          <a:prstGeom prst="ellipse">
-            <a:avLst/>
+            <a:off x="457200" y="3191256"/>
+            <a:ext cx="6858000" cy="941832"/>
+          </a:xfrm>
+          <a:prstGeom prst="roundRect">
+            <a:avLst>
+              <a:gd name="adj" fmla="val 8000"/>
+            </a:avLst>
           </a:prstGeom>
           <a:solidFill>
-            <a:srgbClr val="244A30"/>
+            <a:srgbClr val="CFE0C8"/>
           </a:solidFill>
           <a:ln>
             <a:noFill/>
@@ -5337,8 +5339,8 @@
         </p:nvSpPr>
         <p:spPr>
           <a:xfrm>
-            <a:off x="640080" y="2331720"/>
-            <a:ext cx="685800" cy="685800"/>
+            <a:off x="5394960" y="3273552"/>
+            <a:ext cx="1783080" cy="274320"/>
           </a:xfrm>
           <a:prstGeom prst="rect">
             <a:avLst/>
@@ -5346,12 +5348,12 @@
           <a:noFill/>
         </p:spPr>
         <p:txBody>
-          <a:bodyPr wrap="square" anchor="ctr" lIns="0" rIns="0" tIns="0" bIns="0">
+          <a:bodyPr wrap="square" anchor="t" lIns="0" rIns="0" tIns="0" bIns="0">
             <a:spAutoFit/>
           </a:bodyPr>
           <a:lstStyle/>
           <a:p>
-            <a:pPr algn="ctr">
+            <a:pPr algn="r">
               <a:lnSpc>
                 <a:spcPct val="110000"/>
               </a:lnSpc>
@@ -5360,110 +5362,26 @@
               </a:spcAft>
             </a:pPr>
             <a:r>
-              <a:rPr sz="2200" b="1">
-                <a:solidFill>
-                  <a:srgbClr val="FFFFFF"/>
+              <a:rPr sz="1000" b="1">
+                <a:solidFill>
+                  <a:srgbClr val="244A30"/>
                 </a:solidFill>
                 <a:latin typeface="Montserrat"/>
               </a:rPr>
-              <a:t>1</a:t>
-            </a:r>
-          </a:p>
-        </p:txBody>
-      </p:sp>
-      <p:sp>
-        <p:nvSpPr>
-          <p:cNvPr id="7" name="TextBox 6"/>
-          <p:cNvSpPr txBox="1"/>
-          <p:nvPr/>
-        </p:nvSpPr>
-        <p:spPr>
-          <a:xfrm>
-            <a:off x="1554480" y="2313432"/>
-            <a:ext cx="5669280" cy="457200"/>
-          </a:xfrm>
-          <a:prstGeom prst="rect">
-            <a:avLst/>
-          </a:prstGeom>
-          <a:noFill/>
-        </p:spPr>
-        <p:txBody>
-          <a:bodyPr wrap="square" anchor="t" lIns="0" rIns="0" tIns="0" bIns="0">
-            <a:spAutoFit/>
-          </a:bodyPr>
-          <a:lstStyle/>
-          <a:p>
-            <a:pPr algn="l">
-              <a:lnSpc>
-                <a:spcPct val="110000"/>
-              </a:lnSpc>
-              <a:spcAft>
-                <a:spcPts val="600"/>
-              </a:spcAft>
-            </a:pPr>
-            <a:r>
-              <a:rPr sz="2100" b="1">
-                <a:solidFill>
-                  <a:srgbClr val="1C261E"/>
-                </a:solidFill>
-                <a:latin typeface="Montserrat"/>
-              </a:rPr>
-              <a:t>Nofotografē</a:t>
-            </a:r>
-          </a:p>
-        </p:txBody>
-      </p:sp>
-      <p:sp>
-        <p:nvSpPr>
-          <p:cNvPr id="8" name="TextBox 7"/>
-          <p:cNvSpPr txBox="1"/>
-          <p:nvPr/>
-        </p:nvSpPr>
-        <p:spPr>
-          <a:xfrm>
-            <a:off x="1554480" y="2715768"/>
-            <a:ext cx="5669280" cy="365760"/>
-          </a:xfrm>
-          <a:prstGeom prst="rect">
-            <a:avLst/>
-          </a:prstGeom>
-          <a:noFill/>
-        </p:spPr>
-        <p:txBody>
-          <a:bodyPr wrap="square" anchor="t" lIns="0" rIns="0" tIns="0" bIns="0">
-            <a:spAutoFit/>
-          </a:bodyPr>
-          <a:lstStyle/>
-          <a:p>
-            <a:pPr algn="l">
-              <a:lnSpc>
-                <a:spcPct val="110000"/>
-              </a:lnSpc>
-              <a:spcAft>
-                <a:spcPts val="600"/>
-              </a:spcAft>
-            </a:pPr>
-            <a:r>
-              <a:rPr sz="1400" b="0">
-                <a:solidFill>
-                  <a:srgbClr val="5B665D"/>
-                </a:solidFill>
-                <a:latin typeface="Open Sans"/>
-              </a:rPr>
-              <a:t>Izvēlas veidu un daudzumu maisos — lietotne parāda, kā šķirot</a:t>
-            </a:r>
-          </a:p>
-        </p:txBody>
-      </p:sp>
-      <p:sp>
-        <p:nvSpPr>
-          <p:cNvPr id="9" name="Oval 8"/>
+              <a:t>GALVENĀ FUNKCIJA</a:t>
+            </a:r>
+          </a:p>
+        </p:txBody>
+      </p:sp>
+      <p:sp>
+        <p:nvSpPr>
+          <p:cNvPr id="7" name="Oval 6"/>
           <p:cNvSpPr/>
           <p:nvPr/>
         </p:nvSpPr>
         <p:spPr>
           <a:xfrm>
-            <a:off x="640080" y="3319272"/>
+            <a:off x="640080" y="2331720"/>
             <a:ext cx="685800" cy="685800"/>
           </a:xfrm>
           <a:prstGeom prst="ellipse">
@@ -5501,13 +5419,13 @@
       </p:sp>
       <p:sp>
         <p:nvSpPr>
-          <p:cNvPr id="10" name="TextBox 9"/>
+          <p:cNvPr id="8" name="TextBox 7"/>
           <p:cNvSpPr txBox="1"/>
           <p:nvPr/>
         </p:nvSpPr>
         <p:spPr>
           <a:xfrm>
-            <a:off x="640080" y="3319272"/>
+            <a:off x="640080" y="2331720"/>
             <a:ext cx="685800" cy="685800"/>
           </a:xfrm>
           <a:prstGeom prst="rect">
@@ -5536,20 +5454,20 @@
                 </a:solidFill>
                 <a:latin typeface="Montserrat"/>
               </a:rPr>
-              <a:t>2</a:t>
-            </a:r>
-          </a:p>
-        </p:txBody>
-      </p:sp>
-      <p:sp>
-        <p:nvSpPr>
-          <p:cNvPr id="11" name="TextBox 10"/>
+              <a:t>1</a:t>
+            </a:r>
+          </a:p>
+        </p:txBody>
+      </p:sp>
+      <p:sp>
+        <p:nvSpPr>
+          <p:cNvPr id="9" name="TextBox 8"/>
           <p:cNvSpPr txBox="1"/>
           <p:nvPr/>
         </p:nvSpPr>
         <p:spPr>
           <a:xfrm>
-            <a:off x="1554480" y="3300984"/>
+            <a:off x="1554480" y="2313432"/>
             <a:ext cx="5669280" cy="457200"/>
           </a:xfrm>
           <a:prstGeom prst="rect">
@@ -5578,20 +5496,20 @@
                 </a:solidFill>
                 <a:latin typeface="Montserrat"/>
               </a:rPr>
-              <a:t>Uzreiz redz atlīdzību</a:t>
-            </a:r>
-          </a:p>
-        </p:txBody>
-      </p:sp>
-      <p:sp>
-        <p:nvSpPr>
-          <p:cNvPr id="12" name="TextBox 11"/>
+              <a:t>Nofotografē</a:t>
+            </a:r>
+          </a:p>
+        </p:txBody>
+      </p:sp>
+      <p:sp>
+        <p:nvSpPr>
+          <p:cNvPr id="10" name="TextBox 9"/>
           <p:cNvSpPr txBox="1"/>
           <p:nvPr/>
         </p:nvSpPr>
         <p:spPr>
           <a:xfrm>
-            <a:off x="1554480" y="3703320"/>
+            <a:off x="1554480" y="2715768"/>
             <a:ext cx="5669280" cy="365760"/>
           </a:xfrm>
           <a:prstGeom prst="rect">
@@ -5620,20 +5538,20 @@
                 </a:solidFill>
                 <a:latin typeface="Open Sans"/>
               </a:rPr>
-              <a:t>Vēl pirms reģistrācijas — bez riska, bez pūlēm</a:t>
-            </a:r>
-          </a:p>
-        </p:txBody>
-      </p:sp>
-      <p:sp>
-        <p:nvSpPr>
-          <p:cNvPr id="13" name="Oval 12"/>
+              <a:t>Izvēlas veidu un daudzumu maisos — lietotne parāda, kā šķirot</a:t>
+            </a:r>
+          </a:p>
+        </p:txBody>
+      </p:sp>
+      <p:sp>
+        <p:nvSpPr>
+          <p:cNvPr id="11" name="Oval 10"/>
           <p:cNvSpPr/>
           <p:nvPr/>
         </p:nvSpPr>
         <p:spPr>
           <a:xfrm>
-            <a:off x="640080" y="4306824"/>
+            <a:off x="640080" y="3319272"/>
             <a:ext cx="685800" cy="685800"/>
           </a:xfrm>
           <a:prstGeom prst="ellipse">
@@ -5671,13 +5589,13 @@
       </p:sp>
       <p:sp>
         <p:nvSpPr>
-          <p:cNvPr id="14" name="TextBox 13"/>
+          <p:cNvPr id="12" name="TextBox 11"/>
           <p:cNvSpPr txBox="1"/>
           <p:nvPr/>
         </p:nvSpPr>
         <p:spPr>
           <a:xfrm>
-            <a:off x="640080" y="4306824"/>
+            <a:off x="640080" y="3319272"/>
             <a:ext cx="685800" cy="685800"/>
           </a:xfrm>
           <a:prstGeom prst="rect">
@@ -5706,20 +5624,20 @@
                 </a:solidFill>
                 <a:latin typeface="Montserrat"/>
               </a:rPr>
-              <a:t>3</a:t>
-            </a:r>
-          </a:p>
-        </p:txBody>
-      </p:sp>
-      <p:sp>
-        <p:nvSpPr>
-          <p:cNvPr id="15" name="TextBox 14"/>
+              <a:t>2</a:t>
+            </a:r>
+          </a:p>
+        </p:txBody>
+      </p:sp>
+      <p:sp>
+        <p:nvSpPr>
+          <p:cNvPr id="13" name="TextBox 12"/>
           <p:cNvSpPr txBox="1"/>
           <p:nvPr/>
         </p:nvSpPr>
         <p:spPr>
           <a:xfrm>
-            <a:off x="1554480" y="4288536"/>
+            <a:off x="1554480" y="3300984"/>
             <a:ext cx="5669280" cy="457200"/>
           </a:xfrm>
           <a:prstGeom prst="rect">
@@ -5748,20 +5666,20 @@
                 </a:solidFill>
                 <a:latin typeface="Montserrat"/>
               </a:rPr>
-              <a:t>Izvēlas punktu kartē</a:t>
-            </a:r>
-          </a:p>
-        </p:txBody>
-      </p:sp>
-      <p:sp>
-        <p:nvSpPr>
-          <p:cNvPr id="16" name="TextBox 15"/>
+              <a:t>Uzreiz redz atlīdzību</a:t>
+            </a:r>
+          </a:p>
+        </p:txBody>
+      </p:sp>
+      <p:sp>
+        <p:nvSpPr>
+          <p:cNvPr id="14" name="TextBox 13"/>
           <p:cNvSpPr txBox="1"/>
           <p:nvPr/>
         </p:nvSpPr>
         <p:spPr>
           <a:xfrm>
-            <a:off x="1554480" y="4690872"/>
+            <a:off x="1554480" y="3703320"/>
             <a:ext cx="5669280" cy="365760"/>
           </a:xfrm>
           <a:prstGeom prst="rect">
@@ -5790,20 +5708,20 @@
                 </a:solidFill>
                 <a:latin typeface="Open Sans"/>
               </a:rPr>
-              <a:t>Tikai tur, kur atlīdzība &gt; degvielas izmaksas</a:t>
-            </a:r>
-          </a:p>
-        </p:txBody>
-      </p:sp>
-      <p:sp>
-        <p:nvSpPr>
-          <p:cNvPr id="17" name="Oval 16"/>
+              <a:t>Cik saņems un vai braukt atmaksājas — vēl pirms reģistrācijas</a:t>
+            </a:r>
+          </a:p>
+        </p:txBody>
+      </p:sp>
+      <p:sp>
+        <p:nvSpPr>
+          <p:cNvPr id="15" name="Oval 14"/>
           <p:cNvSpPr/>
           <p:nvPr/>
         </p:nvSpPr>
         <p:spPr>
           <a:xfrm>
-            <a:off x="640080" y="5294376"/>
+            <a:off x="640080" y="4306824"/>
             <a:ext cx="685800" cy="685800"/>
           </a:xfrm>
           <a:prstGeom prst="ellipse">
@@ -5841,13 +5759,13 @@
       </p:sp>
       <p:sp>
         <p:nvSpPr>
-          <p:cNvPr id="18" name="TextBox 17"/>
+          <p:cNvPr id="16" name="TextBox 15"/>
           <p:cNvSpPr txBox="1"/>
           <p:nvPr/>
         </p:nvSpPr>
         <p:spPr>
           <a:xfrm>
-            <a:off x="640080" y="5294376"/>
+            <a:off x="640080" y="4306824"/>
             <a:ext cx="685800" cy="685800"/>
           </a:xfrm>
           <a:prstGeom prst="rect">
@@ -5876,20 +5794,20 @@
                 </a:solidFill>
                 <a:latin typeface="Montserrat"/>
               </a:rPr>
-              <a:t>4</a:t>
-            </a:r>
-          </a:p>
-        </p:txBody>
-      </p:sp>
-      <p:sp>
-        <p:nvSpPr>
-          <p:cNvPr id="19" name="TextBox 18"/>
+              <a:t>3</a:t>
+            </a:r>
+          </a:p>
+        </p:txBody>
+      </p:sp>
+      <p:sp>
+        <p:nvSpPr>
+          <p:cNvPr id="17" name="TextBox 16"/>
           <p:cNvSpPr txBox="1"/>
           <p:nvPr/>
         </p:nvSpPr>
         <p:spPr>
           <a:xfrm>
-            <a:off x="1554480" y="5276088"/>
+            <a:off x="1554480" y="4288536"/>
             <a:ext cx="5669280" cy="457200"/>
           </a:xfrm>
           <a:prstGeom prst="rect">
@@ -5918,20 +5836,20 @@
                 </a:solidFill>
                 <a:latin typeface="Montserrat"/>
               </a:rPr>
-              <a:t>Nodod un saņem</a:t>
-            </a:r>
-          </a:p>
-        </p:txBody>
-      </p:sp>
-      <p:sp>
-        <p:nvSpPr>
-          <p:cNvPr id="20" name="TextBox 19"/>
+              <a:t>Izvēlas punktu kartē</a:t>
+            </a:r>
+          </a:p>
+        </p:txBody>
+      </p:sp>
+      <p:sp>
+        <p:nvSpPr>
+          <p:cNvPr id="18" name="TextBox 17"/>
           <p:cNvSpPr txBox="1"/>
           <p:nvPr/>
         </p:nvSpPr>
         <p:spPr>
           <a:xfrm>
-            <a:off x="1554480" y="5678424"/>
+            <a:off x="1554480" y="4690872"/>
             <a:ext cx="5669280" cy="365760"/>
           </a:xfrm>
           <a:prstGeom prst="rect">
@@ -5960,26 +5878,24 @@
                 </a:solidFill>
                 <a:latin typeface="Open Sans"/>
               </a:rPr>
-              <a:t>Nosver, pārbauda — atlīdzība kontā</a:t>
-            </a:r>
-          </a:p>
-        </p:txBody>
-      </p:sp>
-      <p:sp>
-        <p:nvSpPr>
-          <p:cNvPr id="21" name="Rounded Rectangle 20"/>
+              <a:t>Tikai tur, kur atlīdzība &gt; degvielas izmaksas</a:t>
+            </a:r>
+          </a:p>
+        </p:txBody>
+      </p:sp>
+      <p:sp>
+        <p:nvSpPr>
+          <p:cNvPr id="19" name="Oval 18"/>
           <p:cNvSpPr/>
           <p:nvPr/>
         </p:nvSpPr>
         <p:spPr>
           <a:xfrm>
-            <a:off x="7589520" y="548640"/>
-            <a:ext cx="3291840" cy="5760720"/>
-          </a:xfrm>
-          <a:prstGeom prst="roundRect">
-            <a:avLst>
-              <a:gd name="adj" fmla="val 8000"/>
-            </a:avLst>
+            <a:off x="640080" y="5294376"/>
+            <a:ext cx="685800" cy="685800"/>
+          </a:xfrm>
+          <a:prstGeom prst="ellipse">
+            <a:avLst/>
           </a:prstGeom>
           <a:solidFill>
             <a:srgbClr val="244A30"/>
@@ -6013,14 +5929,140 @@
       </p:sp>
       <p:sp>
         <p:nvSpPr>
-          <p:cNvPr id="22" name="Rounded Rectangle 21"/>
+          <p:cNvPr id="20" name="TextBox 19"/>
+          <p:cNvSpPr txBox="1"/>
+          <p:nvPr/>
+        </p:nvSpPr>
+        <p:spPr>
+          <a:xfrm>
+            <a:off x="640080" y="5294376"/>
+            <a:ext cx="685800" cy="685800"/>
+          </a:xfrm>
+          <a:prstGeom prst="rect">
+            <a:avLst/>
+          </a:prstGeom>
+          <a:noFill/>
+        </p:spPr>
+        <p:txBody>
+          <a:bodyPr wrap="square" anchor="ctr" lIns="0" rIns="0" tIns="0" bIns="0">
+            <a:spAutoFit/>
+          </a:bodyPr>
+          <a:lstStyle/>
+          <a:p>
+            <a:pPr algn="ctr">
+              <a:lnSpc>
+                <a:spcPct val="110000"/>
+              </a:lnSpc>
+              <a:spcAft>
+                <a:spcPts val="600"/>
+              </a:spcAft>
+            </a:pPr>
+            <a:r>
+              <a:rPr sz="2200" b="1">
+                <a:solidFill>
+                  <a:srgbClr val="FFFFFF"/>
+                </a:solidFill>
+                <a:latin typeface="Montserrat"/>
+              </a:rPr>
+              <a:t>4</a:t>
+            </a:r>
+          </a:p>
+        </p:txBody>
+      </p:sp>
+      <p:sp>
+        <p:nvSpPr>
+          <p:cNvPr id="21" name="TextBox 20"/>
+          <p:cNvSpPr txBox="1"/>
+          <p:nvPr/>
+        </p:nvSpPr>
+        <p:spPr>
+          <a:xfrm>
+            <a:off x="1554480" y="5276088"/>
+            <a:ext cx="5669280" cy="457200"/>
+          </a:xfrm>
+          <a:prstGeom prst="rect">
+            <a:avLst/>
+          </a:prstGeom>
+          <a:noFill/>
+        </p:spPr>
+        <p:txBody>
+          <a:bodyPr wrap="square" anchor="t" lIns="0" rIns="0" tIns="0" bIns="0">
+            <a:spAutoFit/>
+          </a:bodyPr>
+          <a:lstStyle/>
+          <a:p>
+            <a:pPr algn="l">
+              <a:lnSpc>
+                <a:spcPct val="110000"/>
+              </a:lnSpc>
+              <a:spcAft>
+                <a:spcPts val="600"/>
+              </a:spcAft>
+            </a:pPr>
+            <a:r>
+              <a:rPr sz="2100" b="1">
+                <a:solidFill>
+                  <a:srgbClr val="1C261E"/>
+                </a:solidFill>
+                <a:latin typeface="Montserrat"/>
+              </a:rPr>
+              <a:t>Nodod un saņem</a:t>
+            </a:r>
+          </a:p>
+        </p:txBody>
+      </p:sp>
+      <p:sp>
+        <p:nvSpPr>
+          <p:cNvPr id="22" name="TextBox 21"/>
+          <p:cNvSpPr txBox="1"/>
+          <p:nvPr/>
+        </p:nvSpPr>
+        <p:spPr>
+          <a:xfrm>
+            <a:off x="1554480" y="5678424"/>
+            <a:ext cx="5669280" cy="365760"/>
+          </a:xfrm>
+          <a:prstGeom prst="rect">
+            <a:avLst/>
+          </a:prstGeom>
+          <a:noFill/>
+        </p:spPr>
+        <p:txBody>
+          <a:bodyPr wrap="square" anchor="t" lIns="0" rIns="0" tIns="0" bIns="0">
+            <a:spAutoFit/>
+          </a:bodyPr>
+          <a:lstStyle/>
+          <a:p>
+            <a:pPr algn="l">
+              <a:lnSpc>
+                <a:spcPct val="110000"/>
+              </a:lnSpc>
+              <a:spcAft>
+                <a:spcPts val="600"/>
+              </a:spcAft>
+            </a:pPr>
+            <a:r>
+              <a:rPr sz="1400" b="0">
+                <a:solidFill>
+                  <a:srgbClr val="5B665D"/>
+                </a:solidFill>
+                <a:latin typeface="Open Sans"/>
+              </a:rPr>
+              <a:t>Nosver, pārbauda — atlīdzība kontā</a:t>
+            </a:r>
+          </a:p>
+        </p:txBody>
+      </p:sp>
+      <p:sp>
+        <p:nvSpPr>
+          <p:cNvPr id="23" name="Rounded Rectangle 22"/>
           <p:cNvSpPr/>
           <p:nvPr/>
         </p:nvSpPr>
         <p:spPr>
           <a:xfrm>
-            <a:off x="7726679" y="685800"/>
-            <a:ext cx="3017520" cy="5486400"/>
+            <a:off x="7589520" y="548640"/>
+            <a:ext cx="3291840" cy="5760720"/>
           </a:xfrm>
           <a:prstGeom prst="roundRect">
             <a:avLst>
@@ -6028,7 +6070,7 @@
             </a:avLst>
           </a:prstGeom>
           <a:solidFill>
-            <a:srgbClr val="CFE0C8"/>
+            <a:srgbClr val="244A30"/>
           </a:solidFill>
           <a:ln>
             <a:noFill/>
@@ -6059,7 +6101,53 @@
       </p:sp>
       <p:sp>
         <p:nvSpPr>
-          <p:cNvPr id="23" name="TextBox 22"/>
+          <p:cNvPr id="24" name="Rounded Rectangle 23"/>
+          <p:cNvSpPr/>
+          <p:nvPr/>
+        </p:nvSpPr>
+        <p:spPr>
+          <a:xfrm>
+            <a:off x="7726679" y="685800"/>
+            <a:ext cx="3017520" cy="5486400"/>
+          </a:xfrm>
+          <a:prstGeom prst="roundRect">
+            <a:avLst>
+              <a:gd name="adj" fmla="val 8000"/>
+            </a:avLst>
+          </a:prstGeom>
+          <a:solidFill>
+            <a:srgbClr val="CFE0C8"/>
+          </a:solidFill>
+          <a:ln>
+            <a:noFill/>
+          </a:ln>
+          <a:effectLst/>
+        </p:spPr>
+        <p:style>
+          <a:lnRef idx="1">
+            <a:schemeClr val="accent1"/>
+          </a:lnRef>
+          <a:fillRef idx="3">
+            <a:schemeClr val="accent1"/>
+          </a:fillRef>
+          <a:effectRef idx="2">
+            <a:schemeClr val="accent1"/>
+          </a:effectRef>
+          <a:fontRef idx="minor">
+            <a:schemeClr val="lt1"/>
+          </a:fontRef>
+        </p:style>
+        <p:txBody>
+          <a:bodyPr rtlCol="0" anchor="ctr"/>
+          <a:lstStyle/>
+          <a:p>
+            <a:pPr algn="ctr"/>
+          </a:p>
+        </p:txBody>
+      </p:sp>
+      <p:sp>
+        <p:nvSpPr>
+          <p:cNvPr id="25" name="TextBox 24"/>
           <p:cNvSpPr txBox="1"/>
           <p:nvPr/>
         </p:nvSpPr>
@@ -6242,21 +6330,189 @@
                 </a:solidFill>
                 <a:latin typeface="Montserrat"/>
               </a:rPr>
-              <a:t>Izdevīgi, nevis tikai pareizi</a:t>
-            </a:r>
-          </a:p>
-        </p:txBody>
-      </p:sp>
-      <p:sp>
-        <p:nvSpPr>
-          <p:cNvPr id="4" name="Rounded Rectangle 3"/>
+              <a:t>Annas iespējas šodien</a:t>
+            </a:r>
+          </a:p>
+        </p:txBody>
+      </p:sp>
+      <p:sp>
+        <p:nvSpPr>
+          <p:cNvPr id="4" name="TextBox 3"/>
+          <p:cNvSpPr txBox="1"/>
+          <p:nvPr/>
+        </p:nvSpPr>
+        <p:spPr>
+          <a:xfrm>
+            <a:off x="3931920" y="1874519"/>
+            <a:ext cx="1920240" cy="320040"/>
+          </a:xfrm>
+          <a:prstGeom prst="rect">
+            <a:avLst/>
+          </a:prstGeom>
+          <a:noFill/>
+        </p:spPr>
+        <p:txBody>
+          <a:bodyPr wrap="square" anchor="t" lIns="0" rIns="0" tIns="0" bIns="0">
+            <a:spAutoFit/>
+          </a:bodyPr>
+          <a:lstStyle/>
+          <a:p>
+            <a:pPr algn="l">
+              <a:lnSpc>
+                <a:spcPct val="110000"/>
+              </a:lnSpc>
+              <a:spcAft>
+                <a:spcPts val="600"/>
+              </a:spcAft>
+            </a:pPr>
+            <a:r>
+              <a:rPr sz="1300" b="1">
+                <a:solidFill>
+                  <a:srgbClr val="5B665D"/>
+                </a:solidFill>
+                <a:latin typeface="Montserrat"/>
+              </a:rPr>
+              <a:t>Bez maksas</a:t>
+            </a:r>
+          </a:p>
+        </p:txBody>
+      </p:sp>
+      <p:sp>
+        <p:nvSpPr>
+          <p:cNvPr id="5" name="TextBox 4"/>
+          <p:cNvSpPr txBox="1"/>
+          <p:nvPr/>
+        </p:nvSpPr>
+        <p:spPr>
+          <a:xfrm>
+            <a:off x="5852160" y="1874519"/>
+            <a:ext cx="1920240" cy="320040"/>
+          </a:xfrm>
+          <a:prstGeom prst="rect">
+            <a:avLst/>
+          </a:prstGeom>
+          <a:noFill/>
+        </p:spPr>
+        <p:txBody>
+          <a:bodyPr wrap="square" anchor="t" lIns="0" rIns="0" tIns="0" bIns="0">
+            <a:spAutoFit/>
+          </a:bodyPr>
+          <a:lstStyle/>
+          <a:p>
+            <a:pPr algn="l">
+              <a:lnSpc>
+                <a:spcPct val="110000"/>
+              </a:lnSpc>
+              <a:spcAft>
+                <a:spcPts val="600"/>
+              </a:spcAft>
+            </a:pPr>
+            <a:r>
+              <a:rPr sz="1300" b="1">
+                <a:solidFill>
+                  <a:srgbClr val="5B665D"/>
+                </a:solidFill>
+                <a:latin typeface="Montserrat"/>
+              </a:rPr>
+              <a:t>Ērti</a:t>
+            </a:r>
+          </a:p>
+        </p:txBody>
+      </p:sp>
+      <p:sp>
+        <p:nvSpPr>
+          <p:cNvPr id="6" name="TextBox 5"/>
+          <p:cNvSpPr txBox="1"/>
+          <p:nvPr/>
+        </p:nvSpPr>
+        <p:spPr>
+          <a:xfrm>
+            <a:off x="8001000" y="1874519"/>
+            <a:ext cx="1920240" cy="320040"/>
+          </a:xfrm>
+          <a:prstGeom prst="rect">
+            <a:avLst/>
+          </a:prstGeom>
+          <a:noFill/>
+        </p:spPr>
+        <p:txBody>
+          <a:bodyPr wrap="square" anchor="t" lIns="0" rIns="0" tIns="0" bIns="0">
+            <a:spAutoFit/>
+          </a:bodyPr>
+          <a:lstStyle/>
+          <a:p>
+            <a:pPr algn="l">
+              <a:lnSpc>
+                <a:spcPct val="110000"/>
+              </a:lnSpc>
+              <a:spcAft>
+                <a:spcPts val="600"/>
+              </a:spcAft>
+            </a:pPr>
+            <a:r>
+              <a:rPr sz="1300" b="1">
+                <a:solidFill>
+                  <a:srgbClr val="5B665D"/>
+                </a:solidFill>
+                <a:latin typeface="Montserrat"/>
+              </a:rPr>
+              <a:t>Atlīdzība</a:t>
+            </a:r>
+          </a:p>
+        </p:txBody>
+      </p:sp>
+      <p:sp>
+        <p:nvSpPr>
+          <p:cNvPr id="7" name="TextBox 6"/>
+          <p:cNvSpPr txBox="1"/>
+          <p:nvPr/>
+        </p:nvSpPr>
+        <p:spPr>
+          <a:xfrm>
+            <a:off x="9692640" y="1874519"/>
+            <a:ext cx="1920240" cy="320040"/>
+          </a:xfrm>
+          <a:prstGeom prst="rect">
+            <a:avLst/>
+          </a:prstGeom>
+          <a:noFill/>
+        </p:spPr>
+        <p:txBody>
+          <a:bodyPr wrap="square" anchor="t" lIns="0" rIns="0" tIns="0" bIns="0">
+            <a:spAutoFit/>
+          </a:bodyPr>
+          <a:lstStyle/>
+          <a:p>
+            <a:pPr algn="l">
+              <a:lnSpc>
+                <a:spcPct val="110000"/>
+              </a:lnSpc>
+              <a:spcAft>
+                <a:spcPts val="600"/>
+              </a:spcAft>
+            </a:pPr>
+            <a:r>
+              <a:rPr sz="1300" b="1">
+                <a:solidFill>
+                  <a:srgbClr val="5B665D"/>
+                </a:solidFill>
+                <a:latin typeface="Montserrat"/>
+              </a:rPr>
+              <a:t>Nonāk pārstrādē</a:t>
+            </a:r>
+          </a:p>
+        </p:txBody>
+      </p:sp>
+      <p:sp>
+        <p:nvSpPr>
+          <p:cNvPr id="8" name="Rounded Rectangle 7"/>
           <p:cNvSpPr/>
           <p:nvPr/>
         </p:nvSpPr>
         <p:spPr>
           <a:xfrm>
-            <a:off x="640080" y="1965960"/>
-            <a:ext cx="5349240" cy="1280160"/>
+            <a:off x="640080" y="2286000"/>
+            <a:ext cx="10927080" cy="603504"/>
           </a:xfrm>
           <a:prstGeom prst="roundRect">
             <a:avLst>
@@ -6295,20 +6551,232 @@
       </p:sp>
       <p:sp>
         <p:nvSpPr>
-          <p:cNvPr id="5" name="Oval 4"/>
+          <p:cNvPr id="9" name="TextBox 8"/>
+          <p:cNvSpPr txBox="1"/>
+          <p:nvPr/>
+        </p:nvSpPr>
+        <p:spPr>
+          <a:xfrm>
+            <a:off x="868680" y="2286000"/>
+            <a:ext cx="3017520" cy="603504"/>
+          </a:xfrm>
+          <a:prstGeom prst="rect">
+            <a:avLst/>
+          </a:prstGeom>
+          <a:noFill/>
+        </p:spPr>
+        <p:txBody>
+          <a:bodyPr wrap="square" anchor="ctr" lIns="0" rIns="0" tIns="0" bIns="0">
+            <a:spAutoFit/>
+          </a:bodyPr>
+          <a:lstStyle/>
+          <a:p>
+            <a:pPr algn="l">
+              <a:lnSpc>
+                <a:spcPct val="110000"/>
+              </a:lnSpc>
+              <a:spcAft>
+                <a:spcPts val="600"/>
+              </a:spcAft>
+            </a:pPr>
+            <a:r>
+              <a:rPr sz="1600" b="1">
+                <a:solidFill>
+                  <a:srgbClr val="1C261E"/>
+                </a:solidFill>
+                <a:latin typeface="Montserrat"/>
+              </a:rPr>
+              <a:t>Sludinājums „izvedam lēti”</a:t>
+            </a:r>
+          </a:p>
+        </p:txBody>
+      </p:sp>
+      <p:sp>
+        <p:nvSpPr>
+          <p:cNvPr id="10" name="TextBox 9"/>
+          <p:cNvSpPr txBox="1"/>
+          <p:nvPr/>
+        </p:nvSpPr>
+        <p:spPr>
+          <a:xfrm>
+            <a:off x="3931920" y="2286000"/>
+            <a:ext cx="2011680" cy="603504"/>
+          </a:xfrm>
+          <a:prstGeom prst="rect">
+            <a:avLst/>
+          </a:prstGeom>
+          <a:noFill/>
+        </p:spPr>
+        <p:txBody>
+          <a:bodyPr wrap="square" anchor="ctr" lIns="0" rIns="0" tIns="0" bIns="0">
+            <a:spAutoFit/>
+          </a:bodyPr>
+          <a:lstStyle/>
+          <a:p>
+            <a:pPr algn="l">
+              <a:lnSpc>
+                <a:spcPct val="110000"/>
+              </a:lnSpc>
+              <a:spcAft>
+                <a:spcPts val="600"/>
+              </a:spcAft>
+            </a:pPr>
+            <a:r>
+              <a:rPr sz="1500" b="0">
+                <a:solidFill>
+                  <a:srgbClr val="5B665D"/>
+                </a:solidFill>
+                <a:latin typeface="Open Sans"/>
+              </a:rPr>
+              <a:t>Lēti</a:t>
+            </a:r>
+          </a:p>
+        </p:txBody>
+      </p:sp>
+      <p:sp>
+        <p:nvSpPr>
+          <p:cNvPr id="11" name="TextBox 10"/>
+          <p:cNvSpPr txBox="1"/>
+          <p:nvPr/>
+        </p:nvSpPr>
+        <p:spPr>
+          <a:xfrm>
+            <a:off x="5852160" y="2286000"/>
+            <a:ext cx="2011680" cy="603504"/>
+          </a:xfrm>
+          <a:prstGeom prst="rect">
+            <a:avLst/>
+          </a:prstGeom>
+          <a:noFill/>
+        </p:spPr>
+        <p:txBody>
+          <a:bodyPr wrap="square" anchor="ctr" lIns="0" rIns="0" tIns="0" bIns="0">
+            <a:spAutoFit/>
+          </a:bodyPr>
+          <a:lstStyle/>
+          <a:p>
+            <a:pPr algn="l">
+              <a:lnSpc>
+                <a:spcPct val="110000"/>
+              </a:lnSpc>
+              <a:spcAft>
+                <a:spcPts val="600"/>
+              </a:spcAft>
+            </a:pPr>
+            <a:r>
+              <a:rPr sz="1500" b="1">
+                <a:solidFill>
+                  <a:srgbClr val="5E8C5A"/>
+                </a:solidFill>
+                <a:latin typeface="Open Sans"/>
+              </a:rPr>
+              <a:t>Jā</a:t>
+            </a:r>
+          </a:p>
+        </p:txBody>
+      </p:sp>
+      <p:sp>
+        <p:nvSpPr>
+          <p:cNvPr id="12" name="TextBox 11"/>
+          <p:cNvSpPr txBox="1"/>
+          <p:nvPr/>
+        </p:nvSpPr>
+        <p:spPr>
+          <a:xfrm>
+            <a:off x="8001000" y="2286000"/>
+            <a:ext cx="2011680" cy="603504"/>
+          </a:xfrm>
+          <a:prstGeom prst="rect">
+            <a:avLst/>
+          </a:prstGeom>
+          <a:noFill/>
+        </p:spPr>
+        <p:txBody>
+          <a:bodyPr wrap="square" anchor="ctr" lIns="0" rIns="0" tIns="0" bIns="0">
+            <a:spAutoFit/>
+          </a:bodyPr>
+          <a:lstStyle/>
+          <a:p>
+            <a:pPr algn="l">
+              <a:lnSpc>
+                <a:spcPct val="110000"/>
+              </a:lnSpc>
+              <a:spcAft>
+                <a:spcPts val="600"/>
+              </a:spcAft>
+            </a:pPr>
+            <a:r>
+              <a:rPr sz="1500" b="1">
+                <a:solidFill>
+                  <a:srgbClr val="B04A3A"/>
+                </a:solidFill>
+                <a:latin typeface="Open Sans"/>
+              </a:rPr>
+              <a:t>Nē</a:t>
+            </a:r>
+          </a:p>
+        </p:txBody>
+      </p:sp>
+      <p:sp>
+        <p:nvSpPr>
+          <p:cNvPr id="13" name="TextBox 12"/>
+          <p:cNvSpPr txBox="1"/>
+          <p:nvPr/>
+        </p:nvSpPr>
+        <p:spPr>
+          <a:xfrm>
+            <a:off x="9692640" y="2286000"/>
+            <a:ext cx="2011680" cy="603504"/>
+          </a:xfrm>
+          <a:prstGeom prst="rect">
+            <a:avLst/>
+          </a:prstGeom>
+          <a:noFill/>
+        </p:spPr>
+        <p:txBody>
+          <a:bodyPr wrap="square" anchor="ctr" lIns="0" rIns="0" tIns="0" bIns="0">
+            <a:spAutoFit/>
+          </a:bodyPr>
+          <a:lstStyle/>
+          <a:p>
+            <a:pPr algn="l">
+              <a:lnSpc>
+                <a:spcPct val="110000"/>
+              </a:lnSpc>
+              <a:spcAft>
+                <a:spcPts val="600"/>
+              </a:spcAft>
+            </a:pPr>
+            <a:r>
+              <a:rPr sz="1500" b="1">
+                <a:solidFill>
+                  <a:srgbClr val="B04A3A"/>
+                </a:solidFill>
+                <a:latin typeface="Open Sans"/>
+              </a:rPr>
+              <a:t>Bieži mežā</a:t>
+            </a:r>
+          </a:p>
+        </p:txBody>
+      </p:sp>
+      <p:sp>
+        <p:nvSpPr>
+          <p:cNvPr id="14" name="Rounded Rectangle 13"/>
           <p:cNvSpPr/>
           <p:nvPr/>
         </p:nvSpPr>
         <p:spPr>
           <a:xfrm>
-            <a:off x="914400" y="2240279"/>
-            <a:ext cx="731520" cy="731520"/>
-          </a:xfrm>
-          <a:prstGeom prst="ellipse">
-            <a:avLst/>
+            <a:off x="640080" y="2999232"/>
+            <a:ext cx="10927080" cy="603504"/>
+          </a:xfrm>
+          <a:prstGeom prst="roundRect">
+            <a:avLst>
+              <a:gd name="adj" fmla="val 8000"/>
+            </a:avLst>
           </a:prstGeom>
           <a:solidFill>
-            <a:srgbClr val="244A30"/>
+            <a:srgbClr val="FFFFFF"/>
           </a:solidFill>
           <a:ln>
             <a:noFill/>
@@ -6339,14 +6807,14 @@
       </p:sp>
       <p:sp>
         <p:nvSpPr>
-          <p:cNvPr id="6" name="TextBox 5"/>
+          <p:cNvPr id="15" name="TextBox 14"/>
           <p:cNvSpPr txBox="1"/>
           <p:nvPr/>
         </p:nvSpPr>
         <p:spPr>
           <a:xfrm>
-            <a:off x="914400" y="2240279"/>
-            <a:ext cx="731520" cy="731520"/>
+            <a:off x="868680" y="2999232"/>
+            <a:ext cx="3017520" cy="603504"/>
           </a:xfrm>
           <a:prstGeom prst="rect">
             <a:avLst/>
@@ -6355,48 +6823,6 @@
         </p:spPr>
         <p:txBody>
           <a:bodyPr wrap="square" anchor="ctr" lIns="0" rIns="0" tIns="0" bIns="0">
-            <a:spAutoFit/>
-          </a:bodyPr>
-          <a:lstStyle/>
-          <a:p>
-            <a:pPr algn="ctr">
-              <a:lnSpc>
-                <a:spcPct val="110000"/>
-              </a:lnSpc>
-              <a:spcAft>
-                <a:spcPts val="600"/>
-              </a:spcAft>
-            </a:pPr>
-            <a:r>
-              <a:rPr sz="2200" b="1">
-                <a:solidFill>
-                  <a:srgbClr val="FFFFFF"/>
-                </a:solidFill>
-                <a:latin typeface="Montserrat"/>
-              </a:rPr>
-              <a:t>1</a:t>
-            </a:r>
-          </a:p>
-        </p:txBody>
-      </p:sp>
-      <p:sp>
-        <p:nvSpPr>
-          <p:cNvPr id="7" name="TextBox 6"/>
-          <p:cNvSpPr txBox="1"/>
-          <p:nvPr/>
-        </p:nvSpPr>
-        <p:spPr>
-          <a:xfrm>
-            <a:off x="1874519" y="2167128"/>
-            <a:ext cx="3931920" cy="457200"/>
-          </a:xfrm>
-          <a:prstGeom prst="rect">
-            <a:avLst/>
-          </a:prstGeom>
-          <a:noFill/>
-        </p:spPr>
-        <p:txBody>
-          <a:bodyPr wrap="square" anchor="t" lIns="0" rIns="0" tIns="0" bIns="0">
             <a:spAutoFit/>
           </a:bodyPr>
           <a:lstStyle/>
@@ -6410,27 +6836,27 @@
               </a:spcAft>
             </a:pPr>
             <a:r>
-              <a:rPr sz="2000" b="1">
+              <a:rPr sz="1600" b="1">
                 <a:solidFill>
                   <a:srgbClr val="1C261E"/>
                 </a:solidFill>
                 <a:latin typeface="Montserrat"/>
               </a:rPr>
-              <a:t>Izdevīgi</a:t>
-            </a:r>
-          </a:p>
-        </p:txBody>
-      </p:sp>
-      <p:sp>
-        <p:nvSpPr>
-          <p:cNvPr id="8" name="TextBox 7"/>
+              <a:t>Konteinera noma</a:t>
+            </a:r>
+          </a:p>
+        </p:txBody>
+      </p:sp>
+      <p:sp>
+        <p:nvSpPr>
+          <p:cNvPr id="16" name="TextBox 15"/>
           <p:cNvSpPr txBox="1"/>
           <p:nvPr/>
         </p:nvSpPr>
         <p:spPr>
           <a:xfrm>
-            <a:off x="1874519" y="2606039"/>
-            <a:ext cx="3931920" cy="548640"/>
+            <a:off x="3931920" y="2999232"/>
+            <a:ext cx="2011680" cy="603504"/>
           </a:xfrm>
           <a:prstGeom prst="rect">
             <a:avLst/>
@@ -6438,7 +6864,7 @@
           <a:noFill/>
         </p:spPr>
         <p:txBody>
-          <a:bodyPr wrap="square" anchor="t" lIns="0" rIns="0" tIns="0" bIns="0">
+          <a:bodyPr wrap="square" anchor="ctr" lIns="0" rIns="0" tIns="0" bIns="0">
             <a:spAutoFit/>
           </a:bodyPr>
           <a:lstStyle/>
@@ -6452,27 +6878,153 @@
               </a:spcAft>
             </a:pPr>
             <a:r>
-              <a:rPr sz="1400" b="0">
-                <a:solidFill>
-                  <a:srgbClr val="5B665D"/>
+              <a:rPr sz="1500" b="1">
+                <a:solidFill>
+                  <a:srgbClr val="B04A3A"/>
                 </a:solidFill>
                 <a:latin typeface="Open Sans"/>
               </a:rPr>
-              <a:t>Nepaļaujamies uz apziņu — legālais ceļš kļūst lētāks par mežu</a:t>
-            </a:r>
-          </a:p>
-        </p:txBody>
-      </p:sp>
-      <p:sp>
-        <p:nvSpPr>
-          <p:cNvPr id="9" name="Rounded Rectangle 8"/>
+              <a:t>Dārgi</a:t>
+            </a:r>
+          </a:p>
+        </p:txBody>
+      </p:sp>
+      <p:sp>
+        <p:nvSpPr>
+          <p:cNvPr id="17" name="TextBox 16"/>
+          <p:cNvSpPr txBox="1"/>
+          <p:nvPr/>
+        </p:nvSpPr>
+        <p:spPr>
+          <a:xfrm>
+            <a:off x="5852160" y="2999232"/>
+            <a:ext cx="2011680" cy="603504"/>
+          </a:xfrm>
+          <a:prstGeom prst="rect">
+            <a:avLst/>
+          </a:prstGeom>
+          <a:noFill/>
+        </p:spPr>
+        <p:txBody>
+          <a:bodyPr wrap="square" anchor="ctr" lIns="0" rIns="0" tIns="0" bIns="0">
+            <a:spAutoFit/>
+          </a:bodyPr>
+          <a:lstStyle/>
+          <a:p>
+            <a:pPr algn="l">
+              <a:lnSpc>
+                <a:spcPct val="110000"/>
+              </a:lnSpc>
+              <a:spcAft>
+                <a:spcPts val="600"/>
+              </a:spcAft>
+            </a:pPr>
+            <a:r>
+              <a:rPr sz="1500" b="1">
+                <a:solidFill>
+                  <a:srgbClr val="5E8C5A"/>
+                </a:solidFill>
+                <a:latin typeface="Open Sans"/>
+              </a:rPr>
+              <a:t>Jā</a:t>
+            </a:r>
+          </a:p>
+        </p:txBody>
+      </p:sp>
+      <p:sp>
+        <p:nvSpPr>
+          <p:cNvPr id="18" name="TextBox 17"/>
+          <p:cNvSpPr txBox="1"/>
+          <p:nvPr/>
+        </p:nvSpPr>
+        <p:spPr>
+          <a:xfrm>
+            <a:off x="8001000" y="2999232"/>
+            <a:ext cx="2011680" cy="603504"/>
+          </a:xfrm>
+          <a:prstGeom prst="rect">
+            <a:avLst/>
+          </a:prstGeom>
+          <a:noFill/>
+        </p:spPr>
+        <p:txBody>
+          <a:bodyPr wrap="square" anchor="ctr" lIns="0" rIns="0" tIns="0" bIns="0">
+            <a:spAutoFit/>
+          </a:bodyPr>
+          <a:lstStyle/>
+          <a:p>
+            <a:pPr algn="l">
+              <a:lnSpc>
+                <a:spcPct val="110000"/>
+              </a:lnSpc>
+              <a:spcAft>
+                <a:spcPts val="600"/>
+              </a:spcAft>
+            </a:pPr>
+            <a:r>
+              <a:rPr sz="1500" b="1">
+                <a:solidFill>
+                  <a:srgbClr val="B04A3A"/>
+                </a:solidFill>
+                <a:latin typeface="Open Sans"/>
+              </a:rPr>
+              <a:t>Nē</a:t>
+            </a:r>
+          </a:p>
+        </p:txBody>
+      </p:sp>
+      <p:sp>
+        <p:nvSpPr>
+          <p:cNvPr id="19" name="TextBox 18"/>
+          <p:cNvSpPr txBox="1"/>
+          <p:nvPr/>
+        </p:nvSpPr>
+        <p:spPr>
+          <a:xfrm>
+            <a:off x="9692640" y="2999232"/>
+            <a:ext cx="2011680" cy="603504"/>
+          </a:xfrm>
+          <a:prstGeom prst="rect">
+            <a:avLst/>
+          </a:prstGeom>
+          <a:noFill/>
+        </p:spPr>
+        <p:txBody>
+          <a:bodyPr wrap="square" anchor="ctr" lIns="0" rIns="0" tIns="0" bIns="0">
+            <a:spAutoFit/>
+          </a:bodyPr>
+          <a:lstStyle/>
+          <a:p>
+            <a:pPr algn="l">
+              <a:lnSpc>
+                <a:spcPct val="110000"/>
+              </a:lnSpc>
+              <a:spcAft>
+                <a:spcPts val="600"/>
+              </a:spcAft>
+            </a:pPr>
+            <a:r>
+              <a:rPr sz="1500" b="1">
+                <a:solidFill>
+                  <a:srgbClr val="5E8C5A"/>
+                </a:solidFill>
+                <a:latin typeface="Open Sans"/>
+              </a:rPr>
+              <a:t>Jā</a:t>
+            </a:r>
+          </a:p>
+        </p:txBody>
+      </p:sp>
+      <p:sp>
+        <p:nvSpPr>
+          <p:cNvPr id="20" name="Rounded Rectangle 19"/>
           <p:cNvSpPr/>
           <p:nvPr/>
         </p:nvSpPr>
         <p:spPr>
           <a:xfrm>
-            <a:off x="6172200" y="1965960"/>
-            <a:ext cx="5349240" cy="1280160"/>
+            <a:off x="640080" y="3712464"/>
+            <a:ext cx="10927080" cy="603504"/>
           </a:xfrm>
           <a:prstGeom prst="roundRect">
             <a:avLst>
@@ -6511,17 +7063,229 @@
       </p:sp>
       <p:sp>
         <p:nvSpPr>
-          <p:cNvPr id="10" name="Oval 9"/>
+          <p:cNvPr id="21" name="TextBox 20"/>
+          <p:cNvSpPr txBox="1"/>
+          <p:nvPr/>
+        </p:nvSpPr>
+        <p:spPr>
+          <a:xfrm>
+            <a:off x="868680" y="3712464"/>
+            <a:ext cx="3017520" cy="603504"/>
+          </a:xfrm>
+          <a:prstGeom prst="rect">
+            <a:avLst/>
+          </a:prstGeom>
+          <a:noFill/>
+        </p:spPr>
+        <p:txBody>
+          <a:bodyPr wrap="square" anchor="ctr" lIns="0" rIns="0" tIns="0" bIns="0">
+            <a:spAutoFit/>
+          </a:bodyPr>
+          <a:lstStyle/>
+          <a:p>
+            <a:pPr algn="l">
+              <a:lnSpc>
+                <a:spcPct val="110000"/>
+              </a:lnSpc>
+              <a:spcAft>
+                <a:spcPts val="600"/>
+              </a:spcAft>
+            </a:pPr>
+            <a:r>
+              <a:rPr sz="1600" b="1">
+                <a:solidFill>
+                  <a:srgbClr val="1C261E"/>
+                </a:solidFill>
+                <a:latin typeface="Montserrat"/>
+              </a:rPr>
+              <a:t>Šķirošanas laukums</a:t>
+            </a:r>
+          </a:p>
+        </p:txBody>
+      </p:sp>
+      <p:sp>
+        <p:nvSpPr>
+          <p:cNvPr id="22" name="TextBox 21"/>
+          <p:cNvSpPr txBox="1"/>
+          <p:nvPr/>
+        </p:nvSpPr>
+        <p:spPr>
+          <a:xfrm>
+            <a:off x="3931920" y="3712464"/>
+            <a:ext cx="2011680" cy="603504"/>
+          </a:xfrm>
+          <a:prstGeom prst="rect">
+            <a:avLst/>
+          </a:prstGeom>
+          <a:noFill/>
+        </p:spPr>
+        <p:txBody>
+          <a:bodyPr wrap="square" anchor="ctr" lIns="0" rIns="0" tIns="0" bIns="0">
+            <a:spAutoFit/>
+          </a:bodyPr>
+          <a:lstStyle/>
+          <a:p>
+            <a:pPr algn="l">
+              <a:lnSpc>
+                <a:spcPct val="110000"/>
+              </a:lnSpc>
+              <a:spcAft>
+                <a:spcPts val="600"/>
+              </a:spcAft>
+            </a:pPr>
+            <a:r>
+              <a:rPr sz="1500" b="0">
+                <a:solidFill>
+                  <a:srgbClr val="5B665D"/>
+                </a:solidFill>
+                <a:latin typeface="Open Sans"/>
+              </a:rPr>
+              <a:t>Daļēji</a:t>
+            </a:r>
+          </a:p>
+        </p:txBody>
+      </p:sp>
+      <p:sp>
+        <p:nvSpPr>
+          <p:cNvPr id="23" name="TextBox 22"/>
+          <p:cNvSpPr txBox="1"/>
+          <p:nvPr/>
+        </p:nvSpPr>
+        <p:spPr>
+          <a:xfrm>
+            <a:off x="5852160" y="3712464"/>
+            <a:ext cx="2011680" cy="603504"/>
+          </a:xfrm>
+          <a:prstGeom prst="rect">
+            <a:avLst/>
+          </a:prstGeom>
+          <a:noFill/>
+        </p:spPr>
+        <p:txBody>
+          <a:bodyPr wrap="square" anchor="ctr" lIns="0" rIns="0" tIns="0" bIns="0">
+            <a:spAutoFit/>
+          </a:bodyPr>
+          <a:lstStyle/>
+          <a:p>
+            <a:pPr algn="l">
+              <a:lnSpc>
+                <a:spcPct val="110000"/>
+              </a:lnSpc>
+              <a:spcAft>
+                <a:spcPts val="600"/>
+              </a:spcAft>
+            </a:pPr>
+            <a:r>
+              <a:rPr sz="1500" b="0">
+                <a:solidFill>
+                  <a:srgbClr val="5B665D"/>
+                </a:solidFill>
+                <a:latin typeface="Open Sans"/>
+              </a:rPr>
+              <a:t>Jāved pašam</a:t>
+            </a:r>
+          </a:p>
+        </p:txBody>
+      </p:sp>
+      <p:sp>
+        <p:nvSpPr>
+          <p:cNvPr id="24" name="TextBox 23"/>
+          <p:cNvSpPr txBox="1"/>
+          <p:nvPr/>
+        </p:nvSpPr>
+        <p:spPr>
+          <a:xfrm>
+            <a:off x="8001000" y="3712464"/>
+            <a:ext cx="2011680" cy="603504"/>
+          </a:xfrm>
+          <a:prstGeom prst="rect">
+            <a:avLst/>
+          </a:prstGeom>
+          <a:noFill/>
+        </p:spPr>
+        <p:txBody>
+          <a:bodyPr wrap="square" anchor="ctr" lIns="0" rIns="0" tIns="0" bIns="0">
+            <a:spAutoFit/>
+          </a:bodyPr>
+          <a:lstStyle/>
+          <a:p>
+            <a:pPr algn="l">
+              <a:lnSpc>
+                <a:spcPct val="110000"/>
+              </a:lnSpc>
+              <a:spcAft>
+                <a:spcPts val="600"/>
+              </a:spcAft>
+            </a:pPr>
+            <a:r>
+              <a:rPr sz="1500" b="1">
+                <a:solidFill>
+                  <a:srgbClr val="B04A3A"/>
+                </a:solidFill>
+                <a:latin typeface="Open Sans"/>
+              </a:rPr>
+              <a:t>Nē</a:t>
+            </a:r>
+          </a:p>
+        </p:txBody>
+      </p:sp>
+      <p:sp>
+        <p:nvSpPr>
+          <p:cNvPr id="25" name="TextBox 24"/>
+          <p:cNvSpPr txBox="1"/>
+          <p:nvPr/>
+        </p:nvSpPr>
+        <p:spPr>
+          <a:xfrm>
+            <a:off x="9692640" y="3712464"/>
+            <a:ext cx="2011680" cy="603504"/>
+          </a:xfrm>
+          <a:prstGeom prst="rect">
+            <a:avLst/>
+          </a:prstGeom>
+          <a:noFill/>
+        </p:spPr>
+        <p:txBody>
+          <a:bodyPr wrap="square" anchor="ctr" lIns="0" rIns="0" tIns="0" bIns="0">
+            <a:spAutoFit/>
+          </a:bodyPr>
+          <a:lstStyle/>
+          <a:p>
+            <a:pPr algn="l">
+              <a:lnSpc>
+                <a:spcPct val="110000"/>
+              </a:lnSpc>
+              <a:spcAft>
+                <a:spcPts val="600"/>
+              </a:spcAft>
+            </a:pPr>
+            <a:r>
+              <a:rPr sz="1500" b="1">
+                <a:solidFill>
+                  <a:srgbClr val="5E8C5A"/>
+                </a:solidFill>
+                <a:latin typeface="Open Sans"/>
+              </a:rPr>
+              <a:t>Jā</a:t>
+            </a:r>
+          </a:p>
+        </p:txBody>
+      </p:sp>
+      <p:sp>
+        <p:nvSpPr>
+          <p:cNvPr id="26" name="Rounded Rectangle 25"/>
           <p:cNvSpPr/>
           <p:nvPr/>
         </p:nvSpPr>
         <p:spPr>
           <a:xfrm>
-            <a:off x="6446520" y="2240279"/>
-            <a:ext cx="731520" cy="731520"/>
-          </a:xfrm>
-          <a:prstGeom prst="ellipse">
-            <a:avLst/>
+            <a:off x="640080" y="4425696"/>
+            <a:ext cx="10927080" cy="603504"/>
+          </a:xfrm>
+          <a:prstGeom prst="roundRect">
+            <a:avLst>
+              <a:gd name="adj" fmla="val 8000"/>
+            </a:avLst>
           </a:prstGeom>
           <a:solidFill>
             <a:srgbClr val="244A30"/>
@@ -6555,14 +7319,14 @@
       </p:sp>
       <p:sp>
         <p:nvSpPr>
-          <p:cNvPr id="11" name="TextBox 10"/>
+          <p:cNvPr id="27" name="TextBox 26"/>
           <p:cNvSpPr txBox="1"/>
           <p:nvPr/>
         </p:nvSpPr>
         <p:spPr>
           <a:xfrm>
-            <a:off x="6446520" y="2240279"/>
-            <a:ext cx="731520" cy="731520"/>
+            <a:off x="868680" y="4425696"/>
+            <a:ext cx="3017520" cy="603504"/>
           </a:xfrm>
           <a:prstGeom prst="rect">
             <a:avLst/>
@@ -6571,48 +7335,6 @@
         </p:spPr>
         <p:txBody>
           <a:bodyPr wrap="square" anchor="ctr" lIns="0" rIns="0" tIns="0" bIns="0">
-            <a:spAutoFit/>
-          </a:bodyPr>
-          <a:lstStyle/>
-          <a:p>
-            <a:pPr algn="ctr">
-              <a:lnSpc>
-                <a:spcPct val="110000"/>
-              </a:lnSpc>
-              <a:spcAft>
-                <a:spcPts val="600"/>
-              </a:spcAft>
-            </a:pPr>
-            <a:r>
-              <a:rPr sz="2200" b="1">
-                <a:solidFill>
-                  <a:srgbClr val="FFFFFF"/>
-                </a:solidFill>
-                <a:latin typeface="Montserrat"/>
-              </a:rPr>
-              <a:t>2</a:t>
-            </a:r>
-          </a:p>
-        </p:txBody>
-      </p:sp>
-      <p:sp>
-        <p:nvSpPr>
-          <p:cNvPr id="12" name="TextBox 11"/>
-          <p:cNvSpPr txBox="1"/>
-          <p:nvPr/>
-        </p:nvSpPr>
-        <p:spPr>
-          <a:xfrm>
-            <a:off x="7406640" y="2167128"/>
-            <a:ext cx="3931920" cy="457200"/>
-          </a:xfrm>
-          <a:prstGeom prst="rect">
-            <a:avLst/>
-          </a:prstGeom>
-          <a:noFill/>
-        </p:spPr>
-        <p:txBody>
-          <a:bodyPr wrap="square" anchor="t" lIns="0" rIns="0" tIns="0" bIns="0">
             <a:spAutoFit/>
           </a:bodyPr>
           <a:lstStyle/>
@@ -6626,27 +7348,27 @@
               </a:spcAft>
             </a:pPr>
             <a:r>
-              <a:rPr sz="2000" b="1">
-                <a:solidFill>
-                  <a:srgbClr val="1C261E"/>
+              <a:rPr sz="1600" b="1">
+                <a:solidFill>
+                  <a:srgbClr val="FFFFFF"/>
                 </a:solidFill>
                 <a:latin typeface="Montserrat"/>
               </a:rPr>
-              <a:t>Reāli aprēķināts</a:t>
-            </a:r>
-          </a:p>
-        </p:txBody>
-      </p:sp>
-      <p:sp>
-        <p:nvSpPr>
-          <p:cNvPr id="13" name="TextBox 12"/>
+              <a:t>Būvgružu birža</a:t>
+            </a:r>
+          </a:p>
+        </p:txBody>
+      </p:sp>
+      <p:sp>
+        <p:nvSpPr>
+          <p:cNvPr id="28" name="TextBox 27"/>
           <p:cNvSpPr txBox="1"/>
           <p:nvPr/>
         </p:nvSpPr>
         <p:spPr>
           <a:xfrm>
-            <a:off x="7406640" y="2606039"/>
-            <a:ext cx="3931920" cy="548640"/>
+            <a:off x="3931920" y="4425696"/>
+            <a:ext cx="2011680" cy="603504"/>
           </a:xfrm>
           <a:prstGeom prst="rect">
             <a:avLst/>
@@ -6654,7 +7376,7 @@
           <a:noFill/>
         </p:spPr>
         <p:txBody>
-          <a:bodyPr wrap="square" anchor="t" lIns="0" rIns="0" tIns="0" bIns="0">
+          <a:bodyPr wrap="square" anchor="ctr" lIns="0" rIns="0" tIns="0" bIns="0">
             <a:spAutoFit/>
           </a:bodyPr>
           <a:lstStyle/>
@@ -6668,27 +7390,153 @@
               </a:spcAft>
             </a:pPr>
             <a:r>
-              <a:rPr sz="1400" b="0">
-                <a:solidFill>
-                  <a:srgbClr val="5B665D"/>
+              <a:rPr sz="1500" b="1">
+                <a:solidFill>
+                  <a:srgbClr val="FFFFFF"/>
                 </a:solidFill>
                 <a:latin typeface="Open Sans"/>
               </a:rPr>
-              <a:t>Atlīdzība balstīta uz pārstrādātāju cenām un peļņu (~2 %)</a:t>
-            </a:r>
-          </a:p>
-        </p:txBody>
-      </p:sp>
-      <p:sp>
-        <p:nvSpPr>
-          <p:cNvPr id="14" name="Rounded Rectangle 13"/>
+              <a:t>Jā</a:t>
+            </a:r>
+          </a:p>
+        </p:txBody>
+      </p:sp>
+      <p:sp>
+        <p:nvSpPr>
+          <p:cNvPr id="29" name="TextBox 28"/>
+          <p:cNvSpPr txBox="1"/>
+          <p:nvPr/>
+        </p:nvSpPr>
+        <p:spPr>
+          <a:xfrm>
+            <a:off x="5852160" y="4425696"/>
+            <a:ext cx="2011680" cy="603504"/>
+          </a:xfrm>
+          <a:prstGeom prst="rect">
+            <a:avLst/>
+          </a:prstGeom>
+          <a:noFill/>
+        </p:spPr>
+        <p:txBody>
+          <a:bodyPr wrap="square" anchor="ctr" lIns="0" rIns="0" tIns="0" bIns="0">
+            <a:spAutoFit/>
+          </a:bodyPr>
+          <a:lstStyle/>
+          <a:p>
+            <a:pPr algn="l">
+              <a:lnSpc>
+                <a:spcPct val="110000"/>
+              </a:lnSpc>
+              <a:spcAft>
+                <a:spcPts val="600"/>
+              </a:spcAft>
+            </a:pPr>
+            <a:r>
+              <a:rPr sz="1500" b="1">
+                <a:solidFill>
+                  <a:srgbClr val="FFFFFF"/>
+                </a:solidFill>
+                <a:latin typeface="Open Sans"/>
+              </a:rPr>
+              <a:t>Karte + pārvadātājs</a:t>
+            </a:r>
+          </a:p>
+        </p:txBody>
+      </p:sp>
+      <p:sp>
+        <p:nvSpPr>
+          <p:cNvPr id="30" name="TextBox 29"/>
+          <p:cNvSpPr txBox="1"/>
+          <p:nvPr/>
+        </p:nvSpPr>
+        <p:spPr>
+          <a:xfrm>
+            <a:off x="8001000" y="4425696"/>
+            <a:ext cx="2011680" cy="603504"/>
+          </a:xfrm>
+          <a:prstGeom prst="rect">
+            <a:avLst/>
+          </a:prstGeom>
+          <a:noFill/>
+        </p:spPr>
+        <p:txBody>
+          <a:bodyPr wrap="square" anchor="ctr" lIns="0" rIns="0" tIns="0" bIns="0">
+            <a:spAutoFit/>
+          </a:bodyPr>
+          <a:lstStyle/>
+          <a:p>
+            <a:pPr algn="l">
+              <a:lnSpc>
+                <a:spcPct val="110000"/>
+              </a:lnSpc>
+              <a:spcAft>
+                <a:spcPts val="600"/>
+              </a:spcAft>
+            </a:pPr>
+            <a:r>
+              <a:rPr sz="1500" b="1">
+                <a:solidFill>
+                  <a:srgbClr val="FFFFFF"/>
+                </a:solidFill>
+                <a:latin typeface="Open Sans"/>
+              </a:rPr>
+              <a:t>Jā</a:t>
+            </a:r>
+          </a:p>
+        </p:txBody>
+      </p:sp>
+      <p:sp>
+        <p:nvSpPr>
+          <p:cNvPr id="31" name="TextBox 30"/>
+          <p:cNvSpPr txBox="1"/>
+          <p:nvPr/>
+        </p:nvSpPr>
+        <p:spPr>
+          <a:xfrm>
+            <a:off x="9692640" y="4425696"/>
+            <a:ext cx="2011680" cy="603504"/>
+          </a:xfrm>
+          <a:prstGeom prst="rect">
+            <a:avLst/>
+          </a:prstGeom>
+          <a:noFill/>
+        </p:spPr>
+        <p:txBody>
+          <a:bodyPr wrap="square" anchor="ctr" lIns="0" rIns="0" tIns="0" bIns="0">
+            <a:spAutoFit/>
+          </a:bodyPr>
+          <a:lstStyle/>
+          <a:p>
+            <a:pPr algn="l">
+              <a:lnSpc>
+                <a:spcPct val="110000"/>
+              </a:lnSpc>
+              <a:spcAft>
+                <a:spcPts val="600"/>
+              </a:spcAft>
+            </a:pPr>
+            <a:r>
+              <a:rPr sz="1500" b="1">
+                <a:solidFill>
+                  <a:srgbClr val="FFFFFF"/>
+                </a:solidFill>
+                <a:latin typeface="Open Sans"/>
+              </a:rPr>
+              <a:t>Jā</a:t>
+            </a:r>
+          </a:p>
+        </p:txBody>
+      </p:sp>
+      <p:sp>
+        <p:nvSpPr>
+          <p:cNvPr id="32" name="Rounded Rectangle 31"/>
           <p:cNvSpPr/>
           <p:nvPr/>
         </p:nvSpPr>
         <p:spPr>
           <a:xfrm>
-            <a:off x="640080" y="3429000"/>
-            <a:ext cx="5349240" cy="1280160"/>
+            <a:off x="640080" y="5257800"/>
+            <a:ext cx="10927080" cy="960120"/>
           </a:xfrm>
           <a:prstGeom prst="roundRect">
             <a:avLst>
@@ -6696,7 +7544,7 @@
             </a:avLst>
           </a:prstGeom>
           <a:solidFill>
-            <a:srgbClr val="FFFFFF"/>
+            <a:srgbClr val="5E8C5A"/>
           </a:solidFill>
           <a:ln>
             <a:noFill/>
@@ -6727,58 +7575,14 @@
       </p:sp>
       <p:sp>
         <p:nvSpPr>
-          <p:cNvPr id="15" name="Oval 14"/>
-          <p:cNvSpPr/>
-          <p:nvPr/>
-        </p:nvSpPr>
-        <p:spPr>
-          <a:xfrm>
-            <a:off x="914400" y="3703320"/>
-            <a:ext cx="731520" cy="731520"/>
-          </a:xfrm>
-          <a:prstGeom prst="ellipse">
-            <a:avLst/>
-          </a:prstGeom>
-          <a:solidFill>
-            <a:srgbClr val="244A30"/>
-          </a:solidFill>
-          <a:ln>
-            <a:noFill/>
-          </a:ln>
-          <a:effectLst/>
-        </p:spPr>
-        <p:style>
-          <a:lnRef idx="1">
-            <a:schemeClr val="accent1"/>
-          </a:lnRef>
-          <a:fillRef idx="3">
-            <a:schemeClr val="accent1"/>
-          </a:fillRef>
-          <a:effectRef idx="2">
-            <a:schemeClr val="accent1"/>
-          </a:effectRef>
-          <a:fontRef idx="minor">
-            <a:schemeClr val="lt1"/>
-          </a:fontRef>
-        </p:style>
-        <p:txBody>
-          <a:bodyPr rtlCol="0" anchor="ctr"/>
-          <a:lstStyle/>
-          <a:p>
-            <a:pPr algn="ctr"/>
-          </a:p>
-        </p:txBody>
-      </p:sp>
-      <p:sp>
-        <p:nvSpPr>
-          <p:cNvPr id="16" name="TextBox 15"/>
+          <p:cNvPr id="33" name="TextBox 32"/>
           <p:cNvSpPr txBox="1"/>
           <p:nvPr/>
         </p:nvSpPr>
         <p:spPr>
           <a:xfrm>
-            <a:off x="914400" y="3703320"/>
-            <a:ext cx="731520" cy="731520"/>
+            <a:off x="914400" y="5257800"/>
+            <a:ext cx="10424160" cy="960120"/>
           </a:xfrm>
           <a:prstGeom prst="rect">
             <a:avLst/>
@@ -6791,47 +7595,24 @@
           </a:bodyPr>
           <a:lstStyle/>
           <a:p>
-            <a:pPr algn="ctr">
+            <a:pPr algn="l">
               <a:lnSpc>
                 <a:spcPct val="110000"/>
               </a:lnSpc>
               <a:spcAft>
-                <a:spcPts val="600"/>
+                <a:spcPts val="200"/>
               </a:spcAft>
             </a:pPr>
             <a:r>
-              <a:rPr sz="2200" b="1">
-                <a:solidFill>
-                  <a:srgbClr val="FFFFFF"/>
-                </a:solidFill>
-                <a:latin typeface="Montserrat"/>
+              <a:rPr sz="1200" b="0">
+                <a:solidFill>
+                  <a:srgbClr val="CFE0C8"/>
+                </a:solidFill>
+                <a:latin typeface="Open Sans"/>
               </a:rPr>
-              <a:t>3</a:t>
-            </a:r>
-          </a:p>
-        </p:txBody>
-      </p:sp>
-      <p:sp>
-        <p:nvSpPr>
-          <p:cNvPr id="17" name="TextBox 16"/>
-          <p:cNvSpPr txBox="1"/>
-          <p:nvPr/>
-        </p:nvSpPr>
-        <p:spPr>
-          <a:xfrm>
-            <a:off x="1874519" y="3630168"/>
-            <a:ext cx="3931920" cy="457200"/>
-          </a:xfrm>
-          <a:prstGeom prst="rect">
-            <a:avLst/>
-          </a:prstGeom>
-          <a:noFill/>
-        </p:spPr>
-        <p:txBody>
-          <a:bodyPr wrap="square" anchor="t" lIns="0" rIns="0" tIns="0" bIns="0">
-            <a:spAutoFit/>
-          </a:bodyPr>
-          <a:lstStyle/>
+              <a:t>Galvenā funkcija</a:t>
+            </a:r>
+          </a:p>
           <a:p>
             <a:pPr algn="l">
               <a:lnSpc>
@@ -6842,27 +7623,27 @@
               </a:spcAft>
             </a:pPr>
             <a:r>
-              <a:rPr sz="2000" b="1">
-                <a:solidFill>
-                  <a:srgbClr val="1C261E"/>
+              <a:rPr sz="2100" b="1">
+                <a:solidFill>
+                  <a:srgbClr val="FFFFFF"/>
                 </a:solidFill>
                 <a:latin typeface="Montserrat"/>
               </a:rPr>
-              <a:t>Atmaksājas braukt</a:t>
-            </a:r>
-          </a:p>
-        </p:txBody>
-      </p:sp>
-      <p:sp>
-        <p:nvSpPr>
-          <p:cNvPr id="18" name="TextBox 17"/>
+              <a:t>Nofotografē — uzreiz redzi, cik saņemsi un kur nodot atmaksājas</a:t>
+            </a:r>
+          </a:p>
+        </p:txBody>
+      </p:sp>
+      <p:sp>
+        <p:nvSpPr>
+          <p:cNvPr id="34" name="TextBox 33"/>
           <p:cNvSpPr txBox="1"/>
           <p:nvPr/>
         </p:nvSpPr>
         <p:spPr>
           <a:xfrm>
-            <a:off x="1874519" y="4069080"/>
-            <a:ext cx="3931920" cy="548640"/>
+            <a:off x="640080" y="6309360"/>
+            <a:ext cx="10927080" cy="274320"/>
           </a:xfrm>
           <a:prstGeom prst="rect">
             <a:avLst/>
@@ -6884,630 +7665,13 @@
               </a:spcAft>
             </a:pPr>
             <a:r>
-              <a:rPr sz="1400" b="0">
+              <a:rPr sz="1000" b="0">
                 <a:solidFill>
                   <a:srgbClr val="5B665D"/>
                 </a:solidFill>
                 <a:latin typeface="Open Sans"/>
               </a:rPr>
-              <a:t>Lietotne rāda tikai punktus, kur atlīdzība &gt; degvielas izmaksas</a:t>
-            </a:r>
-          </a:p>
-        </p:txBody>
-      </p:sp>
-      <p:sp>
-        <p:nvSpPr>
-          <p:cNvPr id="19" name="Rounded Rectangle 18"/>
-          <p:cNvSpPr/>
-          <p:nvPr/>
-        </p:nvSpPr>
-        <p:spPr>
-          <a:xfrm>
-            <a:off x="6172200" y="3429000"/>
-            <a:ext cx="5349240" cy="1280160"/>
-          </a:xfrm>
-          <a:prstGeom prst="roundRect">
-            <a:avLst>
-              <a:gd name="adj" fmla="val 8000"/>
-            </a:avLst>
-          </a:prstGeom>
-          <a:solidFill>
-            <a:srgbClr val="FFFFFF"/>
-          </a:solidFill>
-          <a:ln>
-            <a:noFill/>
-          </a:ln>
-          <a:effectLst/>
-        </p:spPr>
-        <p:style>
-          <a:lnRef idx="1">
-            <a:schemeClr val="accent1"/>
-          </a:lnRef>
-          <a:fillRef idx="3">
-            <a:schemeClr val="accent1"/>
-          </a:fillRef>
-          <a:effectRef idx="2">
-            <a:schemeClr val="accent1"/>
-          </a:effectRef>
-          <a:fontRef idx="minor">
-            <a:schemeClr val="lt1"/>
-          </a:fontRef>
-        </p:style>
-        <p:txBody>
-          <a:bodyPr rtlCol="0" anchor="ctr"/>
-          <a:lstStyle/>
-          <a:p>
-            <a:pPr algn="ctr"/>
-          </a:p>
-        </p:txBody>
-      </p:sp>
-      <p:sp>
-        <p:nvSpPr>
-          <p:cNvPr id="20" name="Oval 19"/>
-          <p:cNvSpPr/>
-          <p:nvPr/>
-        </p:nvSpPr>
-        <p:spPr>
-          <a:xfrm>
-            <a:off x="6446520" y="3703320"/>
-            <a:ext cx="731520" cy="731520"/>
-          </a:xfrm>
-          <a:prstGeom prst="ellipse">
-            <a:avLst/>
-          </a:prstGeom>
-          <a:solidFill>
-            <a:srgbClr val="244A30"/>
-          </a:solidFill>
-          <a:ln>
-            <a:noFill/>
-          </a:ln>
-          <a:effectLst/>
-        </p:spPr>
-        <p:style>
-          <a:lnRef idx="1">
-            <a:schemeClr val="accent1"/>
-          </a:lnRef>
-          <a:fillRef idx="3">
-            <a:schemeClr val="accent1"/>
-          </a:fillRef>
-          <a:effectRef idx="2">
-            <a:schemeClr val="accent1"/>
-          </a:effectRef>
-          <a:fontRef idx="minor">
-            <a:schemeClr val="lt1"/>
-          </a:fontRef>
-        </p:style>
-        <p:txBody>
-          <a:bodyPr rtlCol="0" anchor="ctr"/>
-          <a:lstStyle/>
-          <a:p>
-            <a:pPr algn="ctr"/>
-          </a:p>
-        </p:txBody>
-      </p:sp>
-      <p:sp>
-        <p:nvSpPr>
-          <p:cNvPr id="21" name="TextBox 20"/>
-          <p:cNvSpPr txBox="1"/>
-          <p:nvPr/>
-        </p:nvSpPr>
-        <p:spPr>
-          <a:xfrm>
-            <a:off x="6446520" y="3703320"/>
-            <a:ext cx="731520" cy="731520"/>
-          </a:xfrm>
-          <a:prstGeom prst="rect">
-            <a:avLst/>
-          </a:prstGeom>
-          <a:noFill/>
-        </p:spPr>
-        <p:txBody>
-          <a:bodyPr wrap="square" anchor="ctr" lIns="0" rIns="0" tIns="0" bIns="0">
-            <a:spAutoFit/>
-          </a:bodyPr>
-          <a:lstStyle/>
-          <a:p>
-            <a:pPr algn="ctr">
-              <a:lnSpc>
-                <a:spcPct val="110000"/>
-              </a:lnSpc>
-              <a:spcAft>
-                <a:spcPts val="600"/>
-              </a:spcAft>
-            </a:pPr>
-            <a:r>
-              <a:rPr sz="2200" b="1">
-                <a:solidFill>
-                  <a:srgbClr val="FFFFFF"/>
-                </a:solidFill>
-                <a:latin typeface="Montserrat"/>
-              </a:rPr>
-              <a:t>4</a:t>
-            </a:r>
-          </a:p>
-        </p:txBody>
-      </p:sp>
-      <p:sp>
-        <p:nvSpPr>
-          <p:cNvPr id="22" name="TextBox 21"/>
-          <p:cNvSpPr txBox="1"/>
-          <p:nvPr/>
-        </p:nvSpPr>
-        <p:spPr>
-          <a:xfrm>
-            <a:off x="7406640" y="3630168"/>
-            <a:ext cx="3931920" cy="457200"/>
-          </a:xfrm>
-          <a:prstGeom prst="rect">
-            <a:avLst/>
-          </a:prstGeom>
-          <a:noFill/>
-        </p:spPr>
-        <p:txBody>
-          <a:bodyPr wrap="square" anchor="t" lIns="0" rIns="0" tIns="0" bIns="0">
-            <a:spAutoFit/>
-          </a:bodyPr>
-          <a:lstStyle/>
-          <a:p>
-            <a:pPr algn="l">
-              <a:lnSpc>
-                <a:spcPct val="110000"/>
-              </a:lnSpc>
-              <a:spcAft>
-                <a:spcPts val="600"/>
-              </a:spcAft>
-            </a:pPr>
-            <a:r>
-              <a:rPr sz="2000" b="1">
-                <a:solidFill>
-                  <a:srgbClr val="1C261E"/>
-                </a:solidFill>
-                <a:latin typeface="Montserrat"/>
-              </a:rPr>
-              <a:t>Bez jaunas infrastruktūras</a:t>
-            </a:r>
-          </a:p>
-        </p:txBody>
-      </p:sp>
-      <p:sp>
-        <p:nvSpPr>
-          <p:cNvPr id="23" name="TextBox 22"/>
-          <p:cNvSpPr txBox="1"/>
-          <p:nvPr/>
-        </p:nvSpPr>
-        <p:spPr>
-          <a:xfrm>
-            <a:off x="7406640" y="4069080"/>
-            <a:ext cx="3931920" cy="548640"/>
-          </a:xfrm>
-          <a:prstGeom prst="rect">
-            <a:avLst/>
-          </a:prstGeom>
-          <a:noFill/>
-        </p:spPr>
-        <p:txBody>
-          <a:bodyPr wrap="square" anchor="t" lIns="0" rIns="0" tIns="0" bIns="0">
-            <a:spAutoFit/>
-          </a:bodyPr>
-          <a:lstStyle/>
-          <a:p>
-            <a:pPr algn="l">
-              <a:lnSpc>
-                <a:spcPct val="110000"/>
-              </a:lnSpc>
-              <a:spcAft>
-                <a:spcPts val="600"/>
-              </a:spcAft>
-            </a:pPr>
-            <a:r>
-              <a:rPr sz="1400" b="0">
-                <a:solidFill>
-                  <a:srgbClr val="5B665D"/>
-                </a:solidFill>
-                <a:latin typeface="Open Sans"/>
-              </a:rPr>
-              <a:t>Izmanto esošos licencētos punktus — sākam ar vienu pašvaldību</a:t>
-            </a:r>
-          </a:p>
-        </p:txBody>
-      </p:sp>
-      <p:sp>
-        <p:nvSpPr>
-          <p:cNvPr id="24" name="Rounded Rectangle 23"/>
-          <p:cNvSpPr/>
-          <p:nvPr/>
-        </p:nvSpPr>
-        <p:spPr>
-          <a:xfrm>
-            <a:off x="640080" y="4983480"/>
-            <a:ext cx="10881360" cy="1005840"/>
-          </a:xfrm>
-          <a:prstGeom prst="roundRect">
-            <a:avLst>
-              <a:gd name="adj" fmla="val 8000"/>
-            </a:avLst>
-          </a:prstGeom>
-          <a:solidFill>
-            <a:srgbClr val="244A30"/>
-          </a:solidFill>
-          <a:ln>
-            <a:noFill/>
-          </a:ln>
-          <a:effectLst/>
-        </p:spPr>
-        <p:style>
-          <a:lnRef idx="1">
-            <a:schemeClr val="accent1"/>
-          </a:lnRef>
-          <a:fillRef idx="3">
-            <a:schemeClr val="accent1"/>
-          </a:fillRef>
-          <a:effectRef idx="2">
-            <a:schemeClr val="accent1"/>
-          </a:effectRef>
-          <a:fontRef idx="minor">
-            <a:schemeClr val="lt1"/>
-          </a:fontRef>
-        </p:style>
-        <p:txBody>
-          <a:bodyPr rtlCol="0" anchor="ctr"/>
-          <a:lstStyle/>
-          <a:p>
-            <a:pPr algn="ctr"/>
-          </a:p>
-        </p:txBody>
-      </p:sp>
-      <p:sp>
-        <p:nvSpPr>
-          <p:cNvPr id="25" name="TextBox 24"/>
-          <p:cNvSpPr txBox="1"/>
-          <p:nvPr/>
-        </p:nvSpPr>
-        <p:spPr>
-          <a:xfrm>
-            <a:off x="914400" y="5074920"/>
-            <a:ext cx="2377440" cy="365760"/>
-          </a:xfrm>
-          <a:prstGeom prst="rect">
-            <a:avLst/>
-          </a:prstGeom>
-          <a:noFill/>
-        </p:spPr>
-        <p:txBody>
-          <a:bodyPr wrap="square" anchor="t" lIns="0" rIns="0" tIns="0" bIns="0">
-            <a:spAutoFit/>
-          </a:bodyPr>
-          <a:lstStyle/>
-          <a:p>
-            <a:pPr algn="l">
-              <a:lnSpc>
-                <a:spcPct val="110000"/>
-              </a:lnSpc>
-              <a:spcAft>
-                <a:spcPts val="600"/>
-              </a:spcAft>
-            </a:pPr>
-            <a:r>
-              <a:rPr sz="1300" b="0">
-                <a:solidFill>
-                  <a:srgbClr val="CFE0C8"/>
-                </a:solidFill>
-                <a:latin typeface="Open Sans"/>
-              </a:rPr>
-              <a:t>Koksne</a:t>
-            </a:r>
-          </a:p>
-        </p:txBody>
-      </p:sp>
-      <p:sp>
-        <p:nvSpPr>
-          <p:cNvPr id="26" name="TextBox 25"/>
-          <p:cNvSpPr txBox="1"/>
-          <p:nvPr/>
-        </p:nvSpPr>
-        <p:spPr>
-          <a:xfrm>
-            <a:off x="914400" y="5394960"/>
-            <a:ext cx="2377440" cy="457200"/>
-          </a:xfrm>
-          <a:prstGeom prst="rect">
-            <a:avLst/>
-          </a:prstGeom>
-          <a:noFill/>
-        </p:spPr>
-        <p:txBody>
-          <a:bodyPr wrap="square" anchor="t" lIns="0" rIns="0" tIns="0" bIns="0">
-            <a:spAutoFit/>
-          </a:bodyPr>
-          <a:lstStyle/>
-          <a:p>
-            <a:pPr algn="l">
-              <a:lnSpc>
-                <a:spcPct val="110000"/>
-              </a:lnSpc>
-              <a:spcAft>
-                <a:spcPts val="600"/>
-              </a:spcAft>
-            </a:pPr>
-            <a:r>
-              <a:rPr sz="2200" b="1">
-                <a:solidFill>
-                  <a:srgbClr val="FFFFFF"/>
-                </a:solidFill>
-                <a:latin typeface="Montserrat"/>
-              </a:rPr>
-              <a:t>15–30 €/t</a:t>
-            </a:r>
-          </a:p>
-        </p:txBody>
-      </p:sp>
-      <p:sp>
-        <p:nvSpPr>
-          <p:cNvPr id="27" name="TextBox 26"/>
-          <p:cNvSpPr txBox="1"/>
-          <p:nvPr/>
-        </p:nvSpPr>
-        <p:spPr>
-          <a:xfrm>
-            <a:off x="3429000" y="5074920"/>
-            <a:ext cx="2377440" cy="365760"/>
-          </a:xfrm>
-          <a:prstGeom prst="rect">
-            <a:avLst/>
-          </a:prstGeom>
-          <a:noFill/>
-        </p:spPr>
-        <p:txBody>
-          <a:bodyPr wrap="square" anchor="t" lIns="0" rIns="0" tIns="0" bIns="0">
-            <a:spAutoFit/>
-          </a:bodyPr>
-          <a:lstStyle/>
-          <a:p>
-            <a:pPr algn="l">
-              <a:lnSpc>
-                <a:spcPct val="110000"/>
-              </a:lnSpc>
-              <a:spcAft>
-                <a:spcPts val="600"/>
-              </a:spcAft>
-            </a:pPr>
-            <a:r>
-              <a:rPr sz="1300" b="0">
-                <a:solidFill>
-                  <a:srgbClr val="CFE0C8"/>
-                </a:solidFill>
-                <a:latin typeface="Open Sans"/>
-              </a:rPr>
-              <a:t>Betons</a:t>
-            </a:r>
-          </a:p>
-        </p:txBody>
-      </p:sp>
-      <p:sp>
-        <p:nvSpPr>
-          <p:cNvPr id="28" name="TextBox 27"/>
-          <p:cNvSpPr txBox="1"/>
-          <p:nvPr/>
-        </p:nvSpPr>
-        <p:spPr>
-          <a:xfrm>
-            <a:off x="3429000" y="5394960"/>
-            <a:ext cx="2377440" cy="457200"/>
-          </a:xfrm>
-          <a:prstGeom prst="rect">
-            <a:avLst/>
-          </a:prstGeom>
-          <a:noFill/>
-        </p:spPr>
-        <p:txBody>
-          <a:bodyPr wrap="square" anchor="t" lIns="0" rIns="0" tIns="0" bIns="0">
-            <a:spAutoFit/>
-          </a:bodyPr>
-          <a:lstStyle/>
-          <a:p>
-            <a:pPr algn="l">
-              <a:lnSpc>
-                <a:spcPct val="110000"/>
-              </a:lnSpc>
-              <a:spcAft>
-                <a:spcPts val="600"/>
-              </a:spcAft>
-            </a:pPr>
-            <a:r>
-              <a:rPr sz="2200" b="1">
-                <a:solidFill>
-                  <a:srgbClr val="FFFFFF"/>
-                </a:solidFill>
-                <a:latin typeface="Montserrat"/>
-              </a:rPr>
-              <a:t>1–3 €/t</a:t>
-            </a:r>
-          </a:p>
-        </p:txBody>
-      </p:sp>
-      <p:sp>
-        <p:nvSpPr>
-          <p:cNvPr id="29" name="TextBox 28"/>
-          <p:cNvSpPr txBox="1"/>
-          <p:nvPr/>
-        </p:nvSpPr>
-        <p:spPr>
-          <a:xfrm>
-            <a:off x="5943600" y="5074920"/>
-            <a:ext cx="2377440" cy="365760"/>
-          </a:xfrm>
-          <a:prstGeom prst="rect">
-            <a:avLst/>
-          </a:prstGeom>
-          <a:noFill/>
-        </p:spPr>
-        <p:txBody>
-          <a:bodyPr wrap="square" anchor="t" lIns="0" rIns="0" tIns="0" bIns="0">
-            <a:spAutoFit/>
-          </a:bodyPr>
-          <a:lstStyle/>
-          <a:p>
-            <a:pPr algn="l">
-              <a:lnSpc>
-                <a:spcPct val="110000"/>
-              </a:lnSpc>
-              <a:spcAft>
-                <a:spcPts val="600"/>
-              </a:spcAft>
-            </a:pPr>
-            <a:r>
-              <a:rPr sz="1300" b="0">
-                <a:solidFill>
-                  <a:srgbClr val="CFE0C8"/>
-                </a:solidFill>
-                <a:latin typeface="Open Sans"/>
-              </a:rPr>
-              <a:t>Ķieģeļi</a:t>
-            </a:r>
-          </a:p>
-        </p:txBody>
-      </p:sp>
-      <p:sp>
-        <p:nvSpPr>
-          <p:cNvPr id="30" name="TextBox 29"/>
-          <p:cNvSpPr txBox="1"/>
-          <p:nvPr/>
-        </p:nvSpPr>
-        <p:spPr>
-          <a:xfrm>
-            <a:off x="5943600" y="5394960"/>
-            <a:ext cx="2377440" cy="457200"/>
-          </a:xfrm>
-          <a:prstGeom prst="rect">
-            <a:avLst/>
-          </a:prstGeom>
-          <a:noFill/>
-        </p:spPr>
-        <p:txBody>
-          <a:bodyPr wrap="square" anchor="t" lIns="0" rIns="0" tIns="0" bIns="0">
-            <a:spAutoFit/>
-          </a:bodyPr>
-          <a:lstStyle/>
-          <a:p>
-            <a:pPr algn="l">
-              <a:lnSpc>
-                <a:spcPct val="110000"/>
-              </a:lnSpc>
-              <a:spcAft>
-                <a:spcPts val="600"/>
-              </a:spcAft>
-            </a:pPr>
-            <a:r>
-              <a:rPr sz="2200" b="1">
-                <a:solidFill>
-                  <a:srgbClr val="FFFFFF"/>
-                </a:solidFill>
-                <a:latin typeface="Montserrat"/>
-              </a:rPr>
-              <a:t>0,5–1,5 €/t</a:t>
-            </a:r>
-          </a:p>
-        </p:txBody>
-      </p:sp>
-      <p:sp>
-        <p:nvSpPr>
-          <p:cNvPr id="31" name="TextBox 30"/>
-          <p:cNvSpPr txBox="1"/>
-          <p:nvPr/>
-        </p:nvSpPr>
-        <p:spPr>
-          <a:xfrm>
-            <a:off x="8366760" y="5074920"/>
-            <a:ext cx="3017520" cy="822960"/>
-          </a:xfrm>
-          <a:prstGeom prst="rect">
-            <a:avLst/>
-          </a:prstGeom>
-          <a:noFill/>
-        </p:spPr>
-        <p:txBody>
-          <a:bodyPr wrap="square" anchor="t" lIns="0" rIns="0" tIns="0" bIns="0">
-            <a:spAutoFit/>
-          </a:bodyPr>
-          <a:lstStyle/>
-          <a:p>
-            <a:pPr algn="l">
-              <a:lnSpc>
-                <a:spcPct val="110000"/>
-              </a:lnSpc>
-              <a:spcAft>
-                <a:spcPts val="600"/>
-              </a:spcAft>
-            </a:pPr>
-            <a:r>
-              <a:rPr sz="1300" b="0">
-                <a:solidFill>
-                  <a:srgbClr val="CFE0C8"/>
-                </a:solidFill>
-                <a:latin typeface="Open Sans"/>
-              </a:rPr>
-              <a:t>Atlīdzība =</a:t>
-            </a:r>
-          </a:p>
-          <a:p>
-            <a:pPr algn="l">
-              <a:lnSpc>
-                <a:spcPct val="110000"/>
-              </a:lnSpc>
-              <a:spcAft>
-                <a:spcPts val="600"/>
-              </a:spcAft>
-            </a:pPr>
-            <a:r>
-              <a:rPr sz="1500" b="1">
-                <a:solidFill>
-                  <a:srgbClr val="FFFFFF"/>
-                </a:solidFill>
-                <a:latin typeface="Montserrat"/>
-              </a:rPr>
-              <a:t>svars × cena × kvalitāte</a:t>
-            </a:r>
-          </a:p>
-        </p:txBody>
-      </p:sp>
-      <p:sp>
-        <p:nvSpPr>
-          <p:cNvPr id="32" name="TextBox 31"/>
-          <p:cNvSpPr txBox="1"/>
-          <p:nvPr/>
-        </p:nvSpPr>
-        <p:spPr>
-          <a:xfrm>
-            <a:off x="640080" y="6126480"/>
-            <a:ext cx="10881360" cy="274320"/>
-          </a:xfrm>
-          <a:prstGeom prst="rect">
-            <a:avLst/>
-          </a:prstGeom>
-          <a:noFill/>
-        </p:spPr>
-        <p:txBody>
-          <a:bodyPr wrap="square" anchor="t" lIns="0" rIns="0" tIns="0" bIns="0">
-            <a:spAutoFit/>
-          </a:bodyPr>
-          <a:lstStyle/>
-          <a:p>
-            <a:pPr algn="l">
-              <a:lnSpc>
-                <a:spcPct val="110000"/>
-              </a:lnSpc>
-              <a:spcAft>
-                <a:spcPts val="600"/>
-              </a:spcAft>
-            </a:pPr>
-            <a:r>
-              <a:rPr sz="1000" b="0">
-                <a:solidFill>
-                  <a:srgbClr val="5B665D"/>
-                </a:solidFill>
-                <a:latin typeface="Open Sans"/>
-              </a:rPr>
-              <a:t>€/t — aplēses pēc uzņēmumu datiem, jāpārbauda pilotprojektā.</a:t>
+              <a:t>Atlīdzība pēc pārstrādātāju cenām: koksne 15–30 €/t, betons 1–3 €/t, ķieģeļi 0,5–1,5 €/t (aplēses, jāpārbauda pilotprojektā).</a:t>
             </a:r>
           </a:p>
         </p:txBody>

</xml_diff>

<commit_message>
Hackathon: tell the whole pitch through one user, Anna (mentor's UX request)
Co-Authored-By: Claude Opus 5.5 <noreply@anthropic.com>
Claude-Session: https://claude.ai/code/session_01C3KfjncommuX479wUy9vJ7
</commit_message>
<xml_diff>
--- a/hakatons/buvgruzu-birza.pptx
+++ b/hakatons/buvgruzu-birza.pptx
@@ -506,7 +506,7 @@
           <a:lstStyle/>
           <a:p>
             <a:r>
-              <a:t>0:35 — Iedomājieties: jūs remontējat dzīvokli, un jums ir 30 maisi ar betonu un flīzēm. Nav piekabes, nezināt, kur tos nodot. Internetā — "izvedam būvgružus lēti". Viens zvans, un problēma atrisināta. Bet daļa šo gružu nonāk mežā. Būvniecība patērē pusi no visiem zemē iegūtajiem resursiem, un būvgruži ir vairāk nekā trešdaļa no visiem ES atkritumiem. Problēma nav cilvēkos. Problēma ir tā, ka nelegālais ceļš ir lētāks un vienkāršāks.</a:t>
+              <a:t>0:35 — Šī ir Anna. Viņa remontē māju, un viņai ir kaudze vecu dēļu un betona lausku. Piekabes nav, kur nodot, nezina, legāli ir dārgi. Internetā — "izvedam būvgružus lēti". Viens zvans, un problēma atrisināta. Bet daļa šo gružu nonāk mežā. Būvniecība patērē pusi no visiem zemē iegūtajiem resursiem, un būvgruži ir vairāk nekā trešdaļa no visiem ES atkritumiem. Problēma nav cilvēkos. Problēma ir tā, ka nelegālais ceļš ir lētāks un vienkāršāks.</a:t>
             </a:r>
           </a:p>
           <a:p/>
@@ -582,7 +582,7 @@
           <a:lstStyle/>
           <a:p>
             <a:r>
-              <a:t>0:30 — Mūsu risinājums ir Būvgružu birža — aprites ekonomikas platforma, kas savieno cilvēkus, kuriem ir būvgruži, ar uzņēmumiem, kas tos pārstrādā. Princips kā pudeļu depozītam — nodod un saņem. Cilvēkiem: bezmaksas nodošana un atlīdzība — par koksni nauda, par betonu punkti. Uzņēmumiem: tīrs materiāls bez šķirošanas izmaksām. Videi: mazāk izgāztuvju mežos un mazāk jaunu izejvielu ieguves.</a:t>
+              <a:t>0:30 — Mūsu risinājums ir Būvgružu birža — aprites ekonomikas platforma, kas savieno Annu ar uzņēmumiem, kas pārstrādā būvgružus. Princips kā pudeļu depozītam — nodod un saņem. Anna nodod gružus bez maksas un saņem atlīdzību — par koksni naudu, par betonu punktus. Uzņēmumiem: tīrs materiāls bez šķirošanas izmaksām. Videi: mazāk izgāztuvju mežos un mazāk jaunu izejvielu ieguves.</a:t>
             </a:r>
           </a:p>
         </p:txBody>
@@ -3933,7 +3933,7 @@
                 </a:solidFill>
                 <a:latin typeface="Open Sans"/>
               </a:rPr>
-              <a:t>Nelegāli izmest būvgružus ir lētāk un vienkāršāk nekā tos sašķirot un nodot legāli.</a:t>
+              <a:t>Anna remontē māju. Piekabes nav, kur nodot, nezina, legāli ir dārgi. Nelegālais ceļš ir lētāks un vienkāršāks.</a:t>
             </a:r>
           </a:p>
         </p:txBody>
@@ -5238,7 +5238,7 @@
                 </a:solidFill>
                 <a:latin typeface="Montserrat"/>
               </a:rPr>
-              <a:t>Anna remontē māju</a:t>
+              <a:t>Annas ceļš</a:t>
             </a:r>
           </a:p>
         </p:txBody>
@@ -5280,7 +5280,7 @@
                 </a:solidFill>
                 <a:latin typeface="Open Sans"/>
               </a:rPr>
-              <a:t>Vecie grīdas dēļi un betona lauskas — ko darīt?</a:t>
+              <a:t>No gružu kaudzes līdz atlīdzībai četros soļos</a:t>
             </a:r>
           </a:p>
         </p:txBody>

</xml_diff>

<commit_message>
Hackathon: opening hook and Alyssa's one-line benefit statement
Co-Authored-By: Claude Opus 5.5 <noreply@anthropic.com>
Claude-Session: https://claude.ai/code/session_01C3KfjncommuX479wUy9vJ7
</commit_message>
<xml_diff>
--- a/hakatons/buvgruzu-birza.pptx
+++ b/hakatons/buvgruzu-birza.pptx
@@ -506,7 +506,7 @@
           <a:lstStyle/>
           <a:p>
             <a:r>
-              <a:t>0:35 — Šī ir Anna. Viņa remontē māju, un viņai ir kaudze vecu dēļu un betona lausku. Piekabes nav, kur nodot, nezina, legāli ir dārgi. Internetā — "izvedam būvgružus lēti". Viens zvans, un problēma atrisināta. Bet daļa šo gružu nonāk mežā. Būvniecība patērē pusi no visiem zemē iegūtajiem resursiem, un būvgruži ir vairāk nekā trešdaļa no visiem ES atkritumiem. Problēma nav cilvēkos. Problēma ir tā, ka nelegālais ceļš ir lētāks un vienkāršāks.</a:t>
+              <a:t>0:35 — HOOK (lēni, ar pauzi): Izmest būvgružus mežā maksā nulle eiro. Nodot tos legāli — maksā. Uzminiet, kurš ceļš uzvar. [pauze] Šī ir Anna. Viņa remontē māju: veci dēļi, betona lauskas, piekabes nav, kur nodot — nezina. Internetā — "izvedam būvgružus lēti". Viens zvans, un gruži nonāk mežā. Un būvgruži ir vairāk nekā trešdaļa no visiem ES atkritumiem. Problēma nav cilvēkos — nelegālais ceļš vienkārši ir lētāks.</a:t>
             </a:r>
           </a:p>
           <a:p/>
@@ -4222,8 +4222,8 @@
         </p:nvSpPr>
         <p:spPr>
           <a:xfrm>
-            <a:off x="7086600" y="4983480"/>
-            <a:ext cx="4526280" cy="1325880"/>
+            <a:off x="7269480" y="731520"/>
+            <a:ext cx="2377440" cy="960120"/>
           </a:xfrm>
           <a:prstGeom prst="roundRect">
             <a:avLst>
@@ -4231,7 +4231,7 @@
             </a:avLst>
           </a:prstGeom>
           <a:solidFill>
-            <a:srgbClr val="FFFFFF"/>
+            <a:srgbClr val="244A30"/>
           </a:solidFill>
           <a:ln>
             <a:noFill/>
@@ -4263,6 +4263,113 @@
       <p:sp>
         <p:nvSpPr>
           <p:cNvPr id="13" name="TextBox 12"/>
+          <p:cNvSpPr txBox="1"/>
+          <p:nvPr/>
+        </p:nvSpPr>
+        <p:spPr>
+          <a:xfrm>
+            <a:off x="7269480" y="731520"/>
+            <a:ext cx="2377440" cy="960120"/>
+          </a:xfrm>
+          <a:prstGeom prst="rect">
+            <a:avLst/>
+          </a:prstGeom>
+          <a:noFill/>
+        </p:spPr>
+        <p:txBody>
+          <a:bodyPr wrap="square" anchor="ctr" lIns="0" rIns="0" tIns="0" bIns="0">
+            <a:spAutoFit/>
+          </a:bodyPr>
+          <a:lstStyle/>
+          <a:p>
+            <a:pPr algn="ctr">
+              <a:lnSpc>
+                <a:spcPct val="100000"/>
+              </a:lnSpc>
+              <a:spcAft>
+                <a:spcPts val="0"/>
+              </a:spcAft>
+            </a:pPr>
+            <a:r>
+              <a:rPr sz="1300" b="0">
+                <a:solidFill>
+                  <a:srgbClr val="CFE0C8"/>
+                </a:solidFill>
+                <a:latin typeface="Open Sans"/>
+              </a:rPr>
+              <a:t>Izmest mežā</a:t>
+            </a:r>
+          </a:p>
+          <a:p>
+            <a:pPr algn="ctr">
+              <a:lnSpc>
+                <a:spcPct val="100000"/>
+              </a:lnSpc>
+              <a:spcAft>
+                <a:spcPts val="600"/>
+              </a:spcAft>
+            </a:pPr>
+            <a:r>
+              <a:rPr sz="3000" b="1">
+                <a:solidFill>
+                  <a:srgbClr val="FFFFFF"/>
+                </a:solidFill>
+                <a:latin typeface="Montserrat"/>
+              </a:rPr>
+              <a:t>0 €</a:t>
+            </a:r>
+          </a:p>
+        </p:txBody>
+      </p:sp>
+      <p:sp>
+        <p:nvSpPr>
+          <p:cNvPr id="14" name="Rounded Rectangle 13"/>
+          <p:cNvSpPr/>
+          <p:nvPr/>
+        </p:nvSpPr>
+        <p:spPr>
+          <a:xfrm>
+            <a:off x="7086600" y="4983480"/>
+            <a:ext cx="4526280" cy="1325880"/>
+          </a:xfrm>
+          <a:prstGeom prst="roundRect">
+            <a:avLst>
+              <a:gd name="adj" fmla="val 8000"/>
+            </a:avLst>
+          </a:prstGeom>
+          <a:solidFill>
+            <a:srgbClr val="FFFFFF"/>
+          </a:solidFill>
+          <a:ln>
+            <a:noFill/>
+          </a:ln>
+          <a:effectLst/>
+        </p:spPr>
+        <p:style>
+          <a:lnRef idx="1">
+            <a:schemeClr val="accent1"/>
+          </a:lnRef>
+          <a:fillRef idx="3">
+            <a:schemeClr val="accent1"/>
+          </a:fillRef>
+          <a:effectRef idx="2">
+            <a:schemeClr val="accent1"/>
+          </a:effectRef>
+          <a:fontRef idx="minor">
+            <a:schemeClr val="lt1"/>
+          </a:fontRef>
+        </p:style>
+        <p:txBody>
+          <a:bodyPr rtlCol="0" anchor="ctr"/>
+          <a:lstStyle/>
+          <a:p>
+            <a:pPr algn="ctr"/>
+          </a:p>
+        </p:txBody>
+      </p:sp>
+      <p:sp>
+        <p:nvSpPr>
+          <p:cNvPr id="15" name="TextBox 14"/>
           <p:cNvSpPr txBox="1"/>
           <p:nvPr/>
         </p:nvSpPr>
@@ -4384,7 +4491,7 @@
                 </a:solidFill>
                 <a:latin typeface="Montserrat"/>
               </a:rPr>
-              <a:t>RISINĀJUMS</a:t>
+              <a:t>RISINĀJUMS · APRITES EKONOMIKAS PLATFORMA</a:t>
             </a:r>
           </a:p>
         </p:txBody>
@@ -4439,8 +4546,8 @@
         </p:nvSpPr>
         <p:spPr>
           <a:xfrm>
-            <a:off x="640080" y="1691640"/>
-            <a:ext cx="9326880" cy="548640"/>
+            <a:off x="640080" y="1645920"/>
+            <a:ext cx="9326880" cy="914400"/>
           </a:xfrm>
           <a:prstGeom prst="rect">
             <a:avLst/>
@@ -4462,13 +4569,13 @@
               </a:spcAft>
             </a:pPr>
             <a:r>
-              <a:rPr sz="1800" b="0">
+              <a:rPr sz="1600" b="0">
                 <a:solidFill>
                   <a:srgbClr val="5B665D"/>
                 </a:solidFill>
                 <a:latin typeface="Open Sans"/>
               </a:rPr>
-              <a:t>Aprites ekonomikas platforma būvgružiem. Savieno cilvēkus, kuriem ir būvgruži, ar uzņēmumiem, kas tos pārstrādā.</a:t>
+              <a:t>Motivē cilvēkus viegli un bez maksas vai pat par atlīdzību šķirot būvgružus, bet uzņēmumiem ļauj atkārtoti izmantot materiālus jaunu produktu ražošanā.</a:t>
             </a:r>
           </a:p>
         </p:txBody>

</xml_diff>

<commit_message>
Hackathon: rounded corners on the slide 1 photo
Co-Authored-By: Claude Opus 5.5 <noreply@anthropic.com>
Claude-Session: https://claude.ai/code/session_01C3KfjncommuX479wUy9vJ7
</commit_message>
<xml_diff>
--- a/hakatons/buvgruzu-birza.pptx
+++ b/hakatons/buvgruzu-birza.pptx
@@ -4167,8 +4167,10 @@
             <a:off x="7086600" y="548640"/>
             <a:ext cx="4526280" cy="4206240"/>
           </a:xfrm>
-          <a:prstGeom prst="rect">
-            <a:avLst/>
+          <a:prstGeom prst="roundRect">
+            <a:avLst>
+              <a:gd name="adj" fmla="val 8000"/>
+            </a:avLst>
           </a:prstGeom>
         </p:spPr>
       </p:pic>

</xml_diff>

<commit_message>
Hackathon: drop the Anna persona, keep the user's point of view
Co-Authored-By: Claude Opus 5.5 <noreply@anthropic.com>
Claude-Session: https://claude.ai/code/session_01C3KfjncommuX479wUy9vJ7
</commit_message>
<xml_diff>
--- a/hakatons/buvgruzu-birza.pptx
+++ b/hakatons/buvgruzu-birza.pptx
@@ -506,7 +506,7 @@
           <a:lstStyle/>
           <a:p>
             <a:r>
-              <a:t>0:35 — HOOK (lēni, ar pauzi): Izmest būvgružus mežā maksā nulle eiro. Nodot tos legāli — maksā. Uzminiet, kurš ceļš uzvar. [pauze] Šī ir Anna. Viņa remontē māju: veci dēļi, betona lauskas, piekabes nav, kur nodot — nezina. Internetā — "izvedam būvgružus lēti". Viens zvans, un gruži nonāk mežā. Un būvgruži ir vairāk nekā trešdaļa no visiem ES atkritumiem. Problēma nav cilvēkos — nelegālais ceļš vienkārši ir lētāks.</a:t>
+              <a:t>0:35 — HOOK (lēni, ar pauzi): Izmest būvgružus mežā maksā nulle eiro. Nodot tos legāli — maksā. Uzminiet, kurš ceļš uzvar. [pauze] Iedomājieties, ka remontējat māju: veci dēļi, betona lauskas, piekabes nav, kur nodot — nezināt. Internetā — "izvedam būvgružus lēti". Viens zvans, un gruži nonāk mežā. Un būvgruži ir vairāk nekā trešdaļa no visiem ES atkritumiem. Problēma nav cilvēkos — nelegālais ceļš vienkārši ir lētāks.</a:t>
             </a:r>
           </a:p>
           <a:p/>
@@ -582,7 +582,7 @@
           <a:lstStyle/>
           <a:p>
             <a:r>
-              <a:t>0:30 — Mūsu risinājums ir Būvgružu birža — aprites ekonomikas platforma, kas savieno Annu ar uzņēmumiem, kas pārstrādā būvgružus. Princips kā pudeļu depozītam — nodod un saņem. Anna nodod gružus bez maksas un saņem atlīdzību — par koksni naudu, par betonu punktus. Uzņēmumiem: tīrs materiāls bez šķirošanas izmaksām. Videi: mazāk izgāztuvju mežos un mazāk jaunu izejvielu ieguves.</a:t>
+              <a:t>0:30 — Mūsu risinājums ir Būvgružu birža — aprites ekonomikas platforma, kas savieno cilvēkus, kuriem ir būvgruži, ar uzņēmumiem, kas tos pārstrādā. Princips kā pudeļu depozītam — nodod un saņem. Cilvēks nodod gružus bez maksas un saņem atlīdzību — par koksni naudu, par betonu punktus. Uzņēmumiem: tīrs materiāls bez šķirošanas izmaksām. Videi: mazāk izgāztuvju mežos un mazāk jaunu izejvielu ieguves.</a:t>
             </a:r>
           </a:p>
         </p:txBody>
@@ -652,7 +652,7 @@
           <a:lstStyle/>
           <a:p>
             <a:r>
-              <a:t>0:15 — Paskatīsimies ar Annas acīm. Viņa nofotografē gružus un uzreiz redz, cik saņems — vēl pirms reģistrācijas. Kartē redz tikai tos punktus, kur braukt atmaksājas. Parādīšu.</a:t>
+              <a:t>0:15 — Paskatīsimies ar lietotāja acīm. Tu nofotografē gružus un uzreiz redzi, cik saņemsi — vēl pirms reģistrācijas. Kartē redzi tikai tos punktus, kur braukt atmaksājas. Parādīšu.</a:t>
             </a:r>
           </a:p>
           <a:p/>
@@ -728,7 +728,7 @@
           <a:lstStyle/>
           <a:p>
             <a:r>
-              <a:t>0:30 — Šodien Annai ir trīs iespējas. Sludinājums — lēti, bet gruži bieži nonāk mežā. Konteiners — legāli, bet dārgi. Šķirošanas laukums — jāzina, kur, jāved pašam, un nekas par to netiek. No šīm iespējām tikai Būvgružu biržā nodot ir bez maksas, ar atlīdzību un pārstrādē. Un mūsu galvenā funkcija: nofotografē — un uzreiz redzi, cik saņemsi un kur nodot atmaksājas. To aprēķinājām pēc pārstrādātāju reālajām cenām.</a:t>
+              <a:t>0:30 — Šodien cilvēkam ir trīs iespējas. Sludinājums — lēti, bet gruži bieži nonāk mežā. Konteiners — legāli, bet dārgi. Šķirošanas laukums — jāzina, kur, jāved pašam, un nekas par to netiek. No šīm iespējām tikai Būvgružu biržā nodot ir bez maksas, ar atlīdzību un pārstrādē. Un mūsu galvenā funkcija: nofotografē — un uzreiz redzi, cik saņemsi un kur nodot atmaksājas. To aprēķinājām pēc pārstrādātāju reālajām cenām.</a:t>
             </a:r>
           </a:p>
         </p:txBody>
@@ -3933,7 +3933,7 @@
                 </a:solidFill>
                 <a:latin typeface="Open Sans"/>
               </a:rPr>
-              <a:t>Anna remontē māju. Piekabes nav, kur nodot, nezina, legāli ir dārgi. Nelegālais ceļš ir lētāks un vienkāršāks.</a:t>
+              <a:t>Remontē māju? Piekabes nav, kur nodot, nezini, legāli ir dārgi. Nelegālais ceļš ir lētāks un vienkāršāks.</a:t>
             </a:r>
           </a:p>
         </p:txBody>
@@ -5347,7 +5347,7 @@
                 </a:solidFill>
                 <a:latin typeface="Montserrat"/>
               </a:rPr>
-              <a:t>Annas ceļš</a:t>
+              <a:t>Lietotāja ceļš</a:t>
             </a:r>
           </a:p>
         </p:txBody>
@@ -6439,7 +6439,7 @@
                 </a:solidFill>
                 <a:latin typeface="Montserrat"/>
               </a:rPr>
-              <a:t>Annas iespējas šodien</a:t>
+              <a:t>Iespējas šodien</a:t>
             </a:r>
           </a:p>
         </p:txBody>

</xml_diff>

<commit_message>
Hackathon: leaner slide 1, drop feature banner, remove all dashes
Co-Authored-By: Claude Opus 5.5 <noreply@anthropic.com>
Claude-Session: https://claude.ai/code/session_01C3KfjncommuX479wUy9vJ7
</commit_message>
<xml_diff>
--- a/hakatons/buvgruzu-birza.pptx
+++ b/hakatons/buvgruzu-birza.pptx
@@ -506,7 +506,7 @@
           <a:lstStyle/>
           <a:p>
             <a:r>
-              <a:t>0:35 — HOOK (lēni, ar pauzi): Izmest būvgružus mežā maksā nulle eiro. Nodot tos legāli — maksā. Uzminiet, kurš ceļš uzvar. [pauze] Iedomājieties, ka remontējat māju: veci dēļi, betona lauskas, piekabes nav, kur nodot — nezināt. Internetā — "izvedam būvgružus lēti". Viens zvans, un gruži nonāk mežā. Un būvgruži ir vairāk nekā trešdaļa no visiem ES atkritumiem. Problēma nav cilvēkos — nelegālais ceļš vienkārši ir lētāks.</a:t>
+              <a:t>0:35. HOOK (lēni, ar pauzi): Izmest būvgružus mežā maksā nulle eiro. Nodot tos legāli maksā. Uzminiet, kurš ceļš uzvar. [pauze] Iedomājieties, ka remontējat māju: veci dēļi, betona lauskas, piekabes nav, kur nodot, nezināt. Internetā sludinājums: "izvedam būvgružus lēti". Viens zvans, un gruži nonāk mežā. Būvgruži ir vairāk nekā trešdaļa no visiem ES atkritumiem. Problēma nav cilvēkos. Nelegālais ceļš vienkārši ir lētāks.</a:t>
             </a:r>
           </a:p>
           <a:p/>
@@ -582,7 +582,7 @@
           <a:lstStyle/>
           <a:p>
             <a:r>
-              <a:t>0:30 — Mūsu risinājums ir Būvgružu birža — aprites ekonomikas platforma, kas savieno cilvēkus, kuriem ir būvgruži, ar uzņēmumiem, kas tos pārstrādā. Princips kā pudeļu depozītam — nodod un saņem. Cilvēks nodod gružus bez maksas un saņem atlīdzību — par koksni naudu, par betonu punktus. Uzņēmumiem: tīrs materiāls bez šķirošanas izmaksām. Videi: mazāk izgāztuvju mežos un mazāk jaunu izejvielu ieguves.</a:t>
+              <a:t>0:30. Mūsu risinājums ir Būvgružu birža, aprites ekonomikas platforma, kas savieno cilvēkus, kuriem ir būvgruži, ar uzņēmumiem, kas tos pārstrādā. Princips kā pudeļu depozītam: nodod un saņem. Cilvēks nodod gružus bez maksas un saņem atlīdzību: par koksni naudu, par betonu punktus. Uzņēmumiem: tīrs materiāls bez šķirošanas izmaksām. Videi: mazāk izgāztuvju mežos un mazāk jaunu izejvielu ieguves.</a:t>
             </a:r>
           </a:p>
         </p:txBody>
@@ -652,13 +652,13 @@
           <a:lstStyle/>
           <a:p>
             <a:r>
-              <a:t>0:15 — Paskatīsimies ar lietotāja acīm. Tu nofotografē gružus un uzreiz redzi, cik saņemsi — vēl pirms reģistrācijas. Kartē redzi tikai tos punktus, kur braukt atmaksājas. Parādīšu.</a:t>
+              <a:t>0:15. Paskatīsimies ar lietotāja acīm. Tu nofotografē gružus un uzreiz redzi, cik saņemsi, vēl pirms reģistrācijas. Kartē redzi tikai tos punktus, kur braukt atmaksājas. Parādīšu.</a:t>
             </a:r>
           </a:p>
           <a:p/>
           <a:p>
             <a:r>
-              <a:t>[VIDEO 1:00 — Gustavs komentē]</a:t>
+              <a:t>[VIDEO 1:00, Gustavs komentē]</a:t>
             </a:r>
           </a:p>
         </p:txBody>
@@ -728,7 +728,7 @@
           <a:lstStyle/>
           <a:p>
             <a:r>
-              <a:t>0:30 — Šodien cilvēkam ir trīs iespējas. Sludinājums — lēti, bet gruži bieži nonāk mežā. Konteiners — legāli, bet dārgi. Šķirošanas laukums — jāzina, kur, jāved pašam, un nekas par to netiek. No šīm iespējām tikai Būvgružu biržā nodot ir bez maksas, ar atlīdzību un pārstrādē. Un mūsu galvenā funkcija: nofotografē — un uzreiz redzi, cik saņemsi un kur nodot atmaksājas. To aprēķinājām pēc pārstrādātāju reālajām cenām.</a:t>
+              <a:t>0:30. Šodien cilvēkam ir trīs iespējas. Sludinājums: lēti, bet gruži bieži nonāk mežā. Konteiners: legāli, bet dārgi. Šķirošanas laukums: jāzina, kur, jāved pašam, un nekas par to netiek. No šīm iespējām tikai Būvgružu biržā nodot ir bez maksas, ar atlīdzību un pārstrādē. Un galvenais: lietotne uzreiz parāda, cik saņemsi un vai braukt atmaksājas. To aprēķinājām pēc pārstrādātāju reālajām cenām.</a:t>
             </a:r>
           </a:p>
         </p:txBody>
@@ -798,7 +798,7 @@
           <a:lstStyle/>
           <a:p>
             <a:r>
-              <a:t>0:10 — Būvgružu birža — lai būvgruži atgrieztos būvniecībā, nevis mežā. Paldies! Labprāt atbildēsim uz jautājumiem.</a:t>
+              <a:t>0:10. Būvgružu birža. Lai būvgruži atgrieztos būvniecībā, nevis mežā. Paldies! Labprāt atbildēsim uz jautājumiem.</a:t>
             </a:r>
           </a:p>
         </p:txBody>
@@ -3863,7 +3863,7 @@
         <p:spPr>
           <a:xfrm>
             <a:off x="640080" y="960120"/>
-            <a:ext cx="6035040" cy="2194560"/>
+            <a:ext cx="5669280" cy="2743200"/>
           </a:xfrm>
           <a:prstGeom prst="rect">
             <a:avLst/>
@@ -3885,7 +3885,7 @@
               </a:spcAft>
             </a:pPr>
             <a:r>
-              <a:rPr sz="4000" b="1">
+              <a:rPr sz="4600" b="1">
                 <a:solidFill>
                   <a:srgbClr val="FFFFFF"/>
                 </a:solidFill>
@@ -3904,8 +3904,8 @@
         </p:nvSpPr>
         <p:spPr>
           <a:xfrm>
-            <a:off x="640080" y="3246120"/>
-            <a:ext cx="5760720" cy="914400"/>
+            <a:off x="640080" y="4343400"/>
+            <a:ext cx="5029200" cy="914400"/>
           </a:xfrm>
           <a:prstGeom prst="rect">
             <a:avLst/>
@@ -3927,13 +3927,13 @@
               </a:spcAft>
             </a:pPr>
             <a:r>
-              <a:rPr sz="1800" b="0">
-                <a:solidFill>
-                  <a:srgbClr val="CFE0C8"/>
-                </a:solidFill>
-                <a:latin typeface="Open Sans"/>
+              <a:rPr sz="6000" b="1">
+                <a:solidFill>
+                  <a:srgbClr val="FFFFFF"/>
+                </a:solidFill>
+                <a:latin typeface="Montserrat"/>
               </a:rPr>
-              <a:t>Remontē māju? Piekabes nav, kur nodot, nezini, legāli ir dārgi. Nelegālais ceļš ir lētāks un vienkāršāks.</a:t>
+              <a:t>&gt; ⅓</a:t>
             </a:r>
           </a:p>
         </p:txBody>
@@ -3946,8 +3946,8 @@
         </p:nvSpPr>
         <p:spPr>
           <a:xfrm>
-            <a:off x="640080" y="4343400"/>
-            <a:ext cx="2743200" cy="731520"/>
+            <a:off x="640080" y="5349240"/>
+            <a:ext cx="5029200" cy="731520"/>
           </a:xfrm>
           <a:prstGeom prst="rect">
             <a:avLst/>
@@ -3969,133 +3969,7 @@
               </a:spcAft>
             </a:pPr>
             <a:r>
-              <a:rPr sz="4000" b="1">
-                <a:solidFill>
-                  <a:srgbClr val="FFFFFF"/>
-                </a:solidFill>
-                <a:latin typeface="Montserrat"/>
-              </a:rPr>
-              <a:t>~½</a:t>
-            </a:r>
-          </a:p>
-        </p:txBody>
-      </p:sp>
-      <p:sp>
-        <p:nvSpPr>
-          <p:cNvPr id="6" name="TextBox 5"/>
-          <p:cNvSpPr txBox="1"/>
-          <p:nvPr/>
-        </p:nvSpPr>
-        <p:spPr>
-          <a:xfrm>
-            <a:off x="640080" y="5074920"/>
-            <a:ext cx="2651760" cy="822960"/>
-          </a:xfrm>
-          <a:prstGeom prst="rect">
-            <a:avLst/>
-          </a:prstGeom>
-          <a:noFill/>
-        </p:spPr>
-        <p:txBody>
-          <a:bodyPr wrap="square" anchor="t" lIns="0" rIns="0" tIns="0" bIns="0">
-            <a:spAutoFit/>
-          </a:bodyPr>
-          <a:lstStyle/>
-          <a:p>
-            <a:pPr algn="l">
-              <a:lnSpc>
-                <a:spcPct val="110000"/>
-              </a:lnSpc>
-              <a:spcAft>
-                <a:spcPts val="600"/>
-              </a:spcAft>
-            </a:pPr>
-            <a:r>
-              <a:rPr sz="1400" b="0">
-                <a:solidFill>
-                  <a:srgbClr val="CFE0C8"/>
-                </a:solidFill>
-                <a:latin typeface="Open Sans"/>
-              </a:rPr>
-              <a:t>no zemes dzīlēs iegūtajiem resursiem patērē būvniecība</a:t>
-            </a:r>
-          </a:p>
-        </p:txBody>
-      </p:sp>
-      <p:sp>
-        <p:nvSpPr>
-          <p:cNvPr id="7" name="TextBox 6"/>
-          <p:cNvSpPr txBox="1"/>
-          <p:nvPr/>
-        </p:nvSpPr>
-        <p:spPr>
-          <a:xfrm>
-            <a:off x="3611880" y="4343400"/>
-            <a:ext cx="2743200" cy="731520"/>
-          </a:xfrm>
-          <a:prstGeom prst="rect">
-            <a:avLst/>
-          </a:prstGeom>
-          <a:noFill/>
-        </p:spPr>
-        <p:txBody>
-          <a:bodyPr wrap="square" anchor="t" lIns="0" rIns="0" tIns="0" bIns="0">
-            <a:spAutoFit/>
-          </a:bodyPr>
-          <a:lstStyle/>
-          <a:p>
-            <a:pPr algn="l">
-              <a:lnSpc>
-                <a:spcPct val="110000"/>
-              </a:lnSpc>
-              <a:spcAft>
-                <a:spcPts val="600"/>
-              </a:spcAft>
-            </a:pPr>
-            <a:r>
-              <a:rPr sz="4000" b="1">
-                <a:solidFill>
-                  <a:srgbClr val="FFFFFF"/>
-                </a:solidFill>
-                <a:latin typeface="Montserrat"/>
-              </a:rPr>
-              <a:t>&gt; ⅓</a:t>
-            </a:r>
-          </a:p>
-        </p:txBody>
-      </p:sp>
-      <p:sp>
-        <p:nvSpPr>
-          <p:cNvPr id="8" name="TextBox 7"/>
-          <p:cNvSpPr txBox="1"/>
-          <p:nvPr/>
-        </p:nvSpPr>
-        <p:spPr>
-          <a:xfrm>
-            <a:off x="3611880" y="5074920"/>
-            <a:ext cx="2651760" cy="822960"/>
-          </a:xfrm>
-          <a:prstGeom prst="rect">
-            <a:avLst/>
-          </a:prstGeom>
-          <a:noFill/>
-        </p:spPr>
-        <p:txBody>
-          <a:bodyPr wrap="square" anchor="t" lIns="0" rIns="0" tIns="0" bIns="0">
-            <a:spAutoFit/>
-          </a:bodyPr>
-          <a:lstStyle/>
-          <a:p>
-            <a:pPr algn="l">
-              <a:lnSpc>
-                <a:spcPct val="110000"/>
-              </a:lnSpc>
-              <a:spcAft>
-                <a:spcPts val="600"/>
-              </a:spcAft>
-            </a:pPr>
-            <a:r>
-              <a:rPr sz="1400" b="0">
+              <a:rPr sz="1800" b="0">
                 <a:solidFill>
                   <a:srgbClr val="CFE0C8"/>
                 </a:solidFill>
@@ -4106,51 +3980,9 @@
           </a:p>
         </p:txBody>
       </p:sp>
-      <p:sp>
-        <p:nvSpPr>
-          <p:cNvPr id="9" name="TextBox 8"/>
-          <p:cNvSpPr txBox="1"/>
-          <p:nvPr/>
-        </p:nvSpPr>
-        <p:spPr>
-          <a:xfrm>
-            <a:off x="640080" y="6172200"/>
-            <a:ext cx="5943600" cy="365760"/>
-          </a:xfrm>
-          <a:prstGeom prst="rect">
-            <a:avLst/>
-          </a:prstGeom>
-          <a:noFill/>
-        </p:spPr>
-        <p:txBody>
-          <a:bodyPr wrap="square" anchor="t" lIns="0" rIns="0" tIns="0" bIns="0">
-            <a:spAutoFit/>
-          </a:bodyPr>
-          <a:lstStyle/>
-          <a:p>
-            <a:pPr algn="l">
-              <a:lnSpc>
-                <a:spcPct val="110000"/>
-              </a:lnSpc>
-              <a:spcAft>
-                <a:spcPts val="600"/>
-              </a:spcAft>
-            </a:pPr>
-            <a:r>
-              <a:rPr sz="1000" b="0">
-                <a:solidFill>
-                  <a:srgbClr val="CFE0C8"/>
-                </a:solidFill>
-                <a:latin typeface="Open Sans"/>
-              </a:rPr>
-              <a:t>Avots: hakatona izaicinājums (SCHWENK, RTU, Green Liberty)</a:t>
-            </a:r>
-          </a:p>
-        </p:txBody>
-      </p:sp>
       <p:pic>
         <p:nvPicPr>
-          <p:cNvPr id="10" name="Picture 9" descr="foto-mezs.jpg"/>
+          <p:cNvPr id="6" name="Picture 5" descr="foto-mezs.jpg"/>
           <p:cNvPicPr>
             <a:picLocks noChangeAspect="1"/>
           </p:cNvPicPr>
@@ -4164,26 +3996,26 @@
         </p:blipFill>
         <p:spPr>
           <a:xfrm>
-            <a:off x="7086600" y="548640"/>
-            <a:ext cx="4526280" cy="4206240"/>
+            <a:off x="6720840" y="548640"/>
+            <a:ext cx="4892040" cy="5760720"/>
           </a:xfrm>
           <a:prstGeom prst="roundRect">
             <a:avLst>
-              <a:gd name="adj" fmla="val 8000"/>
+              <a:gd name="adj" fmla="val 7000"/>
             </a:avLst>
           </a:prstGeom>
         </p:spPr>
       </p:pic>
       <p:sp>
         <p:nvSpPr>
-          <p:cNvPr id="11" name="TextBox 10"/>
+          <p:cNvPr id="7" name="TextBox 6"/>
           <p:cNvSpPr txBox="1"/>
           <p:nvPr/>
         </p:nvSpPr>
         <p:spPr>
           <a:xfrm>
-            <a:off x="7086600" y="4773168"/>
-            <a:ext cx="4526280" cy="182880"/>
+            <a:off x="6720840" y="6355080"/>
+            <a:ext cx="4892040" cy="182880"/>
           </a:xfrm>
           <a:prstGeom prst="rect">
             <a:avLst/>
@@ -4218,14 +4050,14 @@
       </p:sp>
       <p:sp>
         <p:nvSpPr>
-          <p:cNvPr id="12" name="Rounded Rectangle 11"/>
+          <p:cNvPr id="8" name="Rounded Rectangle 7"/>
           <p:cNvSpPr/>
           <p:nvPr/>
         </p:nvSpPr>
         <p:spPr>
           <a:xfrm>
-            <a:off x="7269480" y="731520"/>
-            <a:ext cx="2377440" cy="960120"/>
+            <a:off x="6949440" y="777240"/>
+            <a:ext cx="2377440" cy="1051560"/>
           </a:xfrm>
           <a:prstGeom prst="roundRect">
             <a:avLst>
@@ -4264,14 +4096,14 @@
       </p:sp>
       <p:sp>
         <p:nvSpPr>
-          <p:cNvPr id="13" name="TextBox 12"/>
+          <p:cNvPr id="9" name="TextBox 8"/>
           <p:cNvSpPr txBox="1"/>
           <p:nvPr/>
         </p:nvSpPr>
         <p:spPr>
           <a:xfrm>
-            <a:off x="7269480" y="731520"/>
-            <a:ext cx="2377440" cy="960120"/>
+            <a:off x="6949440" y="777240"/>
+            <a:ext cx="2377440" cy="1051560"/>
           </a:xfrm>
           <a:prstGeom prst="rect">
             <a:avLst/>
@@ -4293,7 +4125,7 @@
               </a:spcAft>
             </a:pPr>
             <a:r>
-              <a:rPr sz="1300" b="0">
+              <a:rPr sz="1400" b="0">
                 <a:solidFill>
                   <a:srgbClr val="CFE0C8"/>
                 </a:solidFill>
@@ -4312,120 +4144,13 @@
               </a:spcAft>
             </a:pPr>
             <a:r>
-              <a:rPr sz="3000" b="1">
+              <a:rPr sz="3400" b="1">
                 <a:solidFill>
                   <a:srgbClr val="FFFFFF"/>
                 </a:solidFill>
                 <a:latin typeface="Montserrat"/>
               </a:rPr>
               <a:t>0 €</a:t>
-            </a:r>
-          </a:p>
-        </p:txBody>
-      </p:sp>
-      <p:sp>
-        <p:nvSpPr>
-          <p:cNvPr id="14" name="Rounded Rectangle 13"/>
-          <p:cNvSpPr/>
-          <p:nvPr/>
-        </p:nvSpPr>
-        <p:spPr>
-          <a:xfrm>
-            <a:off x="7086600" y="4983480"/>
-            <a:ext cx="4526280" cy="1325880"/>
-          </a:xfrm>
-          <a:prstGeom prst="roundRect">
-            <a:avLst>
-              <a:gd name="adj" fmla="val 8000"/>
-            </a:avLst>
-          </a:prstGeom>
-          <a:solidFill>
-            <a:srgbClr val="FFFFFF"/>
-          </a:solidFill>
-          <a:ln>
-            <a:noFill/>
-          </a:ln>
-          <a:effectLst/>
-        </p:spPr>
-        <p:style>
-          <a:lnRef idx="1">
-            <a:schemeClr val="accent1"/>
-          </a:lnRef>
-          <a:fillRef idx="3">
-            <a:schemeClr val="accent1"/>
-          </a:fillRef>
-          <a:effectRef idx="2">
-            <a:schemeClr val="accent1"/>
-          </a:effectRef>
-          <a:fontRef idx="minor">
-            <a:schemeClr val="lt1"/>
-          </a:fontRef>
-        </p:style>
-        <p:txBody>
-          <a:bodyPr rtlCol="0" anchor="ctr"/>
-          <a:lstStyle/>
-          <a:p>
-            <a:pPr algn="ctr"/>
-          </a:p>
-        </p:txBody>
-      </p:sp>
-      <p:sp>
-        <p:nvSpPr>
-          <p:cNvPr id="15" name="TextBox 14"/>
-          <p:cNvSpPr txBox="1"/>
-          <p:nvPr/>
-        </p:nvSpPr>
-        <p:spPr>
-          <a:xfrm>
-            <a:off x="7360920" y="5120640"/>
-            <a:ext cx="4023360" cy="1097280"/>
-          </a:xfrm>
-          <a:prstGeom prst="rect">
-            <a:avLst/>
-          </a:prstGeom>
-          <a:noFill/>
-        </p:spPr>
-        <p:txBody>
-          <a:bodyPr wrap="square" anchor="ctr" lIns="0" rIns="0" tIns="0" bIns="0">
-            <a:spAutoFit/>
-          </a:bodyPr>
-          <a:lstStyle/>
-          <a:p>
-            <a:pPr algn="l">
-              <a:lnSpc>
-                <a:spcPct val="110000"/>
-              </a:lnSpc>
-              <a:spcAft>
-                <a:spcPts val="600"/>
-              </a:spcAft>
-            </a:pPr>
-            <a:r>
-              <a:rPr sz="2000" b="1">
-                <a:solidFill>
-                  <a:srgbClr val="244A30"/>
-                </a:solidFill>
-                <a:latin typeface="Montserrat"/>
-              </a:rPr>
-              <a:t>„Izvedam būvgružus lēti!”</a:t>
-            </a:r>
-          </a:p>
-          <a:p>
-            <a:pPr algn="l">
-              <a:lnSpc>
-                <a:spcPct val="110000"/>
-              </a:lnSpc>
-              <a:spcAft>
-                <a:spcPts val="600"/>
-              </a:spcAft>
-            </a:pPr>
-            <a:r>
-              <a:rPr sz="1400" b="0">
-                <a:solidFill>
-                  <a:srgbClr val="5B665D"/>
-                </a:solidFill>
-                <a:latin typeface="Open Sans"/>
-              </a:rPr>
-              <a:t>Viens zvans — un gruži nonāk mežā.</a:t>
             </a:r>
           </a:p>
         </p:txBody>
@@ -5647,7 +5372,7 @@
                 </a:solidFill>
                 <a:latin typeface="Open Sans"/>
               </a:rPr>
-              <a:t>Izvēlas veidu un daudzumu maisos — lietotne parāda, kā šķirot</a:t>
+              <a:t>Izvēlas veidu un daudzumu maisos</a:t>
             </a:r>
           </a:p>
         </p:txBody>
@@ -5817,7 +5542,7 @@
                 </a:solidFill>
                 <a:latin typeface="Open Sans"/>
               </a:rPr>
-              <a:t>Cik saņems un vai braukt atmaksājas — vēl pirms reģistrācijas</a:t>
+              <a:t>Cik saņems un vai braukt atmaksājas</a:t>
             </a:r>
           </a:p>
         </p:txBody>
@@ -6157,7 +5882,7 @@
                 </a:solidFill>
                 <a:latin typeface="Open Sans"/>
               </a:rPr>
-              <a:t>Nosver, pārbauda — atlīdzība kontā</a:t>
+              <a:t>Nosver, pārbauda, atlīdzība kontā</a:t>
             </a:r>
           </a:p>
         </p:txBody>
@@ -7638,60 +7363,14 @@
       </p:sp>
       <p:sp>
         <p:nvSpPr>
-          <p:cNvPr id="32" name="Rounded Rectangle 31"/>
-          <p:cNvSpPr/>
-          <p:nvPr/>
-        </p:nvSpPr>
-        <p:spPr>
-          <a:xfrm>
-            <a:off x="640080" y="5257800"/>
-            <a:ext cx="10927080" cy="960120"/>
-          </a:xfrm>
-          <a:prstGeom prst="roundRect">
-            <a:avLst>
-              <a:gd name="adj" fmla="val 8000"/>
-            </a:avLst>
-          </a:prstGeom>
-          <a:solidFill>
-            <a:srgbClr val="5E8C5A"/>
-          </a:solidFill>
-          <a:ln>
-            <a:noFill/>
-          </a:ln>
-          <a:effectLst/>
-        </p:spPr>
-        <p:style>
-          <a:lnRef idx="1">
-            <a:schemeClr val="accent1"/>
-          </a:lnRef>
-          <a:fillRef idx="3">
-            <a:schemeClr val="accent1"/>
-          </a:fillRef>
-          <a:effectRef idx="2">
-            <a:schemeClr val="accent1"/>
-          </a:effectRef>
-          <a:fontRef idx="minor">
-            <a:schemeClr val="lt1"/>
-          </a:fontRef>
-        </p:style>
-        <p:txBody>
-          <a:bodyPr rtlCol="0" anchor="ctr"/>
-          <a:lstStyle/>
-          <a:p>
-            <a:pPr algn="ctr"/>
-          </a:p>
-        </p:txBody>
-      </p:sp>
-      <p:sp>
-        <p:nvSpPr>
-          <p:cNvPr id="33" name="TextBox 32"/>
+          <p:cNvPr id="32" name="TextBox 31"/>
           <p:cNvSpPr txBox="1"/>
           <p:nvPr/>
         </p:nvSpPr>
         <p:spPr>
           <a:xfrm>
-            <a:off x="914400" y="5257800"/>
-            <a:ext cx="10424160" cy="960120"/>
+            <a:off x="640080" y="5349240"/>
+            <a:ext cx="10927080" cy="274320"/>
           </a:xfrm>
           <a:prstGeom prst="rect">
             <a:avLst/>
@@ -7699,29 +7378,10 @@
           <a:noFill/>
         </p:spPr>
         <p:txBody>
-          <a:bodyPr wrap="square" anchor="ctr" lIns="0" rIns="0" tIns="0" bIns="0">
+          <a:bodyPr wrap="square" anchor="t" lIns="0" rIns="0" tIns="0" bIns="0">
             <a:spAutoFit/>
           </a:bodyPr>
           <a:lstStyle/>
-          <a:p>
-            <a:pPr algn="l">
-              <a:lnSpc>
-                <a:spcPct val="110000"/>
-              </a:lnSpc>
-              <a:spcAft>
-                <a:spcPts val="200"/>
-              </a:spcAft>
-            </a:pPr>
-            <a:r>
-              <a:rPr sz="1200" b="0">
-                <a:solidFill>
-                  <a:srgbClr val="CFE0C8"/>
-                </a:solidFill>
-                <a:latin typeface="Open Sans"/>
-              </a:rPr>
-              <a:t>Galvenā funkcija</a:t>
-            </a:r>
-          </a:p>
           <a:p>
             <a:pPr algn="l">
               <a:lnSpc>
@@ -7732,55 +7392,13 @@
               </a:spcAft>
             </a:pPr>
             <a:r>
-              <a:rPr sz="2100" b="1">
-                <a:solidFill>
-                  <a:srgbClr val="FFFFFF"/>
-                </a:solidFill>
-                <a:latin typeface="Montserrat"/>
-              </a:rPr>
-              <a:t>Nofotografē — uzreiz redzi, cik saņemsi un kur nodot atmaksājas</a:t>
-            </a:r>
-          </a:p>
-        </p:txBody>
-      </p:sp>
-      <p:sp>
-        <p:nvSpPr>
-          <p:cNvPr id="34" name="TextBox 33"/>
-          <p:cNvSpPr txBox="1"/>
-          <p:nvPr/>
-        </p:nvSpPr>
-        <p:spPr>
-          <a:xfrm>
-            <a:off x="640080" y="6309360"/>
-            <a:ext cx="10927080" cy="274320"/>
-          </a:xfrm>
-          <a:prstGeom prst="rect">
-            <a:avLst/>
-          </a:prstGeom>
-          <a:noFill/>
-        </p:spPr>
-        <p:txBody>
-          <a:bodyPr wrap="square" anchor="t" lIns="0" rIns="0" tIns="0" bIns="0">
-            <a:spAutoFit/>
-          </a:bodyPr>
-          <a:lstStyle/>
-          <a:p>
-            <a:pPr algn="l">
-              <a:lnSpc>
-                <a:spcPct val="110000"/>
-              </a:lnSpc>
-              <a:spcAft>
-                <a:spcPts val="600"/>
-              </a:spcAft>
-            </a:pPr>
-            <a:r>
-              <a:rPr sz="1000" b="0">
+              <a:rPr sz="1100" b="0">
                 <a:solidFill>
                   <a:srgbClr val="5B665D"/>
                 </a:solidFill>
                 <a:latin typeface="Open Sans"/>
               </a:rPr>
-              <a:t>Atlīdzība pēc pārstrādātāju cenām: koksne 15–30 €/t, betons 1–3 €/t, ķieģeļi 0,5–1,5 €/t (aplēses, jāpārbauda pilotprojektā).</a:t>
+              <a:t>Atlīdzība pēc pārstrādātāju cenām: koksne 15 līdz 30 €/t, betons 1 līdz 3 €/t, ķieģeļi 0,5 līdz 1,5 €/t (aplēses, jāpārbauda pilotprojektā).</a:t>
             </a:r>
           </a:p>
         </p:txBody>

</xml_diff>

<commit_message>
Hackathon: sources slide, legal disposal cost in hook, CleanR in comparison
Co-Authored-By: Claude Opus 5.5 <noreply@anthropic.com>
Claude-Session: https://claude.ai/code/session_01C3KfjncommuX479wUy9vJ7
</commit_message>
<xml_diff>
--- a/hakatons/buvgruzu-birza.pptx
+++ b/hakatons/buvgruzu-birza.pptx
@@ -10,6 +10,7 @@
     <p:sldId id="258" r:id="rId10"/>
     <p:sldId id="259" r:id="rId11"/>
     <p:sldId id="260" r:id="rId12"/>
+    <p:sldId id="261" r:id="rId13"/>
   </p:sldIdLst>
   <p:sldSz cx="12191695" cy="6858000" type="screen4x3"/>
   <p:notesSz cx="6858000" cy="9144000"/>
@@ -506,10 +507,15 @@
           <a:lstStyle/>
           <a:p>
             <a:r>
-              <a:t>0:35. HOOK (lēni, ar pauzi): Izmest būvgružus mežā maksā nulle eiro. Nodot tos legāli maksā. Uzminiet, kurš ceļš uzvar. [pauze] Iedomājieties, ka remontējat māju: veci dēļi, betona lauskas, piekabes nav, kur nodot, nezināt. Internetā sludinājums: "izvedam būvgružus lēti". Viens zvans, un gruži nonāk mežā. Būvgruži ir vairāk nekā trešdaļa no visiem ES atkritumiem. Problēma nav cilvēkos. Nelegālais ceļš vienkārši ir lētāks.</a:t>
+              <a:t>0:35. HOOK (lēni, ar pauzi): Izmest šo kaudzi mežā maksā nulle eiro. Nodot to legāli: līdz 500 eiro tonnā. Uzminiet, kurš ceļš uzvar. [pauze] Iedomājieties, ka remontējat māju: veci dēļi, betona lauskas, piekabes nav, kur nodot, nezināt. Internetā sludinājums: "izvedam būvgružus lēti". Viens zvans, un gruži nonāk mežā. Būvgruži ir vairāk nekā trešdaļa no visiem ES atkritumiem. Problēma nav cilvēkos. Nelegālais ceļš vienkārši ir lētāks.</a:t>
             </a:r>
           </a:p>
           <a:p/>
+          <a:p>
+            <a:r>
+              <a:t>500 €/t: azbesta šīfera nodošana, LSM 27.11.2023 (avots nr. 17).</a:t>
+            </a:r>
+          </a:p>
           <a:p>
             <a:r>
               <a:t>Foto avots: https://iauto.lv/zinas/latvija/49412-izg-atkritumus-me-k-tdus-cilvkus-nosaukt-foto</a:t>
@@ -728,7 +734,7 @@
           <a:lstStyle/>
           <a:p>
             <a:r>
-              <a:t>0:30. Šodien cilvēkam ir trīs iespējas. Sludinājums: lēti, bet gruži bieži nonāk mežā. Konteiners: legāli, bet dārgi. Šķirošanas laukums: jāzina, kur, jāved pašam, un nekas par to netiek. No šīm iespējām tikai Būvgružu biržā nodot ir bez maksas, ar atlīdzību un pārstrādē. Un galvenais: lietotne uzreiz parāda, cik saņemsi un vai braukt atmaksājas. To aprēķinājām pēc pārstrādātāju reālajām cenām.</a:t>
+              <a:t>0:35. Šodien cilvēkam ir četras iespējas. Sludinājums: lēti, bet gruži bieži nonāk mežā. Konteiners: legāli, bet dārgi. Šķirošanas laukums: jāved pašam, un nekas par to netiek. CleanR apmaiņas punkts Stopiņos jau pieņem tīrus būvgružus bez maksas un dod šķembas, bet tas ir viens punkts, un par to maz kurš zina. Būvgružu birža savieno šādus punktus vienā kartē. Un galvenais: lietotne uzreiz parāda, cik saņemsi un vai braukt atmaksājas.</a:t>
             </a:r>
           </a:p>
         </p:txBody>
@@ -799,6 +805,76 @@
           <a:p>
             <a:r>
               <a:t>0:10. Būvgružu birža. Lai būvgruži atgrieztos būvniecībā, nevis mežā. Paldies! Labprāt atbildēsim uz jautājumiem.</a:t>
+            </a:r>
+          </a:p>
+        </p:txBody>
+      </p:sp>
+      <p:sp>
+        <p:nvSpPr>
+          <p:cNvPr id="4" name="Slide Number Placeholder 3"/>
+          <p:cNvSpPr>
+            <a:spLocks noGrp="1"/>
+          </p:cNvSpPr>
+          <p:nvPr>
+            <p:ph type="sldNum" idx="5" sz="quarter"/>
+          </p:nvPr>
+        </p:nvSpPr>
+        <p:spPr/>
+      </p:sp>
+    </p:spTree>
+  </p:cSld>
+  <p:clrMapOvr>
+    <a:masterClrMapping/>
+  </p:clrMapOvr>
+</p:notes>
+</file>
+
+<file path=ppt/notesSlides/notesSlide6.xml><?xml version="1.0" encoding="utf-8"?>
+<p:notes xmlns:a="http://schemas.openxmlformats.org/drawingml/2006/main" xmlns:p="http://schemas.openxmlformats.org/presentationml/2006/main" xmlns:r="http://schemas.openxmlformats.org/officeDocument/2006/relationships">
+  <p:cSld>
+    <p:spTree>
+      <p:nvGrpSpPr>
+        <p:cNvPr id="1" name=""/>
+        <p:cNvGrpSpPr/>
+        <p:nvPr/>
+      </p:nvGrpSpPr>
+      <p:grpSpPr>
+        <a:xfrm>
+          <a:off x="0" y="0"/>
+          <a:ext cx="0" cy="0"/>
+          <a:chOff x="0" y="0"/>
+          <a:chExt cx="0" cy="0"/>
+        </a:xfrm>
+      </p:grpSpPr>
+      <p:sp>
+        <p:nvSpPr>
+          <p:cNvPr id="2" name="Slide Image Placeholder 1"/>
+          <p:cNvSpPr>
+            <a:spLocks noGrp="1"/>
+          </p:cNvSpPr>
+          <p:nvPr>
+            <p:ph type="sldImg" idx="2"/>
+          </p:nvPr>
+        </p:nvSpPr>
+        <p:spPr/>
+      </p:sp>
+      <p:sp>
+        <p:nvSpPr>
+          <p:cNvPr id="3" name="Notes Placeholder 2"/>
+          <p:cNvSpPr>
+            <a:spLocks noGrp="1"/>
+          </p:cNvSpPr>
+          <p:nvPr>
+            <p:ph type="body" idx="3" sz="quarter"/>
+          </p:nvPr>
+        </p:nvSpPr>
+        <p:spPr/>
+        <p:txBody>
+          <a:bodyPr/>
+          <a:lstStyle/>
+          <a:p>
+            <a:r>
+              <a:t>Pielikums. Netiek rādīts prezentācijas laikā; atvērt tikai, ja žūrija jautā par avotiem.</a:t>
             </a:r>
           </a:p>
         </p:txBody>
@@ -4155,6 +4231,113 @@
           </a:p>
         </p:txBody>
       </p:sp>
+      <p:sp>
+        <p:nvSpPr>
+          <p:cNvPr id="10" name="Rounded Rectangle 9"/>
+          <p:cNvSpPr/>
+          <p:nvPr/>
+        </p:nvSpPr>
+        <p:spPr>
+          <a:xfrm>
+            <a:off x="6949440" y="1965960"/>
+            <a:ext cx="2377440" cy="1051560"/>
+          </a:xfrm>
+          <a:prstGeom prst="roundRect">
+            <a:avLst>
+              <a:gd name="adj" fmla="val 8000"/>
+            </a:avLst>
+          </a:prstGeom>
+          <a:solidFill>
+            <a:srgbClr val="FFFFFF"/>
+          </a:solidFill>
+          <a:ln>
+            <a:noFill/>
+          </a:ln>
+          <a:effectLst/>
+        </p:spPr>
+        <p:style>
+          <a:lnRef idx="1">
+            <a:schemeClr val="accent1"/>
+          </a:lnRef>
+          <a:fillRef idx="3">
+            <a:schemeClr val="accent1"/>
+          </a:fillRef>
+          <a:effectRef idx="2">
+            <a:schemeClr val="accent1"/>
+          </a:effectRef>
+          <a:fontRef idx="minor">
+            <a:schemeClr val="lt1"/>
+          </a:fontRef>
+        </p:style>
+        <p:txBody>
+          <a:bodyPr rtlCol="0" anchor="ctr"/>
+          <a:lstStyle/>
+          <a:p>
+            <a:pPr algn="ctr"/>
+          </a:p>
+        </p:txBody>
+      </p:sp>
+      <p:sp>
+        <p:nvSpPr>
+          <p:cNvPr id="11" name="TextBox 10"/>
+          <p:cNvSpPr txBox="1"/>
+          <p:nvPr/>
+        </p:nvSpPr>
+        <p:spPr>
+          <a:xfrm>
+            <a:off x="6949440" y="1965960"/>
+            <a:ext cx="2377440" cy="1051560"/>
+          </a:xfrm>
+          <a:prstGeom prst="rect">
+            <a:avLst/>
+          </a:prstGeom>
+          <a:noFill/>
+        </p:spPr>
+        <p:txBody>
+          <a:bodyPr wrap="square" anchor="ctr" lIns="0" rIns="0" tIns="0" bIns="0">
+            <a:spAutoFit/>
+          </a:bodyPr>
+          <a:lstStyle/>
+          <a:p>
+            <a:pPr algn="ctr">
+              <a:lnSpc>
+                <a:spcPct val="100000"/>
+              </a:lnSpc>
+              <a:spcAft>
+                <a:spcPts val="0"/>
+              </a:spcAft>
+            </a:pPr>
+            <a:r>
+              <a:rPr sz="1400" b="0">
+                <a:solidFill>
+                  <a:srgbClr val="5B665D"/>
+                </a:solidFill>
+                <a:latin typeface="Open Sans"/>
+              </a:rPr>
+              <a:t>Nodot legāli</a:t>
+            </a:r>
+          </a:p>
+          <a:p>
+            <a:pPr algn="ctr">
+              <a:lnSpc>
+                <a:spcPct val="100000"/>
+              </a:lnSpc>
+              <a:spcAft>
+                <a:spcPts val="600"/>
+              </a:spcAft>
+            </a:pPr>
+            <a:r>
+              <a:rPr sz="2600" b="1">
+                <a:solidFill>
+                  <a:srgbClr val="244A30"/>
+                </a:solidFill>
+                <a:latin typeface="Montserrat"/>
+              </a:rPr>
+              <a:t>līdz 500 €/t</a:t>
+            </a:r>
+          </a:p>
+        </p:txBody>
+      </p:sp>
     </p:spTree>
   </p:cSld>
   <p:clrMapOvr>
@@ -6345,8 +6528,8 @@
         </p:nvSpPr>
         <p:spPr>
           <a:xfrm>
-            <a:off x="640080" y="2286000"/>
-            <a:ext cx="10927080" cy="603504"/>
+            <a:off x="640080" y="2240280"/>
+            <a:ext cx="10927080" cy="566928"/>
           </a:xfrm>
           <a:prstGeom prst="roundRect">
             <a:avLst>
@@ -6391,8 +6574,8 @@
         </p:nvSpPr>
         <p:spPr>
           <a:xfrm>
-            <a:off x="868680" y="2286000"/>
-            <a:ext cx="3017520" cy="603504"/>
+            <a:off x="868680" y="2240280"/>
+            <a:ext cx="3017520" cy="566928"/>
           </a:xfrm>
           <a:prstGeom prst="rect">
             <a:avLst/>
@@ -6433,8 +6616,8 @@
         </p:nvSpPr>
         <p:spPr>
           <a:xfrm>
-            <a:off x="3931920" y="2286000"/>
-            <a:ext cx="2011680" cy="603504"/>
+            <a:off x="3931920" y="2240280"/>
+            <a:ext cx="2011680" cy="566928"/>
           </a:xfrm>
           <a:prstGeom prst="rect">
             <a:avLst/>
@@ -6475,8 +6658,8 @@
         </p:nvSpPr>
         <p:spPr>
           <a:xfrm>
-            <a:off x="5852160" y="2286000"/>
-            <a:ext cx="2011680" cy="603504"/>
+            <a:off x="5852160" y="2240280"/>
+            <a:ext cx="2011680" cy="566928"/>
           </a:xfrm>
           <a:prstGeom prst="rect">
             <a:avLst/>
@@ -6517,8 +6700,8 @@
         </p:nvSpPr>
         <p:spPr>
           <a:xfrm>
-            <a:off x="8001000" y="2286000"/>
-            <a:ext cx="2011680" cy="603504"/>
+            <a:off x="8001000" y="2240280"/>
+            <a:ext cx="2011680" cy="566928"/>
           </a:xfrm>
           <a:prstGeom prst="rect">
             <a:avLst/>
@@ -6559,8 +6742,8 @@
         </p:nvSpPr>
         <p:spPr>
           <a:xfrm>
-            <a:off x="9692640" y="2286000"/>
-            <a:ext cx="2011680" cy="603504"/>
+            <a:off x="9692640" y="2240280"/>
+            <a:ext cx="2011680" cy="566928"/>
           </a:xfrm>
           <a:prstGeom prst="rect">
             <a:avLst/>
@@ -6601,8 +6784,8 @@
         </p:nvSpPr>
         <p:spPr>
           <a:xfrm>
-            <a:off x="640080" y="2999232"/>
-            <a:ext cx="10927080" cy="603504"/>
+            <a:off x="640080" y="2916936"/>
+            <a:ext cx="10927080" cy="566928"/>
           </a:xfrm>
           <a:prstGeom prst="roundRect">
             <a:avLst>
@@ -6647,8 +6830,8 @@
         </p:nvSpPr>
         <p:spPr>
           <a:xfrm>
-            <a:off x="868680" y="2999232"/>
-            <a:ext cx="3017520" cy="603504"/>
+            <a:off x="868680" y="2916936"/>
+            <a:ext cx="3017520" cy="566928"/>
           </a:xfrm>
           <a:prstGeom prst="rect">
             <a:avLst/>
@@ -6689,8 +6872,8 @@
         </p:nvSpPr>
         <p:spPr>
           <a:xfrm>
-            <a:off x="3931920" y="2999232"/>
-            <a:ext cx="2011680" cy="603504"/>
+            <a:off x="3931920" y="2916936"/>
+            <a:ext cx="2011680" cy="566928"/>
           </a:xfrm>
           <a:prstGeom prst="rect">
             <a:avLst/>
@@ -6731,8 +6914,8 @@
         </p:nvSpPr>
         <p:spPr>
           <a:xfrm>
-            <a:off x="5852160" y="2999232"/>
-            <a:ext cx="2011680" cy="603504"/>
+            <a:off x="5852160" y="2916936"/>
+            <a:ext cx="2011680" cy="566928"/>
           </a:xfrm>
           <a:prstGeom prst="rect">
             <a:avLst/>
@@ -6773,8 +6956,8 @@
         </p:nvSpPr>
         <p:spPr>
           <a:xfrm>
-            <a:off x="8001000" y="2999232"/>
-            <a:ext cx="2011680" cy="603504"/>
+            <a:off x="8001000" y="2916936"/>
+            <a:ext cx="2011680" cy="566928"/>
           </a:xfrm>
           <a:prstGeom prst="rect">
             <a:avLst/>
@@ -6815,8 +6998,8 @@
         </p:nvSpPr>
         <p:spPr>
           <a:xfrm>
-            <a:off x="9692640" y="2999232"/>
-            <a:ext cx="2011680" cy="603504"/>
+            <a:off x="9692640" y="2916936"/>
+            <a:ext cx="2011680" cy="566928"/>
           </a:xfrm>
           <a:prstGeom prst="rect">
             <a:avLst/>
@@ -6857,8 +7040,8 @@
         </p:nvSpPr>
         <p:spPr>
           <a:xfrm>
-            <a:off x="640080" y="3712464"/>
-            <a:ext cx="10927080" cy="603504"/>
+            <a:off x="640080" y="3593592"/>
+            <a:ext cx="10927080" cy="566928"/>
           </a:xfrm>
           <a:prstGeom prst="roundRect">
             <a:avLst>
@@ -6903,8 +7086,8 @@
         </p:nvSpPr>
         <p:spPr>
           <a:xfrm>
-            <a:off x="868680" y="3712464"/>
-            <a:ext cx="3017520" cy="603504"/>
+            <a:off x="868680" y="3593592"/>
+            <a:ext cx="3017520" cy="566928"/>
           </a:xfrm>
           <a:prstGeom prst="rect">
             <a:avLst/>
@@ -6945,8 +7128,8 @@
         </p:nvSpPr>
         <p:spPr>
           <a:xfrm>
-            <a:off x="3931920" y="3712464"/>
-            <a:ext cx="2011680" cy="603504"/>
+            <a:off x="3931920" y="3593592"/>
+            <a:ext cx="2011680" cy="566928"/>
           </a:xfrm>
           <a:prstGeom prst="rect">
             <a:avLst/>
@@ -6987,8 +7170,8 @@
         </p:nvSpPr>
         <p:spPr>
           <a:xfrm>
-            <a:off x="5852160" y="3712464"/>
-            <a:ext cx="2011680" cy="603504"/>
+            <a:off x="5852160" y="3593592"/>
+            <a:ext cx="2011680" cy="566928"/>
           </a:xfrm>
           <a:prstGeom prst="rect">
             <a:avLst/>
@@ -7029,8 +7212,8 @@
         </p:nvSpPr>
         <p:spPr>
           <a:xfrm>
-            <a:off x="8001000" y="3712464"/>
-            <a:ext cx="2011680" cy="603504"/>
+            <a:off x="8001000" y="3593592"/>
+            <a:ext cx="2011680" cy="566928"/>
           </a:xfrm>
           <a:prstGeom prst="rect">
             <a:avLst/>
@@ -7071,8 +7254,8 @@
         </p:nvSpPr>
         <p:spPr>
           <a:xfrm>
-            <a:off x="9692640" y="3712464"/>
-            <a:ext cx="2011680" cy="603504"/>
+            <a:off x="9692640" y="3593592"/>
+            <a:ext cx="2011680" cy="566928"/>
           </a:xfrm>
           <a:prstGeom prst="rect">
             <a:avLst/>
@@ -7113,8 +7296,8 @@
         </p:nvSpPr>
         <p:spPr>
           <a:xfrm>
-            <a:off x="640080" y="4425696"/>
-            <a:ext cx="10927080" cy="603504"/>
+            <a:off x="640080" y="4270248"/>
+            <a:ext cx="10927080" cy="566928"/>
           </a:xfrm>
           <a:prstGeom prst="roundRect">
             <a:avLst>
@@ -7122,7 +7305,7 @@
             </a:avLst>
           </a:prstGeom>
           <a:solidFill>
-            <a:srgbClr val="244A30"/>
+            <a:srgbClr val="FFFFFF"/>
           </a:solidFill>
           <a:ln>
             <a:noFill/>
@@ -7159,8 +7342,8 @@
         </p:nvSpPr>
         <p:spPr>
           <a:xfrm>
-            <a:off x="868680" y="4425696"/>
-            <a:ext cx="3017520" cy="603504"/>
+            <a:off x="868680" y="4270248"/>
+            <a:ext cx="3017520" cy="566928"/>
           </a:xfrm>
           <a:prstGeom prst="rect">
             <a:avLst/>
@@ -7184,11 +7367,11 @@
             <a:r>
               <a:rPr sz="1600" b="1">
                 <a:solidFill>
-                  <a:srgbClr val="FFFFFF"/>
+                  <a:srgbClr val="1C261E"/>
                 </a:solidFill>
                 <a:latin typeface="Montserrat"/>
               </a:rPr>
-              <a:t>Būvgružu birža</a:t>
+              <a:t>CleanR apmaiņas punkts</a:t>
             </a:r>
           </a:p>
         </p:txBody>
@@ -7201,8 +7384,8 @@
         </p:nvSpPr>
         <p:spPr>
           <a:xfrm>
-            <a:off x="3931920" y="4425696"/>
-            <a:ext cx="2011680" cy="603504"/>
+            <a:off x="3931920" y="4270248"/>
+            <a:ext cx="2011680" cy="566928"/>
           </a:xfrm>
           <a:prstGeom prst="rect">
             <a:avLst/>
@@ -7226,7 +7409,7 @@
             <a:r>
               <a:rPr sz="1500" b="1">
                 <a:solidFill>
-                  <a:srgbClr val="FFFFFF"/>
+                  <a:srgbClr val="5E8C5A"/>
                 </a:solidFill>
                 <a:latin typeface="Open Sans"/>
               </a:rPr>
@@ -7243,8 +7426,8 @@
         </p:nvSpPr>
         <p:spPr>
           <a:xfrm>
-            <a:off x="5852160" y="4425696"/>
-            <a:ext cx="2011680" cy="603504"/>
+            <a:off x="5852160" y="4270248"/>
+            <a:ext cx="2011680" cy="566928"/>
           </a:xfrm>
           <a:prstGeom prst="rect">
             <a:avLst/>
@@ -7266,13 +7449,13 @@
               </a:spcAft>
             </a:pPr>
             <a:r>
-              <a:rPr sz="1500" b="1">
-                <a:solidFill>
-                  <a:srgbClr val="FFFFFF"/>
+              <a:rPr sz="1500" b="0">
+                <a:solidFill>
+                  <a:srgbClr val="5B665D"/>
                 </a:solidFill>
                 <a:latin typeface="Open Sans"/>
               </a:rPr>
-              <a:t>Karte + pārvadātājs</a:t>
+              <a:t>Viens punkts</a:t>
             </a:r>
           </a:p>
         </p:txBody>
@@ -7285,8 +7468,8 @@
         </p:nvSpPr>
         <p:spPr>
           <a:xfrm>
-            <a:off x="8001000" y="4425696"/>
-            <a:ext cx="2011680" cy="603504"/>
+            <a:off x="8001000" y="4270248"/>
+            <a:ext cx="2011680" cy="566928"/>
           </a:xfrm>
           <a:prstGeom prst="rect">
             <a:avLst/>
@@ -7308,13 +7491,13 @@
               </a:spcAft>
             </a:pPr>
             <a:r>
-              <a:rPr sz="1500" b="1">
-                <a:solidFill>
-                  <a:srgbClr val="FFFFFF"/>
+              <a:rPr sz="1500" b="0">
+                <a:solidFill>
+                  <a:srgbClr val="5B665D"/>
                 </a:solidFill>
                 <a:latin typeface="Open Sans"/>
               </a:rPr>
-              <a:t>Jā</a:t>
+              <a:t>Šķembas</a:t>
             </a:r>
           </a:p>
         </p:txBody>
@@ -7327,8 +7510,8 @@
         </p:nvSpPr>
         <p:spPr>
           <a:xfrm>
-            <a:off x="9692640" y="4425696"/>
-            <a:ext cx="2011680" cy="603504"/>
+            <a:off x="9692640" y="4270248"/>
+            <a:ext cx="2011680" cy="566928"/>
           </a:xfrm>
           <a:prstGeom prst="rect">
             <a:avLst/>
@@ -7352,8 +7535,138 @@
             <a:r>
               <a:rPr sz="1500" b="1">
                 <a:solidFill>
+                  <a:srgbClr val="5E8C5A"/>
+                </a:solidFill>
+                <a:latin typeface="Open Sans"/>
+              </a:rPr>
+              <a:t>Jā</a:t>
+            </a:r>
+          </a:p>
+        </p:txBody>
+      </p:sp>
+      <p:sp>
+        <p:nvSpPr>
+          <p:cNvPr id="32" name="Rounded Rectangle 31"/>
+          <p:cNvSpPr/>
+          <p:nvPr/>
+        </p:nvSpPr>
+        <p:spPr>
+          <a:xfrm>
+            <a:off x="640080" y="4946904"/>
+            <a:ext cx="10927080" cy="566928"/>
+          </a:xfrm>
+          <a:prstGeom prst="roundRect">
+            <a:avLst>
+              <a:gd name="adj" fmla="val 8000"/>
+            </a:avLst>
+          </a:prstGeom>
+          <a:solidFill>
+            <a:srgbClr val="244A30"/>
+          </a:solidFill>
+          <a:ln>
+            <a:noFill/>
+          </a:ln>
+          <a:effectLst/>
+        </p:spPr>
+        <p:style>
+          <a:lnRef idx="1">
+            <a:schemeClr val="accent1"/>
+          </a:lnRef>
+          <a:fillRef idx="3">
+            <a:schemeClr val="accent1"/>
+          </a:fillRef>
+          <a:effectRef idx="2">
+            <a:schemeClr val="accent1"/>
+          </a:effectRef>
+          <a:fontRef idx="minor">
+            <a:schemeClr val="lt1"/>
+          </a:fontRef>
+        </p:style>
+        <p:txBody>
+          <a:bodyPr rtlCol="0" anchor="ctr"/>
+          <a:lstStyle/>
+          <a:p>
+            <a:pPr algn="ctr"/>
+          </a:p>
+        </p:txBody>
+      </p:sp>
+      <p:sp>
+        <p:nvSpPr>
+          <p:cNvPr id="33" name="TextBox 32"/>
+          <p:cNvSpPr txBox="1"/>
+          <p:nvPr/>
+        </p:nvSpPr>
+        <p:spPr>
+          <a:xfrm>
+            <a:off x="868680" y="4946904"/>
+            <a:ext cx="3017520" cy="566928"/>
+          </a:xfrm>
+          <a:prstGeom prst="rect">
+            <a:avLst/>
+          </a:prstGeom>
+          <a:noFill/>
+        </p:spPr>
+        <p:txBody>
+          <a:bodyPr wrap="square" anchor="ctr" lIns="0" rIns="0" tIns="0" bIns="0">
+            <a:spAutoFit/>
+          </a:bodyPr>
+          <a:lstStyle/>
+          <a:p>
+            <a:pPr algn="l">
+              <a:lnSpc>
+                <a:spcPct val="110000"/>
+              </a:lnSpc>
+              <a:spcAft>
+                <a:spcPts val="600"/>
+              </a:spcAft>
+            </a:pPr>
+            <a:r>
+              <a:rPr sz="1600" b="1">
+                <a:solidFill>
                   <a:srgbClr val="FFFFFF"/>
                 </a:solidFill>
+                <a:latin typeface="Montserrat"/>
+              </a:rPr>
+              <a:t>Būvgružu birža</a:t>
+            </a:r>
+          </a:p>
+        </p:txBody>
+      </p:sp>
+      <p:sp>
+        <p:nvSpPr>
+          <p:cNvPr id="34" name="TextBox 33"/>
+          <p:cNvSpPr txBox="1"/>
+          <p:nvPr/>
+        </p:nvSpPr>
+        <p:spPr>
+          <a:xfrm>
+            <a:off x="3931920" y="4946904"/>
+            <a:ext cx="2011680" cy="566928"/>
+          </a:xfrm>
+          <a:prstGeom prst="rect">
+            <a:avLst/>
+          </a:prstGeom>
+          <a:noFill/>
+        </p:spPr>
+        <p:txBody>
+          <a:bodyPr wrap="square" anchor="ctr" lIns="0" rIns="0" tIns="0" bIns="0">
+            <a:spAutoFit/>
+          </a:bodyPr>
+          <a:lstStyle/>
+          <a:p>
+            <a:pPr algn="l">
+              <a:lnSpc>
+                <a:spcPct val="110000"/>
+              </a:lnSpc>
+              <a:spcAft>
+                <a:spcPts val="600"/>
+              </a:spcAft>
+            </a:pPr>
+            <a:r>
+              <a:rPr sz="1500" b="1">
+                <a:solidFill>
+                  <a:srgbClr val="FFFFFF"/>
+                </a:solidFill>
                 <a:latin typeface="Open Sans"/>
               </a:rPr>
               <a:t>Jā</a:t>
@@ -7363,13 +7676,139 @@
       </p:sp>
       <p:sp>
         <p:nvSpPr>
-          <p:cNvPr id="32" name="TextBox 31"/>
+          <p:cNvPr id="35" name="TextBox 34"/>
           <p:cNvSpPr txBox="1"/>
           <p:nvPr/>
         </p:nvSpPr>
         <p:spPr>
           <a:xfrm>
-            <a:off x="640080" y="5349240"/>
+            <a:off x="5852160" y="4946904"/>
+            <a:ext cx="2011680" cy="566928"/>
+          </a:xfrm>
+          <a:prstGeom prst="rect">
+            <a:avLst/>
+          </a:prstGeom>
+          <a:noFill/>
+        </p:spPr>
+        <p:txBody>
+          <a:bodyPr wrap="square" anchor="ctr" lIns="0" rIns="0" tIns="0" bIns="0">
+            <a:spAutoFit/>
+          </a:bodyPr>
+          <a:lstStyle/>
+          <a:p>
+            <a:pPr algn="l">
+              <a:lnSpc>
+                <a:spcPct val="110000"/>
+              </a:lnSpc>
+              <a:spcAft>
+                <a:spcPts val="600"/>
+              </a:spcAft>
+            </a:pPr>
+            <a:r>
+              <a:rPr sz="1500" b="1">
+                <a:solidFill>
+                  <a:srgbClr val="FFFFFF"/>
+                </a:solidFill>
+                <a:latin typeface="Open Sans"/>
+              </a:rPr>
+              <a:t>Karte + pārvadātājs</a:t>
+            </a:r>
+          </a:p>
+        </p:txBody>
+      </p:sp>
+      <p:sp>
+        <p:nvSpPr>
+          <p:cNvPr id="36" name="TextBox 35"/>
+          <p:cNvSpPr txBox="1"/>
+          <p:nvPr/>
+        </p:nvSpPr>
+        <p:spPr>
+          <a:xfrm>
+            <a:off x="8001000" y="4946904"/>
+            <a:ext cx="2011680" cy="566928"/>
+          </a:xfrm>
+          <a:prstGeom prst="rect">
+            <a:avLst/>
+          </a:prstGeom>
+          <a:noFill/>
+        </p:spPr>
+        <p:txBody>
+          <a:bodyPr wrap="square" anchor="ctr" lIns="0" rIns="0" tIns="0" bIns="0">
+            <a:spAutoFit/>
+          </a:bodyPr>
+          <a:lstStyle/>
+          <a:p>
+            <a:pPr algn="l">
+              <a:lnSpc>
+                <a:spcPct val="110000"/>
+              </a:lnSpc>
+              <a:spcAft>
+                <a:spcPts val="600"/>
+              </a:spcAft>
+            </a:pPr>
+            <a:r>
+              <a:rPr sz="1500" b="1">
+                <a:solidFill>
+                  <a:srgbClr val="FFFFFF"/>
+                </a:solidFill>
+                <a:latin typeface="Open Sans"/>
+              </a:rPr>
+              <a:t>Jā</a:t>
+            </a:r>
+          </a:p>
+        </p:txBody>
+      </p:sp>
+      <p:sp>
+        <p:nvSpPr>
+          <p:cNvPr id="37" name="TextBox 36"/>
+          <p:cNvSpPr txBox="1"/>
+          <p:nvPr/>
+        </p:nvSpPr>
+        <p:spPr>
+          <a:xfrm>
+            <a:off x="9692640" y="4946904"/>
+            <a:ext cx="2011680" cy="566928"/>
+          </a:xfrm>
+          <a:prstGeom prst="rect">
+            <a:avLst/>
+          </a:prstGeom>
+          <a:noFill/>
+        </p:spPr>
+        <p:txBody>
+          <a:bodyPr wrap="square" anchor="ctr" lIns="0" rIns="0" tIns="0" bIns="0">
+            <a:spAutoFit/>
+          </a:bodyPr>
+          <a:lstStyle/>
+          <a:p>
+            <a:pPr algn="l">
+              <a:lnSpc>
+                <a:spcPct val="110000"/>
+              </a:lnSpc>
+              <a:spcAft>
+                <a:spcPts val="600"/>
+              </a:spcAft>
+            </a:pPr>
+            <a:r>
+              <a:rPr sz="1500" b="1">
+                <a:solidFill>
+                  <a:srgbClr val="FFFFFF"/>
+                </a:solidFill>
+                <a:latin typeface="Open Sans"/>
+              </a:rPr>
+              <a:t>Jā</a:t>
+            </a:r>
+          </a:p>
+        </p:txBody>
+      </p:sp>
+      <p:sp>
+        <p:nvSpPr>
+          <p:cNvPr id="38" name="TextBox 37"/>
+          <p:cNvSpPr txBox="1"/>
+          <p:nvPr/>
+        </p:nvSpPr>
+        <p:spPr>
+          <a:xfrm>
+            <a:off x="640080" y="5760720"/>
             <a:ext cx="10927080" cy="274320"/>
           </a:xfrm>
           <a:prstGeom prst="rect">
@@ -7617,6 +8056,888 @@
                 <a:latin typeface="Open Sans"/>
               </a:rPr>
               <a:t>Paldies! Jautājumi?</a:t>
+            </a:r>
+          </a:p>
+        </p:txBody>
+      </p:sp>
+    </p:spTree>
+  </p:cSld>
+  <p:clrMapOvr>
+    <a:masterClrMapping/>
+  </p:clrMapOvr>
+</p:sld>
+</file>
+
+<file path=ppt/slides/slide6.xml><?xml version="1.0" encoding="utf-8"?>
+<p:sld xmlns:a="http://schemas.openxmlformats.org/drawingml/2006/main" xmlns:p="http://schemas.openxmlformats.org/presentationml/2006/main" xmlns:r="http://schemas.openxmlformats.org/officeDocument/2006/relationships">
+  <p:cSld>
+    <p:bg>
+      <p:bgPr>
+        <a:solidFill>
+          <a:srgbClr val="EEF3EA"/>
+        </a:solidFill>
+        <a:effectLst/>
+      </p:bgPr>
+    </p:bg>
+    <p:spTree>
+      <p:nvGrpSpPr>
+        <p:cNvPr id="1" name=""/>
+        <p:cNvGrpSpPr/>
+        <p:nvPr/>
+      </p:nvGrpSpPr>
+      <p:grpSpPr/>
+      <p:sp>
+        <p:nvSpPr>
+          <p:cNvPr id="2" name="TextBox 1"/>
+          <p:cNvSpPr txBox="1"/>
+          <p:nvPr/>
+        </p:nvSpPr>
+        <p:spPr>
+          <a:xfrm>
+            <a:off x="640080" y="411480"/>
+            <a:ext cx="7315200" cy="365760"/>
+          </a:xfrm>
+          <a:prstGeom prst="rect">
+            <a:avLst/>
+          </a:prstGeom>
+          <a:noFill/>
+        </p:spPr>
+        <p:txBody>
+          <a:bodyPr wrap="square" anchor="t" lIns="0" rIns="0" tIns="0" bIns="0">
+            <a:spAutoFit/>
+          </a:bodyPr>
+          <a:lstStyle/>
+          <a:p>
+            <a:pPr algn="l">
+              <a:lnSpc>
+                <a:spcPct val="110000"/>
+              </a:lnSpc>
+              <a:spcAft>
+                <a:spcPts val="600"/>
+              </a:spcAft>
+            </a:pPr>
+            <a:r>
+              <a:rPr sz="1300" b="1">
+                <a:solidFill>
+                  <a:srgbClr val="5E8C5A"/>
+                </a:solidFill>
+                <a:latin typeface="Montserrat"/>
+              </a:rPr>
+              <a:t>PIELIKUMS</a:t>
+            </a:r>
+          </a:p>
+        </p:txBody>
+      </p:sp>
+      <p:sp>
+        <p:nvSpPr>
+          <p:cNvPr id="3" name="TextBox 2"/>
+          <p:cNvSpPr txBox="1"/>
+          <p:nvPr/>
+        </p:nvSpPr>
+        <p:spPr>
+          <a:xfrm>
+            <a:off x="640080" y="685800"/>
+            <a:ext cx="10972800" cy="548640"/>
+          </a:xfrm>
+          <a:prstGeom prst="rect">
+            <a:avLst/>
+          </a:prstGeom>
+          <a:noFill/>
+        </p:spPr>
+        <p:txBody>
+          <a:bodyPr wrap="square" anchor="t" lIns="0" rIns="0" tIns="0" bIns="0">
+            <a:spAutoFit/>
+          </a:bodyPr>
+          <a:lstStyle/>
+          <a:p>
+            <a:pPr algn="l">
+              <a:lnSpc>
+                <a:spcPct val="110000"/>
+              </a:lnSpc>
+              <a:spcAft>
+                <a:spcPts val="600"/>
+              </a:spcAft>
+            </a:pPr>
+            <a:r>
+              <a:rPr sz="2600" b="1">
+                <a:solidFill>
+                  <a:srgbClr val="244A30"/>
+                </a:solidFill>
+                <a:latin typeface="Montserrat"/>
+              </a:rPr>
+              <a:t>Avoti</a:t>
+            </a:r>
+          </a:p>
+        </p:txBody>
+      </p:sp>
+      <p:sp>
+        <p:nvSpPr>
+          <p:cNvPr id="4" name="TextBox 3"/>
+          <p:cNvSpPr txBox="1"/>
+          <p:nvPr/>
+        </p:nvSpPr>
+        <p:spPr>
+          <a:xfrm>
+            <a:off x="640080" y="1371600"/>
+            <a:ext cx="3520440" cy="5303520"/>
+          </a:xfrm>
+          <a:prstGeom prst="rect">
+            <a:avLst/>
+          </a:prstGeom>
+          <a:noFill/>
+        </p:spPr>
+        <p:txBody>
+          <a:bodyPr wrap="square" anchor="t" lIns="0" rIns="0" tIns="0" bIns="0">
+            <a:spAutoFit/>
+          </a:bodyPr>
+          <a:lstStyle/>
+          <a:p>
+            <a:pPr algn="l">
+              <a:lnSpc>
+                <a:spcPct val="100000"/>
+              </a:lnSpc>
+              <a:spcAft>
+                <a:spcPts val="400"/>
+              </a:spcAft>
+            </a:pPr>
+            <a:r>
+              <a:rPr sz="750" b="0">
+                <a:solidFill>
+                  <a:srgbClr val="1C261E"/>
+                </a:solidFill>
+                <a:latin typeface="Open Sans"/>
+              </a:rPr>
+              <a:t>1. AST. (2026). Electricity Market Review. https://www.ast.lv/en/electricity-market-review</a:t>
+            </a:r>
+          </a:p>
+          <a:p>
+            <a:pPr algn="l">
+              <a:lnSpc>
+                <a:spcPct val="100000"/>
+              </a:lnSpc>
+              <a:spcAft>
+                <a:spcPts val="400"/>
+              </a:spcAft>
+            </a:pPr>
+            <a:r>
+              <a:rPr sz="750" b="0">
+                <a:solidFill>
+                  <a:srgbClr val="1C261E"/>
+                </a:solidFill>
+                <a:latin typeface="Open Sans"/>
+              </a:rPr>
+              <a:t>2. BB.LV. (2026. gada 12. janvāris). The necessity forces the crushing of construction waste. https://en.bb.lv/article/business/2026/01/12/the-necessity-forces-the-crushing-of-construction-waste-84169</a:t>
+            </a:r>
+          </a:p>
+          <a:p>
+            <a:pPr algn="l">
+              <a:lnSpc>
+                <a:spcPct val="100000"/>
+              </a:lnSpc>
+              <a:spcAft>
+                <a:spcPts val="400"/>
+              </a:spcAft>
+            </a:pPr>
+            <a:r>
+              <a:rPr sz="750" b="0">
+                <a:solidFill>
+                  <a:srgbClr val="1C261E"/>
+                </a:solidFill>
+                <a:latin typeface="Open Sans"/>
+              </a:rPr>
+              <a:t>3. Būvgružu Pārstrāde. (b. g.). Uzņēmuma mājaslapa. https://www.buvgruzup-parstrade.lv/</a:t>
+            </a:r>
+          </a:p>
+          <a:p>
+            <a:pPr algn="l">
+              <a:lnSpc>
+                <a:spcPct val="100000"/>
+              </a:lnSpc>
+              <a:spcAft>
+                <a:spcPts val="400"/>
+              </a:spcAft>
+            </a:pPr>
+            <a:r>
+              <a:rPr sz="750" b="0">
+                <a:solidFill>
+                  <a:srgbClr val="1C261E"/>
+                </a:solidFill>
+                <a:latin typeface="Open Sans"/>
+              </a:rPr>
+              <a:t>4. CleanR. (b. g.). Uzņēmuma mājaslapa. https://cleanr.lv/</a:t>
+            </a:r>
+          </a:p>
+          <a:p>
+            <a:pPr algn="l">
+              <a:lnSpc>
+                <a:spcPct val="100000"/>
+              </a:lnSpc>
+              <a:spcAft>
+                <a:spcPts val="400"/>
+              </a:spcAft>
+            </a:pPr>
+            <a:r>
+              <a:rPr sz="750" b="0">
+                <a:solidFill>
+                  <a:srgbClr val="1C261E"/>
+                </a:solidFill>
+                <a:latin typeface="Open Sans"/>
+              </a:rPr>
+              <a:t>5. Datreal. (b. g.). SIA "Būvgružu Pārstrāde" finanšu dati. https://datreal.com/en/lv/company/40003336873</a:t>
+            </a:r>
+          </a:p>
+          <a:p>
+            <a:pPr algn="l">
+              <a:lnSpc>
+                <a:spcPct val="100000"/>
+              </a:lnSpc>
+              <a:spcAft>
+                <a:spcPts val="400"/>
+              </a:spcAft>
+            </a:pPr>
+            <a:r>
+              <a:rPr sz="750" b="0">
+                <a:solidFill>
+                  <a:srgbClr val="1C261E"/>
+                </a:solidFill>
+                <a:latin typeface="Open Sans"/>
+              </a:rPr>
+              <a:t>6. Datreal. (b. g.). SIA "Kronospan Riga" finanšu dati. https://datreal.com/en/lv/company/40003774690</a:t>
+            </a:r>
+          </a:p>
+          <a:p>
+            <a:pPr algn="l">
+              <a:lnSpc>
+                <a:spcPct val="100000"/>
+              </a:lnSpc>
+              <a:spcAft>
+                <a:spcPts val="400"/>
+              </a:spcAft>
+            </a:pPr>
+            <a:r>
+              <a:rPr sz="750" b="0">
+                <a:solidFill>
+                  <a:srgbClr val="1C261E"/>
+                </a:solidFill>
+                <a:latin typeface="Open Sans"/>
+              </a:rPr>
+              <a:t>7. Gamle Mursten. (b. g.). Uzņēmuma mājaslapa. https://gamlemursten.dk/</a:t>
+            </a:r>
+          </a:p>
+          <a:p>
+            <a:pPr algn="l">
+              <a:lnSpc>
+                <a:spcPct val="100000"/>
+              </a:lnSpc>
+              <a:spcAft>
+                <a:spcPts val="400"/>
+              </a:spcAft>
+            </a:pPr>
+            <a:r>
+              <a:rPr sz="750" b="0">
+                <a:solidFill>
+                  <a:srgbClr val="1C261E"/>
+                </a:solidFill>
+                <a:latin typeface="Open Sans"/>
+              </a:rPr>
+              <a:t>8. Godrej Construction. (b. g.). Uzņēmuma mājaslapa. https://www.godrejconstruction.com/</a:t>
+            </a:r>
+          </a:p>
+          <a:p>
+            <a:pPr algn="l">
+              <a:lnSpc>
+                <a:spcPct val="100000"/>
+              </a:lnSpc>
+              <a:spcAft>
+                <a:spcPts val="400"/>
+              </a:spcAft>
+            </a:pPr>
+            <a:r>
+              <a:rPr sz="750" b="0">
+                <a:solidFill>
+                  <a:srgbClr val="1C261E"/>
+                </a:solidFill>
+                <a:latin typeface="Open Sans"/>
+              </a:rPr>
+              <a:t>9. Godrej Group. (b. g.). Uzņēmuma mājaslapa. https://www.godrej.com/</a:t>
+            </a:r>
+          </a:p>
+          <a:p>
+            <a:pPr algn="l">
+              <a:lnSpc>
+                <a:spcPct val="100000"/>
+              </a:lnSpc>
+              <a:spcAft>
+                <a:spcPts val="400"/>
+              </a:spcAft>
+            </a:pPr>
+            <a:r>
+              <a:rPr sz="750" b="0">
+                <a:solidFill>
+                  <a:srgbClr val="1C261E"/>
+                </a:solidFill>
+                <a:latin typeface="Open Sans"/>
+              </a:rPr>
+              <a:t>10. Heidelberg Materials. (b. g.). Uzņēmuma mājaslapa. https://www.heidelbergmaterials.com/</a:t>
+            </a:r>
+          </a:p>
+          <a:p>
+            <a:pPr algn="l">
+              <a:lnSpc>
+                <a:spcPct val="100000"/>
+              </a:lnSpc>
+              <a:spcAft>
+                <a:spcPts val="400"/>
+              </a:spcAft>
+            </a:pPr>
+            <a:r>
+              <a:rPr sz="750" b="0">
+                <a:solidFill>
+                  <a:srgbClr val="1C261E"/>
+                </a:solidFill>
+                <a:latin typeface="Open Sans"/>
+              </a:rPr>
+              <a:t>11. Heidelberg Materials Polska. (b. g.). Uzņēmuma mājaslapa. https://www.heidelbergmaterials.pl/</a:t>
+            </a:r>
+          </a:p>
+          <a:p>
+            <a:pPr algn="l">
+              <a:lnSpc>
+                <a:spcPct val="100000"/>
+              </a:lnSpc>
+              <a:spcAft>
+                <a:spcPts val="400"/>
+              </a:spcAft>
+            </a:pPr>
+            <a:r>
+              <a:rPr sz="750" b="0">
+                <a:solidFill>
+                  <a:srgbClr val="1C261E"/>
+                </a:solidFill>
+                <a:latin typeface="Open Sans"/>
+              </a:rPr>
+              <a:t>12. IGATE. (b. g.). Uzņēmuma mājaslapa. https://www.igate.lv/</a:t>
+            </a:r>
+          </a:p>
+          <a:p>
+            <a:pPr algn="l">
+              <a:lnSpc>
+                <a:spcPct val="100000"/>
+              </a:lnSpc>
+              <a:spcAft>
+                <a:spcPts val="400"/>
+              </a:spcAft>
+            </a:pPr>
+            <a:r>
+              <a:rPr sz="750" b="0">
+                <a:solidFill>
+                  <a:srgbClr val="1C261E"/>
+                </a:solidFill>
+                <a:latin typeface="Open Sans"/>
+              </a:rPr>
+              <a:t>13. Kenoteq. (b. g.). Uzņēmuma mājaslapa. https://www.kenoteq.com/</a:t>
+            </a:r>
+          </a:p>
+        </p:txBody>
+      </p:sp>
+      <p:sp>
+        <p:nvSpPr>
+          <p:cNvPr id="5" name="TextBox 4"/>
+          <p:cNvSpPr txBox="1"/>
+          <p:nvPr/>
+        </p:nvSpPr>
+        <p:spPr>
+          <a:xfrm>
+            <a:off x="4343400" y="1371600"/>
+            <a:ext cx="3520440" cy="5303520"/>
+          </a:xfrm>
+          <a:prstGeom prst="rect">
+            <a:avLst/>
+          </a:prstGeom>
+          <a:noFill/>
+        </p:spPr>
+        <p:txBody>
+          <a:bodyPr wrap="square" anchor="t" lIns="0" rIns="0" tIns="0" bIns="0">
+            <a:spAutoFit/>
+          </a:bodyPr>
+          <a:lstStyle/>
+          <a:p>
+            <a:pPr algn="l">
+              <a:lnSpc>
+                <a:spcPct val="100000"/>
+              </a:lnSpc>
+              <a:spcAft>
+                <a:spcPts val="400"/>
+              </a:spcAft>
+            </a:pPr>
+            <a:r>
+              <a:rPr sz="750" b="0">
+                <a:solidFill>
+                  <a:srgbClr val="1C261E"/>
+                </a:solidFill>
+                <a:latin typeface="Open Sans"/>
+              </a:rPr>
+              <a:t>14. Kronospan. (b. g.). Uzņēmuma mājaslapa. https://kronospan.com/</a:t>
+            </a:r>
+          </a:p>
+          <a:p>
+            <a:pPr algn="l">
+              <a:lnSpc>
+                <a:spcPct val="100000"/>
+              </a:lnSpc>
+              <a:spcAft>
+                <a:spcPts val="400"/>
+              </a:spcAft>
+            </a:pPr>
+            <a:r>
+              <a:rPr sz="750" b="0">
+                <a:solidFill>
+                  <a:srgbClr val="1C261E"/>
+                </a:solidFill>
+                <a:latin typeface="Open Sans"/>
+              </a:rPr>
+              <a:t>15. Kuldīgas komunālie pakalpojumi. (b. g.). Uzņēmuma mājaslapa. https://www.kkp.lv/</a:t>
+            </a:r>
+          </a:p>
+          <a:p>
+            <a:pPr algn="l">
+              <a:lnSpc>
+                <a:spcPct val="100000"/>
+              </a:lnSpc>
+              <a:spcAft>
+                <a:spcPts val="400"/>
+              </a:spcAft>
+            </a:pPr>
+            <a:r>
+              <a:rPr sz="750" b="0">
+                <a:solidFill>
+                  <a:srgbClr val="1C261E"/>
+                </a:solidFill>
+                <a:latin typeface="Open Sans"/>
+              </a:rPr>
+              <a:t>16. Latvijas Sabiedriskais medijs. (2023. gada 19. septembris). Cementa ražotne Brocēnos izmantos arī saules ražotu elektroenerģiju. https://www.lsm.lv/raksts/zinas/ekonomika/19.09.2023-cementa-razotne-brocenos-izmantos-ari-saules-razotu-elektroenergiju.a524561/</a:t>
+            </a:r>
+          </a:p>
+          <a:p>
+            <a:pPr algn="l">
+              <a:lnSpc>
+                <a:spcPct val="100000"/>
+              </a:lnSpc>
+              <a:spcAft>
+                <a:spcPts val="400"/>
+              </a:spcAft>
+            </a:pPr>
+            <a:r>
+              <a:rPr sz="750" b="0">
+                <a:solidFill>
+                  <a:srgbClr val="1C261E"/>
+                </a:solidFill>
+                <a:latin typeface="Open Sans"/>
+              </a:rPr>
+              <a:t>17. Latvijas Sabiedriskais medijs. (2023. gada 27. novembris). Bez maksas nodot būvgružus, saņemt sev celtniecībā noderīgo: kā tas strādā. https://www.lsm.lv/raksts/dzive--stils/vide-un-dzivnieki/27.11.2023-bez-maksas-nodot-buvgruzus-sanemt-sev-celtnieciba-noderigo-ka-tas-strada.a533151/</a:t>
+            </a:r>
+          </a:p>
+          <a:p>
+            <a:pPr algn="l">
+              <a:lnSpc>
+                <a:spcPct val="100000"/>
+              </a:lnSpc>
+              <a:spcAft>
+                <a:spcPts val="400"/>
+              </a:spcAft>
+            </a:pPr>
+            <a:r>
+              <a:rPr sz="750" b="0">
+                <a:solidFill>
+                  <a:srgbClr val="1C261E"/>
+                </a:solidFill>
+                <a:latin typeface="Open Sans"/>
+              </a:rPr>
+              <a:t>18. Latvijas Būvnieku asociācija. (2023. gada 14. jūnijs). SCHWENK pieredzes stāsts: semināra prezentācija. https://www.latvijasbuvnieki.lv/wp-content/uploads/2023/06/schwenk-pieredzes-stasts-seminars-1406-copy-1.pdf</a:t>
+            </a:r>
+          </a:p>
+          <a:p>
+            <a:pPr algn="l">
+              <a:lnSpc>
+                <a:spcPct val="100000"/>
+              </a:lnSpc>
+              <a:spcAft>
+                <a:spcPts val="400"/>
+              </a:spcAft>
+            </a:pPr>
+            <a:r>
+              <a:rPr sz="750" b="0">
+                <a:solidFill>
+                  <a:srgbClr val="1C261E"/>
+                </a:solidFill>
+                <a:latin typeface="Open Sans"/>
+              </a:rPr>
+              <a:t>19. Mavļutova, I., u. c. (2024). Management of Household-Generated Construction and Demolition Waste: Circularity Principles and the Attitude of Latvian Residents. Energies, 17(1), 205. https://doi.org/10.3390/en17010205</a:t>
+            </a:r>
+          </a:p>
+          <a:p>
+            <a:pPr algn="l">
+              <a:lnSpc>
+                <a:spcPct val="100000"/>
+              </a:lnSpc>
+              <a:spcAft>
+                <a:spcPts val="400"/>
+              </a:spcAft>
+            </a:pPr>
+            <a:r>
+              <a:rPr sz="750" b="0">
+                <a:solidFill>
+                  <a:srgbClr val="1C261E"/>
+                </a:solidFill>
+                <a:latin typeface="Open Sans"/>
+              </a:rPr>
+              <a:t>20. New Horizon. (b. g.). Uzņēmuma mājaslapa. https://www.newhorizon.nl/</a:t>
+            </a:r>
+          </a:p>
+          <a:p>
+            <a:pPr algn="l">
+              <a:lnSpc>
+                <a:spcPct val="100000"/>
+              </a:lnSpc>
+              <a:spcAft>
+                <a:spcPts val="400"/>
+              </a:spcAft>
+            </a:pPr>
+            <a:r>
+              <a:rPr sz="750" b="0">
+                <a:solidFill>
+                  <a:srgbClr val="1C261E"/>
+                </a:solidFill>
+                <a:latin typeface="Open Sans"/>
+              </a:rPr>
+              <a:t>21. Paarhammer. (b. g.). Uzņēmuma mājaslapa. https://www.paarhammer.com.au/</a:t>
+            </a:r>
+          </a:p>
+          <a:p>
+            <a:pPr algn="l">
+              <a:lnSpc>
+                <a:spcPct val="100000"/>
+              </a:lnSpc>
+              <a:spcAft>
+                <a:spcPts val="400"/>
+              </a:spcAft>
+            </a:pPr>
+            <a:r>
+              <a:rPr sz="750" b="0">
+                <a:solidFill>
+                  <a:srgbClr val="1C261E"/>
+                </a:solidFill>
+                <a:latin typeface="Open Sans"/>
+              </a:rPr>
+              <a:t>22. Rīgas Enerģētikas aģentūra. (b. g.). Aģentūras mājaslapa. https://rea.riga.lv/</a:t>
+            </a:r>
+          </a:p>
+          <a:p>
+            <a:pPr algn="l">
+              <a:lnSpc>
+                <a:spcPct val="100000"/>
+              </a:lnSpc>
+              <a:spcAft>
+                <a:spcPts val="400"/>
+              </a:spcAft>
+            </a:pPr>
+            <a:r>
+              <a:rPr sz="750" b="0">
+                <a:solidFill>
+                  <a:srgbClr val="1C261E"/>
+                </a:solidFill>
+                <a:latin typeface="Open Sans"/>
+              </a:rPr>
+              <a:t>23. Rīgas pašvaldība. (b. g.). Pašvaldības mājaslapa. https://www.riga.lv/</a:t>
+            </a:r>
+          </a:p>
+          <a:p>
+            <a:pPr algn="l">
+              <a:lnSpc>
+                <a:spcPct val="100000"/>
+              </a:lnSpc>
+              <a:spcAft>
+                <a:spcPts val="400"/>
+              </a:spcAft>
+            </a:pPr>
+            <a:r>
+              <a:rPr sz="750" b="0">
+                <a:solidFill>
+                  <a:srgbClr val="1C261E"/>
+                </a:solidFill>
+                <a:latin typeface="Open Sans"/>
+              </a:rPr>
+              <a:t>24. Rīgas siltums. (2025). Nerevidētais saīsinātais konsolidētais gada pārskats par gadu, kas noslēdzās 2025. gada 30. septembrī. https://www.rs.lv/sites/default/files/akardeons_fails/nerevidetais_saisinatais_konsolidetais_gada_parskats_par_gadu_kas_nosledzas_30_09_2025.pdf</a:t>
+            </a:r>
+          </a:p>
+          <a:p>
+            <a:pPr algn="l">
+              <a:lnSpc>
+                <a:spcPct val="100000"/>
+              </a:lnSpc>
+              <a:spcAft>
+                <a:spcPts val="400"/>
+              </a:spcAft>
+            </a:pPr>
+            <a:r>
+              <a:rPr sz="750" b="0">
+                <a:solidFill>
+                  <a:srgbClr val="1C261E"/>
+                </a:solidFill>
+                <a:latin typeface="Open Sans"/>
+              </a:rPr>
+              <a:t>25. Rudus. (b. g.). Uzņēmuma mājaslapa. https://www.rudus.fi/</a:t>
+            </a:r>
+          </a:p>
+          <a:p>
+            <a:pPr algn="l">
+              <a:lnSpc>
+                <a:spcPct val="100000"/>
+              </a:lnSpc>
+              <a:spcAft>
+                <a:spcPts val="400"/>
+              </a:spcAft>
+            </a:pPr>
+            <a:r>
+              <a:rPr sz="750" b="0">
+                <a:solidFill>
+                  <a:srgbClr val="1C261E"/>
+                </a:solidFill>
+                <a:latin typeface="Open Sans"/>
+              </a:rPr>
+              <a:t>26. SCHWENK Latvija. (b. g.). Alternatīvais kurināmais. https://schwenk.lv/en/?p=7452</a:t>
+            </a:r>
+          </a:p>
+        </p:txBody>
+      </p:sp>
+      <p:sp>
+        <p:nvSpPr>
+          <p:cNvPr id="6" name="TextBox 5"/>
+          <p:cNvSpPr txBox="1"/>
+          <p:nvPr/>
+        </p:nvSpPr>
+        <p:spPr>
+          <a:xfrm>
+            <a:off x="8046719" y="1371600"/>
+            <a:ext cx="3520440" cy="5303520"/>
+          </a:xfrm>
+          <a:prstGeom prst="rect">
+            <a:avLst/>
+          </a:prstGeom>
+          <a:noFill/>
+        </p:spPr>
+        <p:txBody>
+          <a:bodyPr wrap="square" anchor="t" lIns="0" rIns="0" tIns="0" bIns="0">
+            <a:spAutoFit/>
+          </a:bodyPr>
+          <a:lstStyle/>
+          <a:p>
+            <a:pPr algn="l">
+              <a:lnSpc>
+                <a:spcPct val="100000"/>
+              </a:lnSpc>
+              <a:spcAft>
+                <a:spcPts val="400"/>
+              </a:spcAft>
+            </a:pPr>
+            <a:r>
+              <a:rPr sz="750" b="0">
+                <a:solidFill>
+                  <a:srgbClr val="1C261E"/>
+                </a:solidFill>
+                <a:latin typeface="Open Sans"/>
+              </a:rPr>
+              <a:t>27. SCHWENK Latvija. (b. g.). Uzņēmuma mājaslapa. https://www.schwenk.lv/</a:t>
+            </a:r>
+          </a:p>
+          <a:p>
+            <a:pPr algn="l">
+              <a:lnSpc>
+                <a:spcPct val="100000"/>
+              </a:lnSpc>
+              <a:spcAft>
+                <a:spcPts val="400"/>
+              </a:spcAft>
+            </a:pPr>
+            <a:r>
+              <a:rPr sz="750" b="0">
+                <a:solidFill>
+                  <a:srgbClr val="1C261E"/>
+                </a:solidFill>
+                <a:latin typeface="Open Sans"/>
+              </a:rPr>
+              <a:t>28. Sitra. (b. g.). Ilgtspējīgas attīstības un aprites ekonomikas piemēri. https://www.sitra.fi/en/</a:t>
+            </a:r>
+          </a:p>
+          <a:p>
+            <a:pPr algn="l">
+              <a:lnSpc>
+                <a:spcPct val="100000"/>
+              </a:lnSpc>
+              <a:spcAft>
+                <a:spcPts val="400"/>
+              </a:spcAft>
+            </a:pPr>
+            <a:r>
+              <a:rPr sz="750" b="0">
+                <a:solidFill>
+                  <a:srgbClr val="1C261E"/>
+                </a:solidFill>
+                <a:latin typeface="Open Sans"/>
+              </a:rPr>
+              <a:t>29. STV News. (b. g.). Ziņu portāls. https://news.stv.tv/</a:t>
+            </a:r>
+          </a:p>
+          <a:p>
+            <a:pPr algn="l">
+              <a:lnSpc>
+                <a:spcPct val="100000"/>
+              </a:lnSpc>
+              <a:spcAft>
+                <a:spcPts val="400"/>
+              </a:spcAft>
+            </a:pPr>
+            <a:r>
+              <a:rPr sz="750" b="0">
+                <a:solidFill>
+                  <a:srgbClr val="1C261E"/>
+                </a:solidFill>
+                <a:latin typeface="Open Sans"/>
+              </a:rPr>
+              <a:t>30. Valsts vides dienests. (b. g.). Dienesta mājaslapa. https://www.vvd.gov.lv/</a:t>
+            </a:r>
+          </a:p>
+          <a:p>
+            <a:pPr algn="l">
+              <a:lnSpc>
+                <a:spcPct val="100000"/>
+              </a:lnSpc>
+              <a:spcAft>
+                <a:spcPts val="400"/>
+              </a:spcAft>
+            </a:pPr>
+            <a:r>
+              <a:rPr sz="750" b="0">
+                <a:solidFill>
+                  <a:srgbClr val="1C261E"/>
+                </a:solidFill>
+                <a:latin typeface="Open Sans"/>
+              </a:rPr>
+              <a:t>31. Wienerberger. (b. g.). Uzņēmuma mājaslapa. https://www.wienerberger.com/</a:t>
+            </a:r>
+          </a:p>
+          <a:p>
+            <a:pPr algn="l">
+              <a:lnSpc>
+                <a:spcPct val="100000"/>
+              </a:lnSpc>
+              <a:spcAft>
+                <a:spcPts val="400"/>
+              </a:spcAft>
+            </a:pPr>
+            <a:r>
+              <a:rPr sz="750" b="0">
+                <a:solidFill>
+                  <a:srgbClr val="1C261E"/>
+                </a:solidFill>
+                <a:latin typeface="Open Sans"/>
+              </a:rPr>
+              <a:t>32. Zero Waste Europe. (b. g.). Organizācijas mājaslapa. https://zerowasteeurope.eu/</a:t>
+            </a:r>
+          </a:p>
+          <a:p>
+            <a:pPr algn="l">
+              <a:lnSpc>
+                <a:spcPct val="100000"/>
+              </a:lnSpc>
+              <a:spcAft>
+                <a:spcPts val="400"/>
+              </a:spcAft>
+            </a:pPr>
+            <a:r>
+              <a:rPr sz="750" b="0">
+                <a:solidFill>
+                  <a:srgbClr val="1C261E"/>
+                </a:solidFill>
+                <a:latin typeface="Open Sans"/>
+              </a:rPr>
+              <a:t>33. ØRAS. (b. g.). Uzņēmuma mājaslapa. https://www.oras.no/</a:t>
+            </a:r>
+          </a:p>
+          <a:p>
+            <a:pPr algn="l">
+              <a:lnSpc>
+                <a:spcPct val="100000"/>
+              </a:lnSpc>
+              <a:spcAft>
+                <a:spcPts val="400"/>
+              </a:spcAft>
+            </a:pPr>
+            <a:r>
+              <a:rPr sz="750" b="0">
+                <a:solidFill>
+                  <a:srgbClr val="1C261E"/>
+                </a:solidFill>
+                <a:latin typeface="Open Sans"/>
+              </a:rPr>
+              <a:t>34. EkoBāze. (b. g.). Uzņēmuma mājaslapa. https://www.ekobaze.lv/</a:t>
+            </a:r>
+          </a:p>
+          <a:p>
+            <a:pPr algn="l">
+              <a:lnSpc>
+                <a:spcPct val="100000"/>
+              </a:lnSpc>
+              <a:spcAft>
+                <a:spcPts val="400"/>
+              </a:spcAft>
+            </a:pPr>
+            <a:r>
+              <a:rPr sz="750" b="0">
+                <a:solidFill>
+                  <a:srgbClr val="1C261E"/>
+                </a:solidFill>
+                <a:latin typeface="Open Sans"/>
+              </a:rPr>
+              <a:t>35. Latvijas Centrālā statistikas pārvalde. (b. g.). Oficiālā statistika: atkritumi. https://stat.gov.lv/</a:t>
+            </a:r>
+          </a:p>
+          <a:p>
+            <a:pPr algn="l">
+              <a:lnSpc>
+                <a:spcPct val="100000"/>
+              </a:lnSpc>
+              <a:spcAft>
+                <a:spcPts val="400"/>
+              </a:spcAft>
+            </a:pPr>
+            <a:r>
+              <a:rPr sz="750" b="0">
+                <a:solidFill>
+                  <a:srgbClr val="1C261E"/>
+                </a:solidFill>
+                <a:latin typeface="Open Sans"/>
+              </a:rPr>
+              <a:t>36. Latvijas Vides, ģeoloģijas un meteoroloģijas centrs. (b. g.). Vides dati un pārskati. https://videscentrs.lvgmc.lv/</a:t>
+            </a:r>
+          </a:p>
+          <a:p>
+            <a:pPr algn="l">
+              <a:lnSpc>
+                <a:spcPct val="100000"/>
+              </a:lnSpc>
+              <a:spcAft>
+                <a:spcPts val="400"/>
+              </a:spcAft>
+            </a:pPr>
+            <a:r>
+              <a:rPr sz="750" b="0">
+                <a:solidFill>
+                  <a:srgbClr val="1C261E"/>
+                </a:solidFill>
+                <a:latin typeface="Open Sans"/>
+              </a:rPr>
+              <a:t>37. iAuto.lv. (b. g.). Izgāž atkritumus mežā (foto 1. slaidā). https://iauto.lv/zinas/latvija/49412-izg-atkritumus-me-k-tdus-cilvkus-nosaukt-foto</a:t>
             </a:r>
           </a:p>
         </p:txBody>

</xml_diff>

<commit_message>
Hackathon: record app demo video from the prototype and embed it on slide 3
Co-Authored-By: Claude Opus 5.5 <noreply@anthropic.com>
Claude-Session: https://claude.ai/code/session_01C3KfjncommuX479wUy9vJ7
</commit_message>
<xml_diff>
--- a/hakatons/buvgruzu-birza.pptx
+++ b/hakatons/buvgruzu-birza.pptx
@@ -658,13 +658,13 @@
           <a:lstStyle/>
           <a:p>
             <a:r>
-              <a:t>0:15. Paskatīsimies ar lietotāja acīm. Tu nofotografē gružus un uzreiz redzi, cik saņemsi, vēl pirms reģistrācijas. Kartē redzi tikai tos punktus, kur braukt atmaksājas. Parādīšu.</a:t>
+              <a:t>0:15. Paskatīsimies ar lietotāja acīm. Izvēlies materiālu, ieraksti svaru un pilsētu, un uzreiz redzi, cik saņemsi un kur ir tuvākais punkts. Bez reģistrācijas. Parādīšu.</a:t>
             </a:r>
           </a:p>
           <a:p/>
           <a:p>
             <a:r>
-              <a:t>[VIDEO 1:00, Gustavs komentē]</a:t>
+              <a:t>[VIDEO ~43 s, Gustavs komentē: Izvēlos būvkoksni, 300 kilogrami, Jelgava. Uzreiz redzu: 4 eiro, tuvākais punkts Jelgavā. Kartē redzu, kur tas ir. Ja nevaru atvest pats, piesaku savākšanu: materiāls, daudzums, pilsēta, kontakts. Nosūtīts, un uzņēmums atbrauks pats.]</a:t>
             </a:r>
           </a:p>
         </p:txBody>
@@ -734,7 +734,7 @@
           <a:lstStyle/>
           <a:p>
             <a:r>
-              <a:t>0:35. Šodien cilvēkam ir četras iespējas. Sludinājums: lēti, bet gruži bieži nonāk mežā. Konteiners: legāli, bet dārgi. Šķirošanas laukums: jāved pašam, un nekas par to netiek. CleanR apmaiņas punkts Stopiņos jau pieņem tīrus būvgružus bez maksas un dod šķembas, bet tas ir viens punkts, un par to maz kurš zina. Būvgružu birža savieno šādus punktus vienā kartē. Un galvenais: lietotne uzreiz parāda, cik saņemsi un vai braukt atmaksājas.</a:t>
+              <a:t>0:35. Šodien cilvēkam ir četras iespējas. Sludinājums: lēti, bet gruži bieži nonāk mežā. Konteiners: legāli, bet dārgi. Šķirošanas laukums: jāved pašam, un nekas par to netiek. CleanR apmaiņas punkts Stopiņos jau pieņem tīrus būvgružus bez maksas un dod šķembas, bet tas ir viens punkts, un par to maz kurš zina. Būvgružu birža savieno šādus punktus vienā kartē. Un galvenais: lietotne uzreiz parāda, cik saņemsi un kur ir tuvākais punkts.</a:t>
             </a:r>
           </a:p>
         </p:txBody>
@@ -5227,7 +5227,7 @@
         <p:spPr>
           <a:xfrm>
             <a:off x="640080" y="914400"/>
-            <a:ext cx="6583680" cy="822960"/>
+            <a:ext cx="4754880" cy="822960"/>
           </a:xfrm>
           <a:prstGeom prst="rect">
             <a:avLst/>
@@ -5269,7 +5269,7 @@
         <p:spPr>
           <a:xfrm>
             <a:off x="640080" y="1600200"/>
-            <a:ext cx="6583680" cy="457200"/>
+            <a:ext cx="4754880" cy="457200"/>
           </a:xfrm>
           <a:prstGeom prst="rect">
             <a:avLst/>
@@ -5297,7 +5297,7 @@
                 </a:solidFill>
                 <a:latin typeface="Open Sans"/>
               </a:rPr>
-              <a:t>No gružu kaudzes līdz atlīdzībai četros soļos</a:t>
+              <a:t>Bez reģistrācijas, dažos klikšķos</a:t>
             </a:r>
           </a:p>
         </p:txBody>
@@ -5311,7 +5311,7 @@
         <p:spPr>
           <a:xfrm>
             <a:off x="457200" y="3191256"/>
-            <a:ext cx="6858000" cy="941832"/>
+            <a:ext cx="4800600" cy="941832"/>
           </a:xfrm>
           <a:prstGeom prst="roundRect">
             <a:avLst>
@@ -5356,8 +5356,8 @@
         </p:nvSpPr>
         <p:spPr>
           <a:xfrm>
-            <a:off x="5394960" y="3273552"/>
-            <a:ext cx="1783080" cy="274320"/>
+            <a:off x="3291840" y="3255264"/>
+            <a:ext cx="1874519" cy="274320"/>
           </a:xfrm>
           <a:prstGeom prst="rect">
             <a:avLst/>
@@ -5379,7 +5379,7 @@
               </a:spcAft>
             </a:pPr>
             <a:r>
-              <a:rPr sz="1000" b="1">
+              <a:rPr sz="900" b="1">
                 <a:solidFill>
                   <a:srgbClr val="244A30"/>
                 </a:solidFill>
@@ -5484,8 +5484,8 @@
         </p:nvSpPr>
         <p:spPr>
           <a:xfrm>
-            <a:off x="1554480" y="2313432"/>
-            <a:ext cx="5669280" cy="457200"/>
+            <a:off x="1554480" y="2350008"/>
+            <a:ext cx="3657600" cy="457200"/>
           </a:xfrm>
           <a:prstGeom prst="rect">
             <a:avLst/>
@@ -5507,13 +5507,13 @@
               </a:spcAft>
             </a:pPr>
             <a:r>
-              <a:rPr sz="2100" b="1">
+              <a:rPr sz="1900" b="1">
                 <a:solidFill>
                   <a:srgbClr val="1C261E"/>
                 </a:solidFill>
                 <a:latin typeface="Montserrat"/>
               </a:rPr>
-              <a:t>Nofotografē</a:t>
+              <a:t>Izvēlas materiālu</a:t>
             </a:r>
           </a:p>
         </p:txBody>
@@ -5527,7 +5527,7 @@
         <p:spPr>
           <a:xfrm>
             <a:off x="1554480" y="2715768"/>
-            <a:ext cx="5669280" cy="365760"/>
+            <a:ext cx="3657600" cy="365760"/>
           </a:xfrm>
           <a:prstGeom prst="rect">
             <a:avLst/>
@@ -5549,13 +5549,13 @@
               </a:spcAft>
             </a:pPr>
             <a:r>
-              <a:rPr sz="1400" b="0">
+              <a:rPr sz="1300" b="0">
                 <a:solidFill>
                   <a:srgbClr val="5B665D"/>
                 </a:solidFill>
                 <a:latin typeface="Open Sans"/>
               </a:rPr>
-              <a:t>Izvēlas veidu un daudzumu maisos</a:t>
+              <a:t>Koksne, betons, ķieģeļi, grants</a:t>
             </a:r>
           </a:p>
         </p:txBody>
@@ -5654,8 +5654,8 @@
         </p:nvSpPr>
         <p:spPr>
           <a:xfrm>
-            <a:off x="1554480" y="3300984"/>
-            <a:ext cx="5669280" cy="457200"/>
+            <a:off x="1554480" y="3337560"/>
+            <a:ext cx="3657600" cy="457200"/>
           </a:xfrm>
           <a:prstGeom prst="rect">
             <a:avLst/>
@@ -5677,7 +5677,7 @@
               </a:spcAft>
             </a:pPr>
             <a:r>
-              <a:rPr sz="2100" b="1">
+              <a:rPr sz="1900" b="1">
                 <a:solidFill>
                   <a:srgbClr val="1C261E"/>
                 </a:solidFill>
@@ -5697,7 +5697,7 @@
         <p:spPr>
           <a:xfrm>
             <a:off x="1554480" y="3703320"/>
-            <a:ext cx="5669280" cy="365760"/>
+            <a:ext cx="3657600" cy="365760"/>
           </a:xfrm>
           <a:prstGeom prst="rect">
             <a:avLst/>
@@ -5719,13 +5719,13 @@
               </a:spcAft>
             </a:pPr>
             <a:r>
-              <a:rPr sz="1400" b="0">
+              <a:rPr sz="1300" b="0">
                 <a:solidFill>
                   <a:srgbClr val="5B665D"/>
                 </a:solidFill>
                 <a:latin typeface="Open Sans"/>
               </a:rPr>
-              <a:t>Cik saņems un vai braukt atmaksājas</a:t>
+              <a:t>Pēc svara, kvalitātes un pilsētas</a:t>
             </a:r>
           </a:p>
         </p:txBody>
@@ -5824,8 +5824,8 @@
         </p:nvSpPr>
         <p:spPr>
           <a:xfrm>
-            <a:off x="1554480" y="4288536"/>
-            <a:ext cx="5669280" cy="457200"/>
+            <a:off x="1554480" y="4325112"/>
+            <a:ext cx="3657600" cy="457200"/>
           </a:xfrm>
           <a:prstGeom prst="rect">
             <a:avLst/>
@@ -5847,7 +5847,7 @@
               </a:spcAft>
             </a:pPr>
             <a:r>
-              <a:rPr sz="2100" b="1">
+              <a:rPr sz="1900" b="1">
                 <a:solidFill>
                   <a:srgbClr val="1C261E"/>
                 </a:solidFill>
@@ -5867,7 +5867,7 @@
         <p:spPr>
           <a:xfrm>
             <a:off x="1554480" y="4690872"/>
-            <a:ext cx="5669280" cy="365760"/>
+            <a:ext cx="3657600" cy="365760"/>
           </a:xfrm>
           <a:prstGeom prst="rect">
             <a:avLst/>
@@ -5889,13 +5889,13 @@
               </a:spcAft>
             </a:pPr>
             <a:r>
-              <a:rPr sz="1400" b="0">
+              <a:rPr sz="1300" b="0">
                 <a:solidFill>
                   <a:srgbClr val="5B665D"/>
                 </a:solidFill>
                 <a:latin typeface="Open Sans"/>
               </a:rPr>
-              <a:t>Tikai tur, kur atlīdzība &gt; degvielas izmaksas</a:t>
+              <a:t>Tuvākie punkti ar attālumu un cenu</a:t>
             </a:r>
           </a:p>
         </p:txBody>
@@ -5994,8 +5994,8 @@
         </p:nvSpPr>
         <p:spPr>
           <a:xfrm>
-            <a:off x="1554480" y="5276088"/>
-            <a:ext cx="5669280" cy="457200"/>
+            <a:off x="1554480" y="5312664"/>
+            <a:ext cx="3657600" cy="457200"/>
           </a:xfrm>
           <a:prstGeom prst="rect">
             <a:avLst/>
@@ -6017,13 +6017,13 @@
               </a:spcAft>
             </a:pPr>
             <a:r>
-              <a:rPr sz="2100" b="1">
+              <a:rPr sz="1900" b="1">
                 <a:solidFill>
                   <a:srgbClr val="1C261E"/>
                 </a:solidFill>
                 <a:latin typeface="Montserrat"/>
               </a:rPr>
-              <a:t>Nodod un saņem</a:t>
+              <a:t>Atved vai piesaka savākšanu</a:t>
             </a:r>
           </a:p>
         </p:txBody>
@@ -6037,7 +6037,7 @@
         <p:spPr>
           <a:xfrm>
             <a:off x="1554480" y="5678424"/>
-            <a:ext cx="5669280" cy="365760"/>
+            <a:ext cx="3657600" cy="365760"/>
           </a:xfrm>
           <a:prstGeom prst="rect">
             <a:avLst/>
@@ -6059,13 +6059,13 @@
               </a:spcAft>
             </a:pPr>
             <a:r>
-              <a:rPr sz="1400" b="0">
+              <a:rPr sz="1300" b="0">
                 <a:solidFill>
                   <a:srgbClr val="5B665D"/>
                 </a:solidFill>
                 <a:latin typeface="Open Sans"/>
               </a:rPr>
-              <a:t>Nosver, pārbauda, atlīdzība kontā</a:t>
+              <a:t>Uzņēmums atbrauc pats</a:t>
             </a:r>
           </a:p>
         </p:txBody>
@@ -6078,8 +6078,8 @@
         </p:nvSpPr>
         <p:spPr>
           <a:xfrm>
-            <a:off x="7589520" y="548640"/>
-            <a:ext cx="3291840" cy="5760720"/>
+            <a:off x="5532120" y="1417320"/>
+            <a:ext cx="6309360" cy="4114800"/>
           </a:xfrm>
           <a:prstGeom prst="roundRect">
             <a:avLst>
@@ -6116,52 +6116,39 @@
           </a:p>
         </p:txBody>
       </p:sp>
-      <p:sp>
-        <p:nvSpPr>
-          <p:cNvPr id="24" name="Rounded Rectangle 23"/>
-          <p:cNvSpPr/>
-          <p:nvPr/>
-        </p:nvSpPr>
-        <p:spPr>
-          <a:xfrm>
-            <a:off x="7726679" y="685800"/>
-            <a:ext cx="3017520" cy="5486400"/>
-          </a:xfrm>
-          <a:prstGeom prst="roundRect">
-            <a:avLst>
-              <a:gd name="adj" fmla="val 8000"/>
-            </a:avLst>
-          </a:prstGeom>
-          <a:solidFill>
-            <a:srgbClr val="CFE0C8"/>
-          </a:solidFill>
-          <a:ln>
-            <a:noFill/>
-          </a:ln>
-          <a:effectLst/>
-        </p:spPr>
-        <p:style>
-          <a:lnRef idx="1">
-            <a:schemeClr val="accent1"/>
-          </a:lnRef>
-          <a:fillRef idx="3">
-            <a:schemeClr val="accent1"/>
-          </a:fillRef>
-          <a:effectRef idx="2">
-            <a:schemeClr val="accent1"/>
-          </a:effectRef>
-          <a:fontRef idx="minor">
-            <a:schemeClr val="lt1"/>
-          </a:fontRef>
-        </p:style>
-        <p:txBody>
-          <a:bodyPr rtlCol="0" anchor="ctr"/>
-          <a:lstStyle/>
-          <a:p>
-            <a:pPr algn="ctr"/>
-          </a:p>
-        </p:txBody>
-      </p:sp>
+      <p:pic>
+        <p:nvPicPr>
+          <p:cNvPr id="24" name="demo-video.mp4">
+            <a:hlinkClick r:id="" action="ppaction://media"/>
+          </p:cNvPr>
+          <p:cNvPicPr>
+            <a:picLocks noChangeAspect="1"/>
+          </p:cNvPicPr>
+          <p:nvPr>
+            <a:videoFile r:link="rId3"/>
+            <p:extLst>
+              <p:ext uri="{DAA4B4D4-6D71-4841-9C94-3DE7FCFB9230}">
+                <p14:media xmlns:p14="http://schemas.microsoft.com/office/powerpoint/2010/main" r:embed="rId2"/>
+              </p:ext>
+            </p:extLst>
+          </p:nvPr>
+        </p:nvPicPr>
+        <p:blipFill>
+          <a:blip r:embed="rId4"/>
+          <a:stretch>
+            <a:fillRect/>
+          </a:stretch>
+        </p:blipFill>
+        <p:spPr>
+          <a:xfrm>
+            <a:off x="5669280" y="1554480"/>
+            <a:ext cx="6035040" cy="3771900"/>
+          </a:xfrm>
+          <a:prstGeom prst="rect">
+            <a:avLst/>
+          </a:prstGeom>
+        </p:spPr>
+      </p:pic>
       <p:sp>
         <p:nvSpPr>
           <p:cNvPr id="25" name="TextBox 24"/>
@@ -6170,8 +6157,8 @@
         </p:nvSpPr>
         <p:spPr>
           <a:xfrm>
-            <a:off x="7726679" y="685800"/>
-            <a:ext cx="3017520" cy="5486400"/>
+            <a:off x="5532120" y="5623560"/>
+            <a:ext cx="6309360" cy="274320"/>
           </a:xfrm>
           <a:prstGeom prst="rect">
             <a:avLst/>
@@ -6179,12 +6166,12 @@
           <a:noFill/>
         </p:spPr>
         <p:txBody>
-          <a:bodyPr wrap="square" anchor="ctr" lIns="0" rIns="0" tIns="0" bIns="0">
+          <a:bodyPr wrap="square" anchor="t" lIns="0" rIns="0" tIns="0" bIns="0">
             <a:spAutoFit/>
           </a:bodyPr>
           <a:lstStyle/>
           <a:p>
-            <a:pPr algn="ctr">
+            <a:pPr algn="r">
               <a:lnSpc>
                 <a:spcPct val="110000"/>
               </a:lnSpc>
@@ -6193,51 +6180,13 @@
               </a:spcAft>
             </a:pPr>
             <a:r>
-              <a:rPr sz="1600" b="0">
-                <a:solidFill>
-                  <a:srgbClr val="244A30"/>
+              <a:rPr sz="1000" b="0">
+                <a:solidFill>
+                  <a:srgbClr val="5B665D"/>
                 </a:solidFill>
                 <a:latin typeface="Open Sans"/>
               </a:rPr>
-              <a:t>VIDEO</a:t>
-            </a:r>
-          </a:p>
-          <a:p>
-            <a:pPr algn="ctr">
-              <a:lnSpc>
-                <a:spcPct val="110000"/>
-              </a:lnSpc>
-              <a:spcAft>
-                <a:spcPts val="600"/>
-              </a:spcAft>
-            </a:pPr>
-            <a:r>
-              <a:rPr sz="1600" b="0">
-                <a:solidFill>
-                  <a:srgbClr val="244A30"/>
-                </a:solidFill>
-                <a:latin typeface="Open Sans"/>
-              </a:rPr>
-              <a:t>no lietotnes</a:t>
-            </a:r>
-          </a:p>
-          <a:p>
-            <a:pPr algn="ctr">
-              <a:lnSpc>
-                <a:spcPct val="110000"/>
-              </a:lnSpc>
-              <a:spcAft>
-                <a:spcPts val="600"/>
-              </a:spcAft>
-            </a:pPr>
-            <a:r>
-              <a:rPr sz="1600" b="0">
-                <a:solidFill>
-                  <a:srgbClr val="244A30"/>
-                </a:solidFill>
-                <a:latin typeface="Open Sans"/>
-              </a:rPr>
-              <a:t>(ievelc Canva)</a:t>
+              <a:t>Prototips · demo dati</a:t>
             </a:r>
           </a:p>
         </p:txBody>
@@ -6247,6 +6196,28 @@
   <p:clrMapOvr>
     <a:masterClrMapping/>
   </p:clrMapOvr>
+  <p:timing>
+    <p:tnLst>
+      <p:par>
+        <p:cTn id="1" dur="indefinite" restart="never" nodeType="tmRoot">
+          <p:childTnLst>
+            <p:video>
+              <p:cMediaNode vol="80000">
+                <p:cTn id="2" fill="hold" display="0">
+                  <p:stCondLst>
+                    <p:cond delay="indefinite"/>
+                  </p:stCondLst>
+                </p:cTn>
+                <p:tgtEl>
+                  <p:spTgt spid="24"/>
+                </p:tgtEl>
+              </p:cMediaNode>
+            </p:video>
+          </p:childTnLst>
+        </p:cTn>
+      </p:par>
+    </p:tnLst>
+  </p:timing>
 </p:sld>
 </file>
 

</xml_diff>